<commit_message>
deck_zwfs: sweep verdict replaces the sampling-starved caveat + 1 pm target
The 'Measuring the DM' slide now carries the round-12 sweep finding
(poke gain flat in sampling; the spot is a band-select lever; the
transfer calibrates -- the road to the 1 pm ultimate target), and the
comparison-table poke row is corrected to match.

Co-Authored-By: Claude Fable 5 <noreply@anthropic.com>
</commit_message>
<xml_diff>
--- a/demo_session/deck_zwfs.pptx
+++ b/demo_session/deck_zwfs.pptx
@@ -4933,7 +4933,7 @@
                 </a:solidFill>
                 <a:latin typeface="Arial"/>
               </a:rPr>
-              <a:t>One actuator pushed 20 nm reads at gain 0.45 through one frame at this camera; an 8 nm defocus reads at 0.99 — applied, sensed, and the estimate error, side by side</a:t>
+              <a:t>One actuator pushed 20 nm reads at gain 0.45 through one frame; an 8 nm defocus at 0.99 — and a sampling sweep shows the spot size, not the camera, sets the trade</a:t>
             </a:r>
           </a:p>
         </p:txBody>
@@ -5142,7 +5142,23 @@
                 </a:solidFill>
                 <a:latin typeface="Arial"/>
               </a:rPr>
-              <a:t>•  The honest caveat on the poke number: the beam fills 74% of the aperture, so this camera resolves only 143 pixels across the lit pupil — 1.5× the actuator scale, under the 2× design rule the raw grid count appeared to satisfy.  The compliant configuration (385-pixel grid, 3.0 λF/D spot) is the battery's; and the actuator-model fit — the agreed score — recovers resolution the raw map lacks.</a:t>
+              <a:t>•  Swept, and it is not the camera: poke gain does not move from 1.7× to 5× detector margin over the actuator scale, nor from 1.3 to 3.7 rays per actuator on the DM side.  The lever is the spot: 3.0 λF/D reads the poke at 0.59 but defocus falls to 0.78; 2.0 gives 0.45 and 0.99; the 1.06 hardware spot inverts the poke's sign.  The dimple diameter selects a band — no single spot serves both.</a:t>
+            </a:r>
+          </a:p>
+          <a:p>
+            <a:pPr>
+              <a:spcAft>
+                <a:spcPts val="600"/>
+              </a:spcAft>
+            </a:pPr>
+            <a:r>
+              <a:rPr sz="1500" b="0">
+                <a:solidFill>
+                  <a:srgbClr val="282828"/>
+                </a:solidFill>
+                <a:latin typeface="Arial"/>
+              </a:rPr>
+              <a:t>•  Why that is workable: the transfer is flat in sampling and set by a known dimple — stable and calibratable.  The actuator-model fit (the agreed score) with a measured response absorbs it; that is the battery's reconstructor path toward the 1 pm ultimate target.</a:t>
             </a:r>
           </a:p>
         </p:txBody>
@@ -5155,7 +5171,7 @@
         </p:nvSpPr>
         <p:spPr>
           <a:xfrm>
-            <a:off x="411480" y="5958839"/>
+            <a:off x="411480" y="6841997"/>
             <a:ext cx="11368735" cy="274320"/>
           </a:xfrm>
           <a:prstGeom prst="rect">
@@ -5181,7 +5197,7 @@
                 </a:solidFill>
                 <a:latin typeface="Arial"/>
               </a:rPr>
-              <a:t>Linear reconstructor throughout; alternatives are a scheduled study.  Identical cases measured on the interferometer: poke gain 0.984 / 0.049 nm, defocus 1.024 / 0.086 nm (the Fang deck carries them).</a:t>
+              <a:t>Linear reconstructor throughout; alternatives are a scheduled study.  Sweep record: zwfs_sweep.m (8 configs, 1.2 min).  Identical cases on the interferometer: poke gain 0.984 / 0.049 nm, defocus 1.024 / 0.086 nm (the Fang deck carries them).</a:t>
             </a:r>
           </a:p>
         </p:txBody>
@@ -5917,7 +5933,7 @@
                           </a:solidFill>
                           <a:latin typeface="Arial"/>
                         </a:rPr>
-                        <a:t>gain 0.45 at a sampling-starved camera (next slide)</a:t>
+                        <a:t>gain 0.45–0.59, set by spot size, flat in sampling (next slide)</a:t>
                       </a:r>
                     </a:p>
                   </a:txBody>

</xml_diff>

<commit_message>
deck_zwfs: the literature scan folded (15 slides) -- twelve papers in priority order with synopses and references, the first-task spec (iterated reference wave), the follow-on imports, and the PZT verdict for the interferometer
Co-Authored-By: Claude Fable 5.1 <noreply@anthropic.com>
</commit_message>
<xml_diff>
--- a/demo_session/deck_zwfs.pptx
+++ b/demo_session/deck_zwfs.pptx
@@ -16,6 +16,10 @@
     <p:sldId id="264" r:id="rId15"/>
     <p:sldId id="265" r:id="rId16"/>
     <p:sldId id="266" r:id="rId17"/>
+    <p:sldId id="267" r:id="rId18"/>
+    <p:sldId id="268" r:id="rId19"/>
+    <p:sldId id="269" r:id="rId20"/>
+    <p:sldId id="270" r:id="rId21"/>
   </p:sldIdLst>
   <p:sldSz cx="12191695" cy="6858000" type="screen4x3"/>
   <p:notesSz cx="6858000" cy="9144000"/>
@@ -3196,7 +3200,7 @@
                 </a:solidFill>
                 <a:latin typeface="Arial"/>
               </a:rPr>
-              <a:t>DRAFT — pending review.  Campaign status: sensor model verified; battery, head-to-head and photon pricing measured (reported in the interferometer deck); multi-color excursion folded here; vector step pending.</a:t>
+              <a:t>DRAFT — pending review.  Campaign status: sensor model verified; battery, head-to-head and photon pricing measured (reported in the interferometer deck); multi-color excursion and the literature scan folded here; vector step pending.</a:t>
             </a:r>
           </a:p>
         </p:txBody>
@@ -3251,63 +3255,6 @@
         </p:nvSpPr>
         <p:spPr>
           <a:xfrm>
-            <a:off x="822960" y="2743200"/>
-            <a:ext cx="10545775" cy="1280160"/>
-          </a:xfrm>
-          <a:prstGeom prst="rect">
-            <a:avLst/>
-          </a:prstGeom>
-          <a:noFill/>
-        </p:spPr>
-        <p:txBody>
-          <a:bodyPr wrap="square">
-            <a:spAutoFit/>
-          </a:bodyPr>
-          <a:lstStyle/>
-          <a:p>
-            <a:pPr algn="ctr">
-              <a:spcAft>
-                <a:spcPts val="400"/>
-              </a:spcAft>
-            </a:pPr>
-            <a:r>
-              <a:rPr sz="4000" b="1">
-                <a:solidFill>
-                  <a:srgbClr val="1F4E79"/>
-                </a:solidFill>
-                <a:latin typeface="Arial"/>
-              </a:rPr>
-              <a:t>Backup</a:t>
-            </a:r>
-          </a:p>
-        </p:txBody>
-      </p:sp>
-    </p:spTree>
-  </p:cSld>
-  <p:clrMapOvr>
-    <a:masterClrMapping/>
-  </p:clrMapOvr>
-</p:sld>
-</file>
-
-<file path=ppt/slides/slide11.xml><?xml version="1.0" encoding="utf-8"?>
-<p:sld xmlns:a="http://schemas.openxmlformats.org/drawingml/2006/main" xmlns:p="http://schemas.openxmlformats.org/presentationml/2006/main" xmlns:r="http://schemas.openxmlformats.org/officeDocument/2006/relationships">
-  <p:cSld>
-    <p:spTree>
-      <p:nvGrpSpPr>
-        <p:cNvPr id="1" name=""/>
-        <p:cNvGrpSpPr/>
-        <p:nvPr/>
-      </p:nvGrpSpPr>
-      <p:grpSpPr/>
-      <p:sp>
-        <p:nvSpPr>
-          <p:cNvPr id="2" name="TextBox 1"/>
-          <p:cNvSpPr txBox="1"/>
-          <p:nvPr/>
-        </p:nvSpPr>
-        <p:spPr>
-          <a:xfrm>
             <a:off x="411480" y="201168"/>
             <a:ext cx="11368735" cy="914400"/>
           </a:xfrm>
@@ -3334,7 +3281,7 @@
                 </a:solidFill>
                 <a:latin typeface="Arial"/>
               </a:rPr>
-              <a:t>Provenance and records</a:t>
+              <a:t>What the Zernike-sensor literature offers, in priority order</a:t>
             </a:r>
           </a:p>
           <a:p>
@@ -3350,7 +3297,7 @@
                 </a:solidFill>
                 <a:latin typeface="Arial"/>
               </a:rPr>
-              <a:t>Every number re-derives from a committed script</a:t>
+              <a:t>Twelve papers read; one import addresses this campaign's weak results directly: reconstruct with an iterated reference wave</a:t>
             </a:r>
           </a:p>
         </p:txBody>
@@ -3399,6 +3346,1324 @@
           </a:p>
         </p:txBody>
       </p:sp>
+      <p:graphicFrame>
+        <p:nvGraphicFramePr>
+          <p:cNvPr id="4" name="Table 3"/>
+          <p:cNvGraphicFramePr>
+            <a:graphicFrameLocks noGrp="1"/>
+          </p:cNvGraphicFramePr>
+          <p:nvPr/>
+        </p:nvGraphicFramePr>
+        <p:xfrm>
+          <a:off x="411480" y="1298448"/>
+          <a:ext cx="11368734" cy="3091815"/>
+        </p:xfrm>
+        <a:graphic>
+          <a:graphicData uri="http://schemas.openxmlformats.org/drawingml/2006/table">
+            <a:tbl>
+              <a:tblPr firstRow="1" bandRow="1">
+                <a:tableStyleId>{5C22544A-7EE6-4342-B048-85BDC9FD1C3A}</a:tableStyleId>
+              </a:tblPr>
+              <a:tblGrid>
+                <a:gridCol w="218948"/>
+                <a:gridCol w="2691327"/>
+                <a:gridCol w="8458459"/>
+              </a:tblGrid>
+              <a:tr h="280035">
+                <a:tc>
+                  <a:txBody>
+                    <a:bodyPr wrap="square"/>
+                    <a:lstStyle/>
+                    <a:p>
+                      <a:r>
+                        <a:rPr sz="1100" b="1">
+                          <a:solidFill>
+                            <a:srgbClr val="FFFFFF"/>
+                          </a:solidFill>
+                          <a:latin typeface="Arial"/>
+                        </a:rPr>
+                        <a:t>#</a:t>
+                      </a:r>
+                    </a:p>
+                  </a:txBody>
+                  <a:tcPr marL="54864" marR="54864" marT="18288" marB="18288">
+                    <a:solidFill>
+                      <a:srgbClr val="1F4E79"/>
+                    </a:solidFill>
+                  </a:tcPr>
+                </a:tc>
+                <a:tc>
+                  <a:txBody>
+                    <a:bodyPr wrap="square"/>
+                    <a:lstStyle/>
+                    <a:p>
+                      <a:r>
+                        <a:rPr sz="1100" b="1">
+                          <a:solidFill>
+                            <a:srgbClr val="FFFFFF"/>
+                          </a:solidFill>
+                          <a:latin typeface="Arial"/>
+                        </a:rPr>
+                        <a:t>paper</a:t>
+                      </a:r>
+                    </a:p>
+                  </a:txBody>
+                  <a:tcPr marL="54864" marR="54864" marT="18288" marB="18288">
+                    <a:solidFill>
+                      <a:srgbClr val="1F4E79"/>
+                    </a:solidFill>
+                  </a:tcPr>
+                </a:tc>
+                <a:tc>
+                  <a:txBody>
+                    <a:bodyPr wrap="square"/>
+                    <a:lstStyle/>
+                    <a:p>
+                      <a:r>
+                        <a:rPr sz="1100" b="1">
+                          <a:solidFill>
+                            <a:srgbClr val="FFFFFF"/>
+                          </a:solidFill>
+                          <a:latin typeface="Arial"/>
+                        </a:rPr>
+                        <a:t>what it gives this model</a:t>
+                      </a:r>
+                    </a:p>
+                  </a:txBody>
+                  <a:tcPr marL="54864" marR="54864" marT="18288" marB="18288">
+                    <a:solidFill>
+                      <a:srgbClr val="1F4E79"/>
+                    </a:solidFill>
+                  </a:tcPr>
+                </a:tc>
+              </a:tr>
+              <a:tr h="468630">
+                <a:tc>
+                  <a:txBody>
+                    <a:bodyPr wrap="square"/>
+                    <a:lstStyle/>
+                    <a:p>
+                      <a:r>
+                        <a:rPr sz="1100" b="0">
+                          <a:solidFill>
+                            <a:srgbClr val="282828"/>
+                          </a:solidFill>
+                          <a:latin typeface="Arial"/>
+                        </a:rPr>
+                        <a:t>1</a:t>
+                      </a:r>
+                    </a:p>
+                  </a:txBody>
+                  <a:tcPr marL="54864" marR="54864" marT="18288" marB="18288">
+                    <a:solidFill>
+                      <a:srgbClr val="FFFFFF"/>
+                    </a:solidFill>
+                  </a:tcPr>
+                </a:tc>
+                <a:tc>
+                  <a:txBody>
+                    <a:bodyPr wrap="square"/>
+                    <a:lstStyle/>
+                    <a:p>
+                      <a:r>
+                        <a:rPr sz="1100" b="0">
+                          <a:solidFill>
+                            <a:srgbClr val="282828"/>
+                          </a:solidFill>
+                          <a:latin typeface="Arial"/>
+                        </a:rPr>
+                        <a:t>Ruane, Wallace, Steeves et al. 2020, JATIS 6, 045005</a:t>
+                      </a:r>
+                    </a:p>
+                  </a:txBody>
+                  <a:tcPr marL="54864" marR="54864" marT="18288" marB="18288">
+                    <a:solidFill>
+                      <a:srgbClr val="FFFFFF"/>
+                    </a:solidFill>
+                  </a:tcPr>
+                </a:tc>
+                <a:tc>
+                  <a:txBody>
+                    <a:bodyPr wrap="square"/>
+                    <a:lstStyle/>
+                    <a:p>
+                      <a:r>
+                        <a:rPr sz="1100" b="0">
+                          <a:solidFill>
+                            <a:srgbClr val="282828"/>
+                          </a:solidFill>
+                          <a:latin typeface="Arial"/>
+                        </a:rPr>
+                        <a:t>Exact per-pixel reconstruction from the pupil amplitude, the reference wave b and the masked image; a sensitivity factor per pixel; a four-term systematic budget; 1 pm reached at 4.4×10⁵ frames; no loss to 25 % bandwidth</a:t>
+                      </a:r>
+                    </a:p>
+                  </a:txBody>
+                  <a:tcPr marL="54864" marR="54864" marT="18288" marB="18288">
+                    <a:solidFill>
+                      <a:srgbClr val="FFFFFF"/>
+                    </a:solidFill>
+                  </a:tcPr>
+                </a:tc>
+              </a:tr>
+              <a:tr h="468630">
+                <a:tc>
+                  <a:txBody>
+                    <a:bodyPr wrap="square"/>
+                    <a:lstStyle/>
+                    <a:p>
+                      <a:r>
+                        <a:rPr sz="1100" b="0">
+                          <a:solidFill>
+                            <a:srgbClr val="282828"/>
+                          </a:solidFill>
+                          <a:latin typeface="Arial"/>
+                        </a:rPr>
+                        <a:t>2</a:t>
+                      </a:r>
+                    </a:p>
+                  </a:txBody>
+                  <a:tcPr marL="54864" marR="54864" marT="18288" marB="18288">
+                    <a:solidFill>
+                      <a:srgbClr val="ECF1F6"/>
+                    </a:solidFill>
+                  </a:tcPr>
+                </a:tc>
+                <a:tc>
+                  <a:txBody>
+                    <a:bodyPr wrap="square"/>
+                    <a:lstStyle/>
+                    <a:p>
+                      <a:r>
+                        <a:rPr sz="1100" b="0">
+                          <a:solidFill>
+                            <a:srgbClr val="282828"/>
+                          </a:solidFill>
+                          <a:latin typeface="Arial"/>
+                        </a:rPr>
+                        <a:t>Doelman, Fagginger Auer, Escuti, Snik 2019, Opt. Lett. 44, 17</a:t>
+                      </a:r>
+                    </a:p>
+                  </a:txBody>
+                  <a:tcPr marL="54864" marR="54864" marT="18288" marB="18288">
+                    <a:solidFill>
+                      <a:srgbClr val="ECF1F6"/>
+                    </a:solidFill>
+                  </a:tcPr>
+                </a:tc>
+                <a:tc>
+                  <a:txBody>
+                    <a:bodyPr wrap="square"/>
+                    <a:lstStyle/>
+                    <a:p>
+                      <a:r>
+                        <a:rPr sz="1100" b="0">
+                          <a:solidFill>
+                            <a:srgbClr val="282828"/>
+                          </a:solidFill>
+                          <a:latin typeface="Arial"/>
+                        </a:rPr>
+                        <a:t>Vector Zernike: ±π/2 on opposite circular polarizations gives two pupil images, an exact phase-and-amplitude solution, an iterated b, achromatic to 100 % bandwidth; the leakage terms are written down</a:t>
+                      </a:r>
+                    </a:p>
+                  </a:txBody>
+                  <a:tcPr marL="54864" marR="54864" marT="18288" marB="18288">
+                    <a:solidFill>
+                      <a:srgbClr val="ECF1F6"/>
+                    </a:solidFill>
+                  </a:tcPr>
+                </a:tc>
+              </a:tr>
+              <a:tr h="468630">
+                <a:tc>
+                  <a:txBody>
+                    <a:bodyPr wrap="square"/>
+                    <a:lstStyle/>
+                    <a:p>
+                      <a:r>
+                        <a:rPr sz="1100" b="0">
+                          <a:solidFill>
+                            <a:srgbClr val="282828"/>
+                          </a:solidFill>
+                          <a:latin typeface="Arial"/>
+                        </a:rPr>
+                        <a:t>3</a:t>
+                      </a:r>
+                    </a:p>
+                  </a:txBody>
+                  <a:tcPr marL="54864" marR="54864" marT="18288" marB="18288">
+                    <a:solidFill>
+                      <a:srgbClr val="FFFFFF"/>
+                    </a:solidFill>
+                  </a:tcPr>
+                </a:tc>
+                <a:tc>
+                  <a:txBody>
+                    <a:bodyPr wrap="square"/>
+                    <a:lstStyle/>
+                    <a:p>
+                      <a:r>
+                        <a:rPr sz="1100" b="0">
+                          <a:solidFill>
+                            <a:srgbClr val="282828"/>
+                          </a:solidFill>
+                          <a:latin typeface="Arial"/>
+                        </a:rPr>
+                        <a:t>N'Diaye, Vigan, Dohlen et al. 2016, A&amp;A 592, A79 (ZELDA II)</a:t>
+                      </a:r>
+                    </a:p>
+                  </a:txBody>
+                  <a:tcPr marL="54864" marR="54864" marT="18288" marB="18288">
+                    <a:solidFill>
+                      <a:srgbClr val="FFFFFF"/>
+                    </a:solidFill>
+                  </a:tcPr>
+                </a:tc>
+                <a:tc>
+                  <a:txBody>
+                    <a:bodyPr wrap="square"/>
+                    <a:lstStyle/>
+                    <a:p>
+                      <a:r>
+                        <a:rPr sz="1100" b="0">
+                          <a:solidFill>
+                            <a:srgbClr val="282828"/>
+                          </a:solidFill>
+                          <a:latin typeface="Arial"/>
+                        </a:rPr>
+                        <a:t>Second-order reconstruction with b from the mask model; 1.06 λ/D at π/2; range −0.14 to +0.36 λ; the sensitivity factor drifts 10 % day to day on SPHERE</a:t>
+                      </a:r>
+                    </a:p>
+                  </a:txBody>
+                  <a:tcPr marL="54864" marR="54864" marT="18288" marB="18288">
+                    <a:solidFill>
+                      <a:srgbClr val="FFFFFF"/>
+                    </a:solidFill>
+                  </a:tcPr>
+                </a:tc>
+              </a:tr>
+              <a:tr h="468630">
+                <a:tc>
+                  <a:txBody>
+                    <a:bodyPr wrap="square"/>
+                    <a:lstStyle/>
+                    <a:p>
+                      <a:r>
+                        <a:rPr sz="1100" b="0">
+                          <a:solidFill>
+                            <a:srgbClr val="282828"/>
+                          </a:solidFill>
+                          <a:latin typeface="Arial"/>
+                        </a:rPr>
+                        <a:t>4</a:t>
+                      </a:r>
+                    </a:p>
+                  </a:txBody>
+                  <a:tcPr marL="54864" marR="54864" marT="18288" marB="18288">
+                    <a:solidFill>
+                      <a:srgbClr val="ECF1F6"/>
+                    </a:solidFill>
+                  </a:tcPr>
+                </a:tc>
+                <a:tc>
+                  <a:txBody>
+                    <a:bodyPr wrap="square"/>
+                    <a:lstStyle/>
+                    <a:p>
+                      <a:r>
+                        <a:rPr sz="1100" b="0">
+                          <a:solidFill>
+                            <a:srgbClr val="282828"/>
+                          </a:solidFill>
+                          <a:latin typeface="Arial"/>
+                        </a:rPr>
+                        <a:t>Chambouleyron, Cissé, Salama, Haffert, Wallace et al. 2024, SPIE 13097</a:t>
+                      </a:r>
+                    </a:p>
+                  </a:txBody>
+                  <a:tcPr marL="54864" marR="54864" marT="18288" marB="18288">
+                    <a:solidFill>
+                      <a:srgbClr val="ECF1F6"/>
+                    </a:solidFill>
+                  </a:tcPr>
+                </a:tc>
+                <a:tc>
+                  <a:txBody>
+                    <a:bodyPr wrap="square"/>
+                    <a:lstStyle/>
+                    <a:p>
+                      <a:r>
+                        <a:rPr sz="1100" b="0">
+                          <a:solidFill>
+                            <a:srgbClr val="282828"/>
+                          </a:solidFill>
+                          <a:latin typeface="Arial"/>
+                        </a:rPr>
+                        <a:t>A phase-shifted pair (±π/2) yields cos φ and sin φ; iterative reconstructors reach about 1 rad rms; the bench limits were polarization crosstalk and defocus between the two pupils</a:t>
+                      </a:r>
+                    </a:p>
+                  </a:txBody>
+                  <a:tcPr marL="54864" marR="54864" marT="18288" marB="18288">
+                    <a:solidFill>
+                      <a:srgbClr val="ECF1F6"/>
+                    </a:solidFill>
+                  </a:tcPr>
+                </a:tc>
+              </a:tr>
+              <a:tr h="468630">
+                <a:tc>
+                  <a:txBody>
+                    <a:bodyPr wrap="square"/>
+                    <a:lstStyle/>
+                    <a:p>
+                      <a:r>
+                        <a:rPr sz="1100" b="0">
+                          <a:solidFill>
+                            <a:srgbClr val="282828"/>
+                          </a:solidFill>
+                          <a:latin typeface="Arial"/>
+                        </a:rPr>
+                        <a:t>5</a:t>
+                      </a:r>
+                    </a:p>
+                  </a:txBody>
+                  <a:tcPr marL="54864" marR="54864" marT="18288" marB="18288">
+                    <a:solidFill>
+                      <a:srgbClr val="FFFFFF"/>
+                    </a:solidFill>
+                  </a:tcPr>
+                </a:tc>
+                <a:tc>
+                  <a:txBody>
+                    <a:bodyPr wrap="square"/>
+                    <a:lstStyle/>
+                    <a:p>
+                      <a:r>
+                        <a:rPr sz="1100" b="0">
+                          <a:solidFill>
+                            <a:srgbClr val="282828"/>
+                          </a:solidFill>
+                          <a:latin typeface="Arial"/>
+                        </a:rPr>
+                        <a:t>Haffert 2024, A&amp;A 683, A113</a:t>
+                      </a:r>
+                    </a:p>
+                  </a:txBody>
+                  <a:tcPr marL="54864" marR="54864" marT="18288" marB="18288">
+                    <a:solidFill>
+                      <a:srgbClr val="FFFFFF"/>
+                    </a:solidFill>
+                  </a:tcPr>
+                </a:tc>
+                <a:tc>
+                  <a:txBody>
+                    <a:bodyPr wrap="square"/>
+                    <a:lstStyle/>
+                    <a:p>
+                      <a:r>
+                        <a:rPr sz="1100" b="0">
+                          <a:solidFill>
+                            <a:srgbClr val="282828"/>
+                          </a:solidFill>
+                          <a:latin typeface="Arial"/>
+                        </a:rPr>
+                        <a:t>Iterative nonlinear reconstructors reach machine precision below 0.25 rad rms; phase sorting extends to 0.75 rad; adding wavelengths to 1.4 rad rms</a:t>
+                      </a:r>
+                    </a:p>
+                  </a:txBody>
+                  <a:tcPr marL="54864" marR="54864" marT="18288" marB="18288">
+                    <a:solidFill>
+                      <a:srgbClr val="FFFFFF"/>
+                    </a:solidFill>
+                  </a:tcPr>
+                </a:tc>
+              </a:tr>
+              <a:tr h="468630">
+                <a:tc>
+                  <a:txBody>
+                    <a:bodyPr wrap="square"/>
+                    <a:lstStyle/>
+                    <a:p>
+                      <a:r>
+                        <a:rPr sz="1100" b="0">
+                          <a:solidFill>
+                            <a:srgbClr val="282828"/>
+                          </a:solidFill>
+                          <a:latin typeface="Arial"/>
+                        </a:rPr>
+                        <a:t>6</a:t>
+                      </a:r>
+                    </a:p>
+                  </a:txBody>
+                  <a:tcPr marL="54864" marR="54864" marT="18288" marB="18288">
+                    <a:solidFill>
+                      <a:srgbClr val="ECF1F6"/>
+                    </a:solidFill>
+                  </a:tcPr>
+                </a:tc>
+                <a:tc>
+                  <a:txBody>
+                    <a:bodyPr wrap="square"/>
+                    <a:lstStyle/>
+                    <a:p>
+                      <a:r>
+                        <a:rPr sz="1100" b="0">
+                          <a:solidFill>
+                            <a:srgbClr val="282828"/>
+                          </a:solidFill>
+                          <a:latin typeface="Arial"/>
+                        </a:rPr>
+                        <a:t>Darcis, Haffert, Chambouleyron, Doelman et al. 2025, A&amp;A</a:t>
+                      </a:r>
+                    </a:p>
+                  </a:txBody>
+                  <a:tcPr marL="54864" marR="54864" marT="18288" marB="18288">
+                    <a:solidFill>
+                      <a:srgbClr val="ECF1F6"/>
+                    </a:solidFill>
+                  </a:tcPr>
+                </a:tc>
+                <a:tc>
+                  <a:txBody>
+                    <a:bodyPr wrap="square"/>
+                    <a:lstStyle/>
+                    <a:p>
+                      <a:r>
+                        <a:rPr sz="1100" b="0">
+                          <a:solidFill>
+                            <a:srgbClr val="282828"/>
+                          </a:solidFill>
+                          <a:latin typeface="Arial"/>
+                        </a:rPr>
+                        <a:t>Multi-wavelength gradient descent through the forward model: dynamic range for the scalar sensor, photon robustness across a wider band, two-wavelength unwrapping of petal errors</a:t>
+                      </a:r>
+                    </a:p>
+                  </a:txBody>
+                  <a:tcPr marL="54864" marR="54864" marT="18288" marB="18288">
+                    <a:solidFill>
+                      <a:srgbClr val="ECF1F6"/>
+                    </a:solidFill>
+                  </a:tcPr>
+                </a:tc>
+              </a:tr>
+            </a:tbl>
+          </a:graphicData>
+        </a:graphic>
+      </p:graphicFrame>
+      <p:sp>
+        <p:nvSpPr>
+          <p:cNvPr id="5" name="TextBox 4"/>
+          <p:cNvSpPr txBox="1"/>
+          <p:nvPr/>
+        </p:nvSpPr>
+        <p:spPr>
+          <a:xfrm>
+            <a:off x="411480" y="4536567"/>
+            <a:ext cx="11368735" cy="274320"/>
+          </a:xfrm>
+          <a:prstGeom prst="rect">
+            <a:avLst/>
+          </a:prstGeom>
+          <a:noFill/>
+        </p:spPr>
+        <p:txBody>
+          <a:bodyPr wrap="square">
+            <a:spAutoFit/>
+          </a:bodyPr>
+          <a:lstStyle/>
+          <a:p>
+            <a:pPr>
+              <a:spcAft>
+                <a:spcPts val="600"/>
+              </a:spcAft>
+            </a:pPr>
+            <a:r>
+              <a:rPr sz="1050" b="0">
+                <a:solidFill>
+                  <a:srgbClr val="6E6E6E"/>
+                </a:solidFill>
+                <a:latin typeface="Arial"/>
+              </a:rPr>
+              <a:t>Priority = payoff against this campaign's measured weak results (the base-crosstalk floors, the undetected grid-on-base case, the stepped-reading regression under equal-weight color combination).  Synopses and links: macos/REPORT_zwfs_lit_scan.md.</a:t>
+            </a:r>
+          </a:p>
+        </p:txBody>
+      </p:sp>
+    </p:spTree>
+  </p:cSld>
+  <p:clrMapOvr>
+    <a:masterClrMapping/>
+  </p:clrMapOvr>
+</p:sld>
+</file>
+
+<file path=ppt/slides/slide11.xml><?xml version="1.0" encoding="utf-8"?>
+<p:sld xmlns:a="http://schemas.openxmlformats.org/drawingml/2006/main" xmlns:p="http://schemas.openxmlformats.org/presentationml/2006/main" xmlns:r="http://schemas.openxmlformats.org/officeDocument/2006/relationships">
+  <p:cSld>
+    <p:spTree>
+      <p:nvGrpSpPr>
+        <p:cNvPr id="1" name=""/>
+        <p:cNvGrpSpPr/>
+        <p:nvPr/>
+      </p:nvGrpSpPr>
+      <p:grpSpPr/>
+      <p:sp>
+        <p:nvSpPr>
+          <p:cNvPr id="2" name="TextBox 1"/>
+          <p:cNvSpPr txBox="1"/>
+          <p:nvPr/>
+        </p:nvSpPr>
+        <p:spPr>
+          <a:xfrm>
+            <a:off x="411480" y="201168"/>
+            <a:ext cx="11368735" cy="914400"/>
+          </a:xfrm>
+          <a:prstGeom prst="rect">
+            <a:avLst/>
+          </a:prstGeom>
+          <a:noFill/>
+        </p:spPr>
+        <p:txBody>
+          <a:bodyPr wrap="square">
+            <a:spAutoFit/>
+          </a:bodyPr>
+          <a:lstStyle/>
+          <a:p>
+            <a:pPr>
+              <a:spcAft>
+                <a:spcPts val="400"/>
+              </a:spcAft>
+            </a:pPr>
+            <a:r>
+              <a:rPr sz="2400" b="1">
+                <a:solidFill>
+                  <a:srgbClr val="1F4E79"/>
+                </a:solidFill>
+                <a:latin typeface="Arial"/>
+              </a:rPr>
+              <a:t>Demonstrations, segmented mirrors, and the in-house precedent</a:t>
+            </a:r>
+          </a:p>
+          <a:p>
+            <a:pPr>
+              <a:spcAft>
+                <a:spcPts val="0"/>
+              </a:spcAft>
+            </a:pPr>
+            <a:r>
+              <a:rPr sz="1250" b="0">
+                <a:solidFill>
+                  <a:srgbClr val="6E6E6E"/>
+                </a:solidFill>
+                <a:latin typeface="Arial"/>
+              </a:rPr>
+              <a:t>Picometers by alternating DM states and averaging; segment piston by model iteration, underestimated below 50 % Strehl</a:t>
+            </a:r>
+          </a:p>
+        </p:txBody>
+      </p:sp>
+      <p:sp>
+        <p:nvSpPr>
+          <p:cNvPr id="3" name="Rectangle 2"/>
+          <p:cNvSpPr/>
+          <p:nvPr/>
+        </p:nvSpPr>
+        <p:spPr>
+          <a:xfrm>
+            <a:off x="411480" y="1133856"/>
+            <a:ext cx="11368735" cy="20320"/>
+          </a:xfrm>
+          <a:prstGeom prst="rect">
+            <a:avLst/>
+          </a:prstGeom>
+          <a:solidFill>
+            <a:srgbClr val="B8C6D4"/>
+          </a:solidFill>
+          <a:ln>
+            <a:noFill/>
+          </a:ln>
+          <a:effectLst/>
+        </p:spPr>
+        <p:style>
+          <a:lnRef idx="1">
+            <a:schemeClr val="accent1"/>
+          </a:lnRef>
+          <a:fillRef idx="3">
+            <a:schemeClr val="accent1"/>
+          </a:fillRef>
+          <a:effectRef idx="2">
+            <a:schemeClr val="accent1"/>
+          </a:effectRef>
+          <a:fontRef idx="minor">
+            <a:schemeClr val="lt1"/>
+          </a:fontRef>
+        </p:style>
+        <p:txBody>
+          <a:bodyPr rtlCol="0" anchor="ctr"/>
+          <a:lstStyle/>
+          <a:p>
+            <a:pPr algn="ctr"/>
+          </a:p>
+        </p:txBody>
+      </p:sp>
+      <p:graphicFrame>
+        <p:nvGraphicFramePr>
+          <p:cNvPr id="4" name="Table 3"/>
+          <p:cNvGraphicFramePr>
+            <a:graphicFrameLocks noGrp="1"/>
+          </p:cNvGraphicFramePr>
+          <p:nvPr/>
+        </p:nvGraphicFramePr>
+        <p:xfrm>
+          <a:off x="411480" y="1298448"/>
+          <a:ext cx="11368734" cy="3091815"/>
+        </p:xfrm>
+        <a:graphic>
+          <a:graphicData uri="http://schemas.openxmlformats.org/drawingml/2006/table">
+            <a:tbl>
+              <a:tblPr firstRow="1" bandRow="1">
+                <a:tableStyleId>{5C22544A-7EE6-4342-B048-85BDC9FD1C3A}</a:tableStyleId>
+              </a:tblPr>
+              <a:tblGrid>
+                <a:gridCol w="291592"/>
+                <a:gridCol w="3730058"/>
+                <a:gridCol w="7347084"/>
+              </a:tblGrid>
+              <a:tr h="280035">
+                <a:tc>
+                  <a:txBody>
+                    <a:bodyPr wrap="square"/>
+                    <a:lstStyle/>
+                    <a:p>
+                      <a:r>
+                        <a:rPr sz="1100" b="1">
+                          <a:solidFill>
+                            <a:srgbClr val="FFFFFF"/>
+                          </a:solidFill>
+                          <a:latin typeface="Arial"/>
+                        </a:rPr>
+                        <a:t>#</a:t>
+                      </a:r>
+                    </a:p>
+                  </a:txBody>
+                  <a:tcPr marL="54864" marR="54864" marT="18288" marB="18288">
+                    <a:solidFill>
+                      <a:srgbClr val="1F4E79"/>
+                    </a:solidFill>
+                  </a:tcPr>
+                </a:tc>
+                <a:tc>
+                  <a:txBody>
+                    <a:bodyPr wrap="square"/>
+                    <a:lstStyle/>
+                    <a:p>
+                      <a:r>
+                        <a:rPr sz="1100" b="1">
+                          <a:solidFill>
+                            <a:srgbClr val="FFFFFF"/>
+                          </a:solidFill>
+                          <a:latin typeface="Arial"/>
+                        </a:rPr>
+                        <a:t>paper</a:t>
+                      </a:r>
+                    </a:p>
+                  </a:txBody>
+                  <a:tcPr marL="54864" marR="54864" marT="18288" marB="18288">
+                    <a:solidFill>
+                      <a:srgbClr val="1F4E79"/>
+                    </a:solidFill>
+                  </a:tcPr>
+                </a:tc>
+                <a:tc>
+                  <a:txBody>
+                    <a:bodyPr wrap="square"/>
+                    <a:lstStyle/>
+                    <a:p>
+                      <a:r>
+                        <a:rPr sz="1100" b="1">
+                          <a:solidFill>
+                            <a:srgbClr val="FFFFFF"/>
+                          </a:solidFill>
+                          <a:latin typeface="Arial"/>
+                        </a:rPr>
+                        <a:t>what it gives this model</a:t>
+                      </a:r>
+                    </a:p>
+                  </a:txBody>
+                  <a:tcPr marL="54864" marR="54864" marT="18288" marB="18288">
+                    <a:solidFill>
+                      <a:srgbClr val="1F4E79"/>
+                    </a:solidFill>
+                  </a:tcPr>
+                </a:tc>
+              </a:tr>
+              <a:tr h="468630">
+                <a:tc>
+                  <a:txBody>
+                    <a:bodyPr wrap="square"/>
+                    <a:lstStyle/>
+                    <a:p>
+                      <a:r>
+                        <a:rPr sz="1100" b="0">
+                          <a:solidFill>
+                            <a:srgbClr val="282828"/>
+                          </a:solidFill>
+                          <a:latin typeface="Arial"/>
+                        </a:rPr>
+                        <a:t>7</a:t>
+                      </a:r>
+                    </a:p>
+                  </a:txBody>
+                  <a:tcPr marL="54864" marR="54864" marT="18288" marB="18288">
+                    <a:solidFill>
+                      <a:srgbClr val="FFFFFF"/>
+                    </a:solidFill>
+                  </a:tcPr>
+                </a:tc>
+                <a:tc>
+                  <a:txBody>
+                    <a:bodyPr wrap="square"/>
+                    <a:lstStyle/>
+                    <a:p>
+                      <a:r>
+                        <a:rPr sz="1100" b="0">
+                          <a:solidFill>
+                            <a:srgbClr val="282828"/>
+                          </a:solidFill>
+                          <a:latin typeface="Arial"/>
+                        </a:rPr>
+                        <a:t>Steeves, Wallace, Kettenbeil, Jewell 2020, Optica 7, 1267</a:t>
+                      </a:r>
+                    </a:p>
+                  </a:txBody>
+                  <a:tcPr marL="54864" marR="54864" marT="18288" marB="18288">
+                    <a:solidFill>
+                      <a:srgbClr val="FFFFFF"/>
+                    </a:solidFill>
+                  </a:tcPr>
+                </a:tc>
+                <a:tc>
+                  <a:txBody>
+                    <a:bodyPr wrap="square"/>
+                    <a:lstStyle/>
+                    <a:p>
+                      <a:r>
+                        <a:rPr sz="1100" b="0">
+                          <a:solidFill>
+                            <a:srgbClr val="282828"/>
+                          </a:solidFill>
+                          <a:latin typeface="Arial"/>
+                        </a:rPr>
+                        <a:t>1.6 pm repeatability in 4.3 s by alternating flat and waffle DM states and averaging the differences; a reconstruction robust at the highest spatial frequencies</a:t>
+                      </a:r>
+                    </a:p>
+                  </a:txBody>
+                  <a:tcPr marL="54864" marR="54864" marT="18288" marB="18288">
+                    <a:solidFill>
+                      <a:srgbClr val="FFFFFF"/>
+                    </a:solidFill>
+                  </a:tcPr>
+                </a:tc>
+              </a:tr>
+              <a:tr h="468630">
+                <a:tc>
+                  <a:txBody>
+                    <a:bodyPr wrap="square"/>
+                    <a:lstStyle/>
+                    <a:p>
+                      <a:r>
+                        <a:rPr sz="1100" b="0">
+                          <a:solidFill>
+                            <a:srgbClr val="282828"/>
+                          </a:solidFill>
+                          <a:latin typeface="Arial"/>
+                        </a:rPr>
+                        <a:t>8</a:t>
+                      </a:r>
+                    </a:p>
+                  </a:txBody>
+                  <a:tcPr marL="54864" marR="54864" marT="18288" marB="18288">
+                    <a:solidFill>
+                      <a:srgbClr val="ECF1F6"/>
+                    </a:solidFill>
+                  </a:tcPr>
+                </a:tc>
+                <a:tc>
+                  <a:txBody>
+                    <a:bodyPr wrap="square"/>
+                    <a:lstStyle/>
+                    <a:p>
+                      <a:r>
+                        <a:rPr sz="1100" b="0">
+                          <a:solidFill>
+                            <a:srgbClr val="282828"/>
+                          </a:solidFill>
+                          <a:latin typeface="Arial"/>
+                        </a:rPr>
+                        <a:t>Wallace, Rao, Jensen-Clem, Serabyn 2011, SPIE 8126</a:t>
+                      </a:r>
+                    </a:p>
+                  </a:txBody>
+                  <a:tcPr marL="54864" marR="54864" marT="18288" marB="18288">
+                    <a:solidFill>
+                      <a:srgbClr val="ECF1F6"/>
+                    </a:solidFill>
+                  </a:tcPr>
+                </a:tc>
+                <a:tc>
+                  <a:txBody>
+                    <a:bodyPr wrap="square"/>
+                    <a:lstStyle/>
+                    <a:p>
+                      <a:r>
+                        <a:rPr sz="1100" b="0">
+                          <a:solidFill>
+                            <a:srgbClr val="282828"/>
+                          </a:solidFill>
+                          <a:latin typeface="Arial"/>
+                        </a:rPr>
+                        <a:t>All-reflective phase-shifting Zernike interferometer: a dynamic, arbitrary core phase shift read in four steps gives phase and amplitude; low sensitivity to vibration, polarization and wavelength</a:t>
+                      </a:r>
+                    </a:p>
+                  </a:txBody>
+                  <a:tcPr marL="54864" marR="54864" marT="18288" marB="18288">
+                    <a:solidFill>
+                      <a:srgbClr val="ECF1F6"/>
+                    </a:solidFill>
+                  </a:tcPr>
+                </a:tc>
+              </a:tr>
+              <a:tr h="468630">
+                <a:tc>
+                  <a:txBody>
+                    <a:bodyPr wrap="square"/>
+                    <a:lstStyle/>
+                    <a:p>
+                      <a:r>
+                        <a:rPr sz="1100" b="0">
+                          <a:solidFill>
+                            <a:srgbClr val="282828"/>
+                          </a:solidFill>
+                          <a:latin typeface="Arial"/>
+                        </a:rPr>
+                        <a:t>9</a:t>
+                      </a:r>
+                    </a:p>
+                  </a:txBody>
+                  <a:tcPr marL="54864" marR="54864" marT="18288" marB="18288">
+                    <a:solidFill>
+                      <a:srgbClr val="FFFFFF"/>
+                    </a:solidFill>
+                  </a:tcPr>
+                </a:tc>
+                <a:tc>
+                  <a:txBody>
+                    <a:bodyPr wrap="square"/>
+                    <a:lstStyle/>
+                    <a:p>
+                      <a:r>
+                        <a:rPr sz="1100" b="0">
+                          <a:solidFill>
+                            <a:srgbClr val="282828"/>
+                          </a:solidFill>
+                          <a:latin typeface="Arial"/>
+                        </a:rPr>
+                        <a:t>Moore and Redding 2018, SPIE 10698</a:t>
+                      </a:r>
+                    </a:p>
+                  </a:txBody>
+                  <a:tcPr marL="54864" marR="54864" marT="18288" marB="18288">
+                    <a:solidFill>
+                      <a:srgbClr val="FFFFFF"/>
+                    </a:solidFill>
+                  </a:tcPr>
+                </a:tc>
+                <a:tc>
+                  <a:txBody>
+                    <a:bodyPr wrap="square"/>
+                    <a:lstStyle/>
+                    <a:p>
+                      <a:r>
+                        <a:rPr sz="1100" b="0">
+                          <a:solidFill>
+                            <a:srgbClr val="282828"/>
+                          </a:solidFill>
+                          <a:latin typeface="Arial"/>
+                        </a:rPr>
+                        <a:t>Nonlinear polychromatic physical-optics reconstruction for picometer differential metrology on LUVOIR; the in-house precedent for the reconstructor above</a:t>
+                      </a:r>
+                    </a:p>
+                  </a:txBody>
+                  <a:tcPr marL="54864" marR="54864" marT="18288" marB="18288">
+                    <a:solidFill>
+                      <a:srgbClr val="FFFFFF"/>
+                    </a:solidFill>
+                  </a:tcPr>
+                </a:tc>
+              </a:tr>
+              <a:tr h="468630">
+                <a:tc>
+                  <a:txBody>
+                    <a:bodyPr wrap="square"/>
+                    <a:lstStyle/>
+                    <a:p>
+                      <a:r>
+                        <a:rPr sz="1100" b="0">
+                          <a:solidFill>
+                            <a:srgbClr val="282828"/>
+                          </a:solidFill>
+                          <a:latin typeface="Arial"/>
+                        </a:rPr>
+                        <a:t>10</a:t>
+                      </a:r>
+                    </a:p>
+                  </a:txBody>
+                  <a:tcPr marL="54864" marR="54864" marT="18288" marB="18288">
+                    <a:solidFill>
+                      <a:srgbClr val="ECF1F6"/>
+                    </a:solidFill>
+                  </a:tcPr>
+                </a:tc>
+                <a:tc>
+                  <a:txBody>
+                    <a:bodyPr wrap="square"/>
+                    <a:lstStyle/>
+                    <a:p>
+                      <a:r>
+                        <a:rPr sz="1100" b="0">
+                          <a:solidFill>
+                            <a:srgbClr val="282828"/>
+                          </a:solidFill>
+                          <a:latin typeface="Arial"/>
+                        </a:rPr>
+                        <a:t>Keck vector-Zernike segment control 2024 (arXiv 2404.08728); Wallace et al. 2022 (arXiv 2205.02241)</a:t>
+                      </a:r>
+                    </a:p>
+                  </a:txBody>
+                  <a:tcPr marL="54864" marR="54864" marT="18288" marB="18288">
+                    <a:solidFill>
+                      <a:srgbClr val="ECF1F6"/>
+                    </a:solidFill>
+                  </a:tcPr>
+                </a:tc>
+                <a:tc>
+                  <a:txBody>
+                    <a:bodyPr wrap="square"/>
+                    <a:lstStyle/>
+                    <a:p>
+                      <a:r>
+                        <a:rPr sz="1100" b="0">
+                          <a:solidFill>
+                            <a:srgbClr val="282828"/>
+                          </a:solidFill>
+                          <a:latin typeface="Arial"/>
+                        </a:rPr>
+                        <a:t>Segment piston by model-based iteration; 11 nm rms piston uncertainty; underestimation 2 to 4× below 50 % Strehl; fabricated shifts 0.30π and 0.68π instead of ±0.5π</a:t>
+                      </a:r>
+                    </a:p>
+                  </a:txBody>
+                  <a:tcPr marL="54864" marR="54864" marT="18288" marB="18288">
+                    <a:solidFill>
+                      <a:srgbClr val="ECF1F6"/>
+                    </a:solidFill>
+                  </a:tcPr>
+                </a:tc>
+              </a:tr>
+              <a:tr h="468630">
+                <a:tc>
+                  <a:txBody>
+                    <a:bodyPr wrap="square"/>
+                    <a:lstStyle/>
+                    <a:p>
+                      <a:r>
+                        <a:rPr sz="1100" b="0">
+                          <a:solidFill>
+                            <a:srgbClr val="282828"/>
+                          </a:solidFill>
+                          <a:latin typeface="Arial"/>
+                        </a:rPr>
+                        <a:t>11</a:t>
+                      </a:r>
+                    </a:p>
+                  </a:txBody>
+                  <a:tcPr marL="54864" marR="54864" marT="18288" marB="18288">
+                    <a:solidFill>
+                      <a:srgbClr val="FFFFFF"/>
+                    </a:solidFill>
+                  </a:tcPr>
+                </a:tc>
+                <a:tc>
+                  <a:txBody>
+                    <a:bodyPr wrap="square"/>
+                    <a:lstStyle/>
+                    <a:p>
+                      <a:r>
+                        <a:rPr sz="1100" b="0">
+                          <a:solidFill>
+                            <a:srgbClr val="282828"/>
+                          </a:solidFill>
+                          <a:latin typeface="Arial"/>
+                        </a:rPr>
+                        <a:t>HiCAT mid-order Zernike sensor 2024 (arXiv 2409.03411)</a:t>
+                      </a:r>
+                    </a:p>
+                  </a:txBody>
+                  <a:tcPr marL="54864" marR="54864" marT="18288" marB="18288">
+                    <a:solidFill>
+                      <a:srgbClr val="FFFFFF"/>
+                    </a:solidFill>
+                  </a:tcPr>
+                </a:tc>
+                <a:tc>
+                  <a:txBody>
+                    <a:bodyPr wrap="square"/>
+                    <a:lstStyle/>
+                    <a:p>
+                      <a:r>
+                        <a:rPr sz="1100" b="0">
+                          <a:solidFill>
+                            <a:srgbClr val="282828"/>
+                          </a:solidFill>
+                          <a:latin typeface="Arial"/>
+                        </a:rPr>
+                        <a:t>Per-segment piston, tip and tilt by interaction matrix; a minimal step of 125 ± 31 pm at SNR 4; 14-bit DM quantization reads as steps in the response</a:t>
+                      </a:r>
+                    </a:p>
+                  </a:txBody>
+                  <a:tcPr marL="54864" marR="54864" marT="18288" marB="18288">
+                    <a:solidFill>
+                      <a:srgbClr val="FFFFFF"/>
+                    </a:solidFill>
+                  </a:tcPr>
+                </a:tc>
+              </a:tr>
+              <a:tr h="468630">
+                <a:tc>
+                  <a:txBody>
+                    <a:bodyPr wrap="square"/>
+                    <a:lstStyle/>
+                    <a:p>
+                      <a:r>
+                        <a:rPr sz="1100" b="0">
+                          <a:solidFill>
+                            <a:srgbClr val="282828"/>
+                          </a:solidFill>
+                          <a:latin typeface="Arial"/>
+                        </a:rPr>
+                        <a:t>12</a:t>
+                      </a:r>
+                    </a:p>
+                  </a:txBody>
+                  <a:tcPr marL="54864" marR="54864" marT="18288" marB="18288">
+                    <a:solidFill>
+                      <a:srgbClr val="ECF1F6"/>
+                    </a:solidFill>
+                  </a:tcPr>
+                </a:tc>
+                <a:tc>
+                  <a:txBody>
+                    <a:bodyPr wrap="square"/>
+                    <a:lstStyle/>
+                    <a:p>
+                      <a:r>
+                        <a:rPr sz="1100" b="0">
+                          <a:solidFill>
+                            <a:srgbClr val="282828"/>
+                          </a:solidFill>
+                          <a:latin typeface="Arial"/>
+                        </a:rPr>
+                        <a:t>Shi et al. 2015, SPIE 9605 (Roman low-order sensor)</a:t>
+                      </a:r>
+                    </a:p>
+                  </a:txBody>
+                  <a:tcPr marL="54864" marR="54864" marT="18288" marB="18288">
+                    <a:solidFill>
+                      <a:srgbClr val="ECF1F6"/>
+                    </a:solidFill>
+                  </a:tcPr>
+                </a:tc>
+                <a:tc>
+                  <a:txBody>
+                    <a:bodyPr wrap="square"/>
+                    <a:lstStyle/>
+                    <a:p>
+                      <a:r>
+                        <a:rPr sz="1100" b="0">
+                          <a:solidFill>
+                            <a:srgbClr val="282828"/>
+                          </a:solidFill>
+                          <a:latin typeface="Arial"/>
+                        </a:rPr>
+                        <a:t>A reflective dimple on the focal-plane mask senses Z2 to Z11 from the rejected starlight: the spatially filtered form of the same sensor</a:t>
+                      </a:r>
+                    </a:p>
+                  </a:txBody>
+                  <a:tcPr marL="54864" marR="54864" marT="18288" marB="18288">
+                    <a:solidFill>
+                      <a:srgbClr val="ECF1F6"/>
+                    </a:solidFill>
+                  </a:tcPr>
+                </a:tc>
+              </a:tr>
+            </a:tbl>
+          </a:graphicData>
+        </a:graphic>
+      </p:graphicFrame>
+      <p:sp>
+        <p:nvSpPr>
+          <p:cNvPr id="5" name="TextBox 4"/>
+          <p:cNvSpPr txBox="1"/>
+          <p:nvPr/>
+        </p:nvSpPr>
+        <p:spPr>
+          <a:xfrm>
+            <a:off x="411480" y="4536567"/>
+            <a:ext cx="11368735" cy="274320"/>
+          </a:xfrm>
+          <a:prstGeom prst="rect">
+            <a:avLst/>
+          </a:prstGeom>
+          <a:noFill/>
+        </p:spPr>
+        <p:txBody>
+          <a:bodyPr wrap="square">
+            <a:spAutoFit/>
+          </a:bodyPr>
+          <a:lstStyle/>
+          <a:p>
+            <a:pPr>
+              <a:spcAft>
+                <a:spcPts val="600"/>
+              </a:spcAft>
+            </a:pPr>
+            <a:r>
+              <a:rPr sz="1050" b="0">
+                <a:solidFill>
+                  <a:srgbClr val="6E6E6E"/>
+                </a:solidFill>
+                <a:latin typeface="Arial"/>
+              </a:rPr>
+              <a:t>Also read: PIAA-ZWFS (2026, arXiv 2606.28136), lossless pupil apodization that closes the gap to the fundamental sensitivity limit by 10× — a design lever, not a model change.</a:t>
+            </a:r>
+          </a:p>
+        </p:txBody>
+      </p:sp>
+    </p:spTree>
+  </p:cSld>
+  <p:clrMapOvr>
+    <a:masterClrMapping/>
+  </p:clrMapOvr>
+</p:sld>
+</file>
+
+<file path=ppt/slides/slide12.xml><?xml version="1.0" encoding="utf-8"?>
+<p:sld xmlns:a="http://schemas.openxmlformats.org/drawingml/2006/main" xmlns:p="http://schemas.openxmlformats.org/presentationml/2006/main" xmlns:r="http://schemas.openxmlformats.org/officeDocument/2006/relationships">
+  <p:cSld>
+    <p:spTree>
+      <p:nvGrpSpPr>
+        <p:cNvPr id="1" name=""/>
+        <p:cNvGrpSpPr/>
+        <p:nvPr/>
+      </p:nvGrpSpPr>
+      <p:grpSpPr/>
+      <p:sp>
+        <p:nvSpPr>
+          <p:cNvPr id="2" name="TextBox 1"/>
+          <p:cNvSpPr txBox="1"/>
+          <p:nvPr/>
+        </p:nvSpPr>
+        <p:spPr>
+          <a:xfrm>
+            <a:off x="411480" y="201168"/>
+            <a:ext cx="11368735" cy="914400"/>
+          </a:xfrm>
+          <a:prstGeom prst="rect">
+            <a:avLst/>
+          </a:prstGeom>
+          <a:noFill/>
+        </p:spPr>
+        <p:txBody>
+          <a:bodyPr wrap="square">
+            <a:spAutoFit/>
+          </a:bodyPr>
+          <a:lstStyle/>
+          <a:p>
+            <a:pPr>
+              <a:spcAft>
+                <a:spcPts val="400"/>
+              </a:spcAft>
+            </a:pPr>
+            <a:r>
+              <a:rPr sz="2400" b="1">
+                <a:solidFill>
+                  <a:srgbClr val="1F4E79"/>
+                </a:solidFill>
+                <a:latin typeface="Arial"/>
+              </a:rPr>
+              <a:t>Conclusions: reconstruct with an iterated reference wave first</a:t>
+            </a:r>
+          </a:p>
+          <a:p>
+            <a:pPr>
+              <a:spcAft>
+                <a:spcPts val="0"/>
+              </a:spcAft>
+            </a:pPr>
+            <a:r>
+              <a:rPr sz="1250" b="0">
+                <a:solidFill>
+                  <a:srgbClr val="6E6E6E"/>
+                </a:solidFill>
+                <a:latin typeface="Arial"/>
+              </a:rPr>
+              <a:t>The frozen-reference linear reading is the un-iterated case of what every recent paper iterates; that is where the sensor's remaining floors come from</a:t>
+            </a:r>
+          </a:p>
+        </p:txBody>
+      </p:sp>
+      <p:sp>
+        <p:nvSpPr>
+          <p:cNvPr id="3" name="Rectangle 2"/>
+          <p:cNvSpPr/>
+          <p:nvPr/>
+        </p:nvSpPr>
+        <p:spPr>
+          <a:xfrm>
+            <a:off x="411480" y="1133856"/>
+            <a:ext cx="11368735" cy="20320"/>
+          </a:xfrm>
+          <a:prstGeom prst="rect">
+            <a:avLst/>
+          </a:prstGeom>
+          <a:solidFill>
+            <a:srgbClr val="B8C6D4"/>
+          </a:solidFill>
+          <a:ln>
+            <a:noFill/>
+          </a:ln>
+          <a:effectLst/>
+        </p:spPr>
+        <p:style>
+          <a:lnRef idx="1">
+            <a:schemeClr val="accent1"/>
+          </a:lnRef>
+          <a:fillRef idx="3">
+            <a:schemeClr val="accent1"/>
+          </a:fillRef>
+          <a:effectRef idx="2">
+            <a:schemeClr val="accent1"/>
+          </a:effectRef>
+          <a:fontRef idx="minor">
+            <a:schemeClr val="lt1"/>
+          </a:fontRef>
+        </p:style>
+        <p:txBody>
+          <a:bodyPr rtlCol="0" anchor="ctr"/>
+          <a:lstStyle/>
+          <a:p>
+            <a:pPr algn="ctr"/>
+          </a:p>
+        </p:txBody>
+      </p:sp>
       <p:sp>
         <p:nvSpPr>
           <p:cNvPr id="4" name="TextBox 3"/>
@@ -3433,6 +4698,549 @@
                 </a:solidFill>
                 <a:latin typeface="Arial"/>
               </a:rPr>
+              <a:t>•  Why this comes first: the base-crosstalk floors and the undetected grid-on-base case are the frozen-b error — the reference wave is calibrated on the flat DM and never updated, so a working surface moves the reference core and the linear reading reads it as crosstalk (S2b: defocus on a working surface read 0.74 under exact retrieval).  Every recent reconstructor iterates b; this model does not yet.</a:t>
+            </a:r>
+          </a:p>
+          <a:p>
+            <a:pPr>
+              <a:spcAft>
+                <a:spcPts val="600"/>
+              </a:spcAft>
+            </a:pPr>
+            <a:r>
+              <a:rPr sz="1500" b="0">
+                <a:solidFill>
+                  <a:srgbClr val="282828"/>
+                </a:solidFill>
+                <a:latin typeface="Arial"/>
+              </a:rPr>
+              <a:t>•  The spec: solve each pixel exactly from the masked image, the pupil amplitude and b (Ruane 2020, eq. 36–37); re-propagate the estimate through the mask model to refresh b; repeat three to five times.  The engine's exact reference field gates the FFT surrogate for b to 10⁻¹⁰ before it is trusted — a check no bench can make.  Success: the grid-on-base case detected from one frame at SNR ≥ 5, and the hold-out gain within 3 % of 1 without the modal over-correction.</a:t>
+            </a:r>
+          </a:p>
+          <a:p>
+            <a:pPr>
+              <a:spcAft>
+                <a:spcPts val="600"/>
+              </a:spcAft>
+            </a:pPr>
+            <a:r>
+              <a:rPr sz="1500" b="0">
+                <a:solidFill>
+                  <a:srgbClr val="282828"/>
+                </a:solidFill>
+                <a:latin typeface="Arial"/>
+              </a:rPr>
+              <a:t>•  What this model has that the papers do not: engine-exact reference and pupil fields, the ray-affine registration doctrine, actuator-space scoring through the DM influence model, the two-observables-per-pixel depth-ladder result, and the color-resolved migration of the response nulls.</a:t>
+            </a:r>
+          </a:p>
+        </p:txBody>
+      </p:sp>
+      <p:sp>
+        <p:nvSpPr>
+          <p:cNvPr id="5" name="TextBox 4"/>
+          <p:cNvSpPr txBox="1"/>
+          <p:nvPr/>
+        </p:nvSpPr>
+        <p:spPr>
+          <a:xfrm>
+            <a:off x="411480" y="4479797"/>
+            <a:ext cx="11368735" cy="274320"/>
+          </a:xfrm>
+          <a:prstGeom prst="rect">
+            <a:avLst/>
+          </a:prstGeom>
+          <a:noFill/>
+        </p:spPr>
+        <p:txBody>
+          <a:bodyPr wrap="square">
+            <a:spAutoFit/>
+          </a:bodyPr>
+          <a:lstStyle/>
+          <a:p>
+            <a:pPr>
+              <a:spcAft>
+                <a:spcPts val="600"/>
+              </a:spcAft>
+            </a:pPr>
+            <a:r>
+              <a:rPr sz="1050" b="0">
+                <a:solidFill>
+                  <a:srgbClr val="6E6E6E"/>
+                </a:solidFill>
+                <a:latin typeface="Arial"/>
+              </a:rPr>
+              <a:t>Spec and provenance: macos/REPORT_zwfs_lit_scan.md, "Suggested first ZWFS task"; implemented as a third reading in dm_gauge_lib/dmg_zwfs_gauge beside the frozen-linear and phase-stepped readings.</a:t>
+            </a:r>
+          </a:p>
+        </p:txBody>
+      </p:sp>
+    </p:spTree>
+  </p:cSld>
+  <p:clrMapOvr>
+    <a:masterClrMapping/>
+  </p:clrMapOvr>
+</p:sld>
+</file>
+
+<file path=ppt/slides/slide13.xml><?xml version="1.0" encoding="utf-8"?>
+<p:sld xmlns:a="http://schemas.openxmlformats.org/drawingml/2006/main" xmlns:p="http://schemas.openxmlformats.org/presentationml/2006/main" xmlns:r="http://schemas.openxmlformats.org/officeDocument/2006/relationships">
+  <p:cSld>
+    <p:spTree>
+      <p:nvGrpSpPr>
+        <p:cNvPr id="1" name=""/>
+        <p:cNvGrpSpPr/>
+        <p:nvPr/>
+      </p:nvGrpSpPr>
+      <p:grpSpPr/>
+      <p:sp>
+        <p:nvSpPr>
+          <p:cNvPr id="2" name="TextBox 1"/>
+          <p:cNvSpPr txBox="1"/>
+          <p:nvPr/>
+        </p:nvSpPr>
+        <p:spPr>
+          <a:xfrm>
+            <a:off x="411480" y="201168"/>
+            <a:ext cx="11368735" cy="914400"/>
+          </a:xfrm>
+          <a:prstGeom prst="rect">
+            <a:avLst/>
+          </a:prstGeom>
+          <a:noFill/>
+        </p:spPr>
+        <p:txBody>
+          <a:bodyPr wrap="square">
+            <a:spAutoFit/>
+          </a:bodyPr>
+          <a:lstStyle/>
+          <a:p>
+            <a:pPr>
+              <a:spcAft>
+                <a:spcPts val="400"/>
+              </a:spcAft>
+            </a:pPr>
+            <a:r>
+              <a:rPr sz="2400" b="1">
+                <a:solidFill>
+                  <a:srgbClr val="1F4E79"/>
+                </a:solidFill>
+                <a:latin typeface="Arial"/>
+              </a:rPr>
+              <a:t>Conclusions: the follow-on imports, in order</a:t>
+            </a:r>
+          </a:p>
+          <a:p>
+            <a:pPr>
+              <a:spcAft>
+                <a:spcPts val="0"/>
+              </a:spcAft>
+            </a:pPr>
+            <a:r>
+              <a:rPr sz="1250" b="0">
+                <a:solidFill>
+                  <a:srgbClr val="6E6E6E"/>
+                </a:solidFill>
+                <a:latin typeface="Arial"/>
+              </a:rPr>
+              <a:t>Budget form, model-matched DM calibration, spot and color reruns on the new reconstructor, the vector sensor priced before it is built</a:t>
+            </a:r>
+          </a:p>
+        </p:txBody>
+      </p:sp>
+      <p:sp>
+        <p:nvSpPr>
+          <p:cNvPr id="3" name="Rectangle 2"/>
+          <p:cNvSpPr/>
+          <p:nvPr/>
+        </p:nvSpPr>
+        <p:spPr>
+          <a:xfrm>
+            <a:off x="411480" y="1133856"/>
+            <a:ext cx="11368735" cy="20320"/>
+          </a:xfrm>
+          <a:prstGeom prst="rect">
+            <a:avLst/>
+          </a:prstGeom>
+          <a:solidFill>
+            <a:srgbClr val="B8C6D4"/>
+          </a:solidFill>
+          <a:ln>
+            <a:noFill/>
+          </a:ln>
+          <a:effectLst/>
+        </p:spPr>
+        <p:style>
+          <a:lnRef idx="1">
+            <a:schemeClr val="accent1"/>
+          </a:lnRef>
+          <a:fillRef idx="3">
+            <a:schemeClr val="accent1"/>
+          </a:fillRef>
+          <a:effectRef idx="2">
+            <a:schemeClr val="accent1"/>
+          </a:effectRef>
+          <a:fontRef idx="minor">
+            <a:schemeClr val="lt1"/>
+          </a:fontRef>
+        </p:style>
+        <p:txBody>
+          <a:bodyPr rtlCol="0" anchor="ctr"/>
+          <a:lstStyle/>
+          <a:p>
+            <a:pPr algn="ctr"/>
+          </a:p>
+        </p:txBody>
+      </p:sp>
+      <p:sp>
+        <p:nvSpPr>
+          <p:cNvPr id="4" name="TextBox 3"/>
+          <p:cNvSpPr txBox="1"/>
+          <p:nvPr/>
+        </p:nvSpPr>
+        <p:spPr>
+          <a:xfrm>
+            <a:off x="411480" y="1298448"/>
+            <a:ext cx="11368735" cy="274320"/>
+          </a:xfrm>
+          <a:prstGeom prst="rect">
+            <a:avLst/>
+          </a:prstGeom>
+          <a:noFill/>
+        </p:spPr>
+        <p:txBody>
+          <a:bodyPr wrap="square">
+            <a:spAutoFit/>
+          </a:bodyPr>
+          <a:lstStyle/>
+          <a:p>
+            <a:pPr>
+              <a:spcAft>
+                <a:spcPts val="600"/>
+              </a:spcAft>
+            </a:pPr>
+            <a:r>
+              <a:rPr sz="1500" b="0">
+                <a:solidFill>
+                  <a:srgbClr val="282828"/>
+                </a:solidFill>
+                <a:latin typeface="Arial"/>
+              </a:rPr>
+              <a:t>•  The JPL budget form: a per-pixel sensitivity factor from the measured fields predicts the photon-noise stage analytically, and the four systematic terms (pupil calibration at ½, reference wave at 1, dimple depth, initial phase) become the rows of the error budget.</a:t>
+            </a:r>
+          </a:p>
+          <a:p>
+            <a:pPr>
+              <a:spcAft>
+                <a:spcPts val="600"/>
+              </a:spcAft>
+            </a:pPr>
+            <a:r>
+              <a:rPr sz="1500" b="0">
+                <a:solidFill>
+                  <a:srgbClr val="282828"/>
+                </a:solidFill>
+                <a:latin typeface="Arial"/>
+              </a:rPr>
+              <a:t>•  Calibrate the DM through the sensor's own image model: fit actuator positions and gains by matching sensor images of poke grids to a simulation that includes the propagation distances — the out-of-conjugate case.  The interferometer's detector sits off the DM conjugate after the null-tuned tail, so this is its lever too.</a:t>
+            </a:r>
+          </a:p>
+          <a:p>
+            <a:pPr>
+              <a:spcAft>
+                <a:spcPts val="600"/>
+              </a:spcAft>
+            </a:pPr>
+            <a:r>
+              <a:rPr sz="1500" b="0">
+                <a:solidFill>
+                  <a:srgbClr val="282828"/>
+                </a:solidFill>
+                <a:latin typeface="Arial"/>
+              </a:rPr>
+              <a:t>•  Rerun spot size and color on the new reconstructor: the "larger spot, worse b" trade disappears once b is iterated, so the 1.06 / 2.0 / 3.0 λ/D sweep is due again; the five-color combination becomes a joint per-wavelength fit, which also removes the stepped-reading regression seen under equal weights.</a:t>
+            </a:r>
+          </a:p>
+          <a:p>
+            <a:pPr>
+              <a:spcAft>
+                <a:spcPts val="600"/>
+              </a:spcAft>
+            </a:pPr>
+            <a:r>
+              <a:rPr sz="1500" b="0">
+                <a:solidFill>
+                  <a:srgbClr val="282828"/>
+                </a:solidFill>
+                <a:latin typeface="Arial"/>
+              </a:rPr>
+              <a:t>•  Model the vector sensor before the metasurface is built: the exact two-image solution and its leakage terms (retardance offsets, splitter rotation) run on the engine's polarization machinery; the bench limits at Keck and SEAL were defocus and crosstalk between the two pupil images, both priceable here.</a:t>
+            </a:r>
+          </a:p>
+          <a:p>
+            <a:pPr>
+              <a:spcAft>
+                <a:spcPts val="600"/>
+              </a:spcAft>
+            </a:pPr>
+            <a:r>
+              <a:rPr sz="1500" b="0">
+                <a:solidFill>
+                  <a:srgbClr val="282828"/>
+                </a:solidFill>
+                <a:latin typeface="Arial"/>
+              </a:rPr>
+              <a:t>•  The interferometer, for balance: a PZT phase shift buys no model gain — its floors are geometric and color-independent — but on hardware an absolute phase scale and freedom from polarization systematics; the recommended form is a hybrid: polarization snapshot for the differential measurements, a PZT on the reference flat as calibrator.</a:t>
+            </a:r>
+          </a:p>
+        </p:txBody>
+      </p:sp>
+      <p:sp>
+        <p:nvSpPr>
+          <p:cNvPr id="5" name="TextBox 4"/>
+          <p:cNvSpPr txBox="1"/>
+          <p:nvPr/>
+        </p:nvSpPr>
+        <p:spPr>
+          <a:xfrm>
+            <a:off x="411480" y="5750814"/>
+            <a:ext cx="11368735" cy="274320"/>
+          </a:xfrm>
+          <a:prstGeom prst="rect">
+            <a:avLst/>
+          </a:prstGeom>
+          <a:noFill/>
+        </p:spPr>
+        <p:txBody>
+          <a:bodyPr wrap="square">
+            <a:spAutoFit/>
+          </a:bodyPr>
+          <a:lstStyle/>
+          <a:p>
+            <a:pPr>
+              <a:spcAft>
+                <a:spcPts val="600"/>
+              </a:spcAft>
+            </a:pPr>
+            <a:r>
+              <a:rPr sz="1050" b="0">
+                <a:solidFill>
+                  <a:srgbClr val="6E6E6E"/>
+                </a:solidFill>
+                <a:latin typeface="Arial"/>
+              </a:rPr>
+              <a:t>Segmented-mirror lessons carried forward: the sensor reads segment piston but not global piston, DM quantization appears as steps in the response, and piston is underestimated below 50 % Strehl (Keck) — all three enter the e5-class segmented gauges.</a:t>
+            </a:r>
+          </a:p>
+        </p:txBody>
+      </p:sp>
+    </p:spTree>
+  </p:cSld>
+  <p:clrMapOvr>
+    <a:masterClrMapping/>
+  </p:clrMapOvr>
+</p:sld>
+</file>
+
+<file path=ppt/slides/slide14.xml><?xml version="1.0" encoding="utf-8"?>
+<p:sld xmlns:a="http://schemas.openxmlformats.org/drawingml/2006/main" xmlns:p="http://schemas.openxmlformats.org/presentationml/2006/main" xmlns:r="http://schemas.openxmlformats.org/officeDocument/2006/relationships">
+  <p:cSld>
+    <p:spTree>
+      <p:nvGrpSpPr>
+        <p:cNvPr id="1" name=""/>
+        <p:cNvGrpSpPr/>
+        <p:nvPr/>
+      </p:nvGrpSpPr>
+      <p:grpSpPr/>
+      <p:sp>
+        <p:nvSpPr>
+          <p:cNvPr id="2" name="TextBox 1"/>
+          <p:cNvSpPr txBox="1"/>
+          <p:nvPr/>
+        </p:nvSpPr>
+        <p:spPr>
+          <a:xfrm>
+            <a:off x="822960" y="2743200"/>
+            <a:ext cx="10545775" cy="1280160"/>
+          </a:xfrm>
+          <a:prstGeom prst="rect">
+            <a:avLst/>
+          </a:prstGeom>
+          <a:noFill/>
+        </p:spPr>
+        <p:txBody>
+          <a:bodyPr wrap="square">
+            <a:spAutoFit/>
+          </a:bodyPr>
+          <a:lstStyle/>
+          <a:p>
+            <a:pPr algn="ctr">
+              <a:spcAft>
+                <a:spcPts val="400"/>
+              </a:spcAft>
+            </a:pPr>
+            <a:r>
+              <a:rPr sz="4000" b="1">
+                <a:solidFill>
+                  <a:srgbClr val="1F4E79"/>
+                </a:solidFill>
+                <a:latin typeface="Arial"/>
+              </a:rPr>
+              <a:t>Backup</a:t>
+            </a:r>
+          </a:p>
+        </p:txBody>
+      </p:sp>
+    </p:spTree>
+  </p:cSld>
+  <p:clrMapOvr>
+    <a:masterClrMapping/>
+  </p:clrMapOvr>
+</p:sld>
+</file>
+
+<file path=ppt/slides/slide15.xml><?xml version="1.0" encoding="utf-8"?>
+<p:sld xmlns:a="http://schemas.openxmlformats.org/drawingml/2006/main" xmlns:p="http://schemas.openxmlformats.org/presentationml/2006/main" xmlns:r="http://schemas.openxmlformats.org/officeDocument/2006/relationships">
+  <p:cSld>
+    <p:spTree>
+      <p:nvGrpSpPr>
+        <p:cNvPr id="1" name=""/>
+        <p:cNvGrpSpPr/>
+        <p:nvPr/>
+      </p:nvGrpSpPr>
+      <p:grpSpPr/>
+      <p:sp>
+        <p:nvSpPr>
+          <p:cNvPr id="2" name="TextBox 1"/>
+          <p:cNvSpPr txBox="1"/>
+          <p:nvPr/>
+        </p:nvSpPr>
+        <p:spPr>
+          <a:xfrm>
+            <a:off x="411480" y="201168"/>
+            <a:ext cx="11368735" cy="914400"/>
+          </a:xfrm>
+          <a:prstGeom prst="rect">
+            <a:avLst/>
+          </a:prstGeom>
+          <a:noFill/>
+        </p:spPr>
+        <p:txBody>
+          <a:bodyPr wrap="square">
+            <a:spAutoFit/>
+          </a:bodyPr>
+          <a:lstStyle/>
+          <a:p>
+            <a:pPr>
+              <a:spcAft>
+                <a:spcPts val="400"/>
+              </a:spcAft>
+            </a:pPr>
+            <a:r>
+              <a:rPr sz="2400" b="1">
+                <a:solidFill>
+                  <a:srgbClr val="1F4E79"/>
+                </a:solidFill>
+                <a:latin typeface="Arial"/>
+              </a:rPr>
+              <a:t>Provenance and records</a:t>
+            </a:r>
+          </a:p>
+          <a:p>
+            <a:pPr>
+              <a:spcAft>
+                <a:spcPts val="0"/>
+              </a:spcAft>
+            </a:pPr>
+            <a:r>
+              <a:rPr sz="1250" b="0">
+                <a:solidFill>
+                  <a:srgbClr val="6E6E6E"/>
+                </a:solidFill>
+                <a:latin typeface="Arial"/>
+              </a:rPr>
+              <a:t>Every number re-derives from a committed script</a:t>
+            </a:r>
+          </a:p>
+        </p:txBody>
+      </p:sp>
+      <p:sp>
+        <p:nvSpPr>
+          <p:cNvPr id="3" name="Rectangle 2"/>
+          <p:cNvSpPr/>
+          <p:nvPr/>
+        </p:nvSpPr>
+        <p:spPr>
+          <a:xfrm>
+            <a:off x="411480" y="1133856"/>
+            <a:ext cx="11368735" cy="20320"/>
+          </a:xfrm>
+          <a:prstGeom prst="rect">
+            <a:avLst/>
+          </a:prstGeom>
+          <a:solidFill>
+            <a:srgbClr val="B8C6D4"/>
+          </a:solidFill>
+          <a:ln>
+            <a:noFill/>
+          </a:ln>
+          <a:effectLst/>
+        </p:spPr>
+        <p:style>
+          <a:lnRef idx="1">
+            <a:schemeClr val="accent1"/>
+          </a:lnRef>
+          <a:fillRef idx="3">
+            <a:schemeClr val="accent1"/>
+          </a:fillRef>
+          <a:effectRef idx="2">
+            <a:schemeClr val="accent1"/>
+          </a:effectRef>
+          <a:fontRef idx="minor">
+            <a:schemeClr val="lt1"/>
+          </a:fontRef>
+        </p:style>
+        <p:txBody>
+          <a:bodyPr rtlCol="0" anchor="ctr"/>
+          <a:lstStyle/>
+          <a:p>
+            <a:pPr algn="ctr"/>
+          </a:p>
+        </p:txBody>
+      </p:sp>
+      <p:sp>
+        <p:nvSpPr>
+          <p:cNvPr id="4" name="TextBox 3"/>
+          <p:cNvSpPr txBox="1"/>
+          <p:nvPr/>
+        </p:nvSpPr>
+        <p:spPr>
+          <a:xfrm>
+            <a:off x="411480" y="1298448"/>
+            <a:ext cx="11368735" cy="274320"/>
+          </a:xfrm>
+          <a:prstGeom prst="rect">
+            <a:avLst/>
+          </a:prstGeom>
+          <a:noFill/>
+        </p:spPr>
+        <p:txBody>
+          <a:bodyPr wrap="square">
+            <a:spAutoFit/>
+          </a:bodyPr>
+          <a:lstStyle/>
+          <a:p>
+            <a:pPr>
+              <a:spcAft>
+                <a:spcPts val="600"/>
+              </a:spcAft>
+            </a:pPr>
+            <a:r>
+              <a:rPr sz="1500" b="0">
+                <a:solidFill>
+                  <a:srgbClr val="282828"/>
+                </a:solidFill>
+                <a:latin typeface="Arial"/>
+              </a:rPr>
               <a:t>•  Campaign: templates/40_benches/zwfs_dm96 — zwfs_s1.m (five gates: sampling, superposition, reference wave, response, no-dimple control), zwfs_mask.m, zwfs_s1_figs.m (the figures here), zwfs_s1_report.txt, README with the findings chain; plan and rulings in macos/BRIEF_zwfs_campaign.md.</a:t>
             </a:r>
           </a:p>
@@ -3530,6 +5338,22 @@
                 <a:latin typeface="Arial"/>
               </a:rPr>
               <a:t>•  Interferometer comparison column: templates/40_benches/tg_psi_dm96, run 10 (tg96_report.txt).</a:t>
+            </a:r>
+          </a:p>
+          <a:p>
+            <a:pPr>
+              <a:spcAft>
+                <a:spcPts val="600"/>
+              </a:spcAft>
+            </a:pPr>
+            <a:r>
+              <a:rPr sz="1500" b="0">
+                <a:solidFill>
+                  <a:srgbClr val="282828"/>
+                </a:solidFill>
+                <a:latin typeface="Arial"/>
+              </a:rPr>
+              <a:t>•  Literature scan (2026-09-09): macos/REPORT_zwfs_lit_scan.md — twelve papers, ranked, with the PZT verdict for the interferometer and the spec for the iterated-reference-wave reconstructor.</a:t>
             </a:r>
           </a:p>
         </p:txBody>

</xml_diff>

<commit_message>
S11 closed-loop hold metric: campaign brief section, CCMac addendum (the IFO half, deliverable 7), deck_zwfs slide 14 + side-by-side row + conclusion (DRAFT), slice
Record run loop193: the loop propagates noise and a random walk per
theory on the real instrument; L and S cost the same light (3 pm from
~2e12 photons per cycle noise-only, ~7.4e12 under a 2 pm walk); the
stepped reading has no fixed error (steps -> 0.000 pm), the linear
reading imprints fine-scale error under a persistent low-order residual
(thermal 27.6 vs 10.0 pm), the one-frame exact reading diverges.

Co-Authored-By: Claude Fable 5.1 <noreply@anthropic.com>
</commit_message>
<xml_diff>
--- a/demo_session/deck_zwfs.pptx
+++ b/demo_session/deck_zwfs.pptx
@@ -27,6 +27,7 @@
     <p:sldId id="275" r:id="rId26"/>
     <p:sldId id="276" r:id="rId27"/>
     <p:sldId id="277" r:id="rId28"/>
+    <p:sldId id="278" r:id="rId29"/>
   </p:sldIdLst>
   <p:sldSz cx="12191695" cy="6858000" type="screen4x3"/>
   <p:notesSz cx="6858000" cy="9144000"/>
@@ -5766,7 +5767,7 @@
                 </a:solidFill>
                 <a:latin typeface="Arial"/>
               </a:rPr>
-              <a:t>Run it yourself</a:t>
+              <a:t>Holding the surface in closed loop: the on-orbit metric</a:t>
             </a:r>
           </a:p>
           <a:p>
@@ -5782,7 +5783,7 @@
                 </a:solidFill>
                 <a:latin typeface="Arial"/>
               </a:rPr>
-              <a:t>One parameter sheet and one script reproduce every number here; the defaults reproduce the stage-7 record to the last printed digit</a:t>
+              <a:t>Servoed through the sensor, the readings cost the same light; what differs is each reading's fixed error: none, some, or a runaway</a:t>
             </a:r>
           </a:p>
         </p:txBody>
@@ -5831,16 +5832,40 @@
           </a:p>
         </p:txBody>
       </p:sp>
-      <p:sp>
-        <p:nvSpPr>
-          <p:cNvPr id="4" name="TextBox 3"/>
+      <p:pic>
+        <p:nvPicPr>
+          <p:cNvPr id="4" name="Picture 3" descr="crop_zwfs_loop193_left.png"/>
+          <p:cNvPicPr>
+            <a:picLocks noChangeAspect="1"/>
+          </p:cNvPicPr>
+          <p:nvPr/>
+        </p:nvPicPr>
+        <p:blipFill>
+          <a:blip r:embed="rId2"/>
+          <a:stretch>
+            <a:fillRect/>
+          </a:stretch>
+        </p:blipFill>
+        <p:spPr>
+          <a:xfrm>
+            <a:off x="1654521" y="1298448"/>
+            <a:ext cx="3320357" cy="2823972"/>
+          </a:xfrm>
+          <a:prstGeom prst="rect">
+            <a:avLst/>
+          </a:prstGeom>
+        </p:spPr>
+      </p:pic>
+      <p:sp>
+        <p:nvSpPr>
+          <p:cNvPr id="5" name="TextBox 4"/>
           <p:cNvSpPr txBox="1"/>
           <p:nvPr/>
         </p:nvSpPr>
         <p:spPr>
           <a:xfrm>
-            <a:off x="411480" y="1298448"/>
-            <a:ext cx="11368735" cy="274320"/>
+            <a:off x="411480" y="4140708"/>
+            <a:ext cx="5806440" cy="559307"/>
           </a:xfrm>
           <a:prstGeom prst="rect">
             <a:avLst/>
@@ -5853,34 +5878,34 @@
           </a:bodyPr>
           <a:lstStyle/>
           <a:p>
-            <a:pPr>
+            <a:pPr algn="ctr">
               <a:spcAft>
-                <a:spcPts val="600"/>
+                <a:spcPts val="0"/>
               </a:spcAft>
             </a:pPr>
             <a:r>
-              <a:rPr sz="1500" b="0">
-                <a:solidFill>
-                  <a:srgbClr val="282828"/>
+              <a:rPr sz="1000" b="0">
+                <a:solidFill>
+                  <a:srgbClr val="6E6E6E"/>
                 </a:solidFill>
                 <a:latin typeface="Arial"/>
               </a:rPr>
-              <a:t>•  Two files: zwfs_params.m returns every setting at its value of record — grid and ray count, wavelength, the bench's lengths and tuned figures, the mask's etch and spot, the sampling checks, registration, the DM sizes, the test amplitudes and seeds, the colour and photon stages.  zwfs_run.m runs the chosen stages and writes the report, a .mat file and the figures into a folder named by the run's tag.</a:t>
+              <a:t>The stepped reading's residual per cycle under a 2 pm-per-cycle random walk at four light levels (10¹² to 10¹⁵ photons per cycle, light to dark), and a noise-free 1 nm step (dashed) returning to zero.  Left panel of the runner's figure.</a:t>
             </a:r>
           </a:p>
         </p:txBody>
       </p:sp>
       <p:graphicFrame>
         <p:nvGraphicFramePr>
-          <p:cNvPr id="5" name="Table 4"/>
+          <p:cNvPr id="6" name="Table 5"/>
           <p:cNvGraphicFramePr>
             <a:graphicFrameLocks noGrp="1"/>
           </p:cNvGraphicFramePr>
           <p:nvPr/>
         </p:nvGraphicFramePr>
         <p:xfrm>
-          <a:off x="411480" y="2465831"/>
-          <a:ext cx="11368735" cy="1680210"/>
+          <a:off x="6400800" y="1298448"/>
+          <a:ext cx="5394959" cy="2000250"/>
         </p:xfrm>
         <a:graphic>
           <a:graphicData uri="http://schemas.openxmlformats.org/drawingml/2006/table">
@@ -5889,23 +5914,25 @@
                 <a:tableStyleId>{5C22544A-7EE6-4342-B048-85BDC9FD1C3A}</a:tableStyleId>
               </a:tblPr>
               <a:tblGrid>
-                <a:gridCol w="6601201"/>
-                <a:gridCol w="4767534"/>
+                <a:gridCol w="1622874"/>
+                <a:gridCol w="1052675"/>
+                <a:gridCol w="921090"/>
+                <a:gridCol w="1798320"/>
               </a:tblGrid>
-              <a:tr h="280035">
-                <a:tc>
-                  <a:txBody>
-                    <a:bodyPr wrap="square"/>
-                    <a:lstStyle/>
-                    <a:p>
-                      <a:r>
-                        <a:rPr sz="1100" b="1">
+              <a:tr h="434340">
+                <a:tc>
+                  <a:txBody>
+                    <a:bodyPr wrap="square"/>
+                    <a:lstStyle/>
+                    <a:p>
+                      <a:r>
+                        <a:rPr sz="1000" b="1">
                           <a:solidFill>
                             <a:srgbClr val="FFFFFF"/>
                           </a:solidFill>
                           <a:latin typeface="Arial"/>
                         </a:rPr>
-                        <a:t>call</a:t>
+                        <a:t>held to 3 pm rms: photons per cycle</a:t>
                       </a:r>
                     </a:p>
                   </a:txBody>
@@ -5921,13 +5948,13 @@
                     <a:lstStyle/>
                     <a:p>
                       <a:r>
-                        <a:rPr sz="1100" b="1">
+                        <a:rPr sz="1000" b="1">
                           <a:solidFill>
                             <a:srgbClr val="FFFFFF"/>
                           </a:solidFill>
                           <a:latin typeface="Arial"/>
                         </a:rPr>
-                        <a:t>what it does</a:t>
+                        <a:t>linear (L)</a:t>
                       </a:r>
                     </a:p>
                   </a:txBody>
@@ -5937,21 +5964,65 @@
                     </a:solidFill>
                   </a:tcPr>
                 </a:tc>
+                <a:tc>
+                  <a:txBody>
+                    <a:bodyPr wrap="square"/>
+                    <a:lstStyle/>
+                    <a:p>
+                      <a:r>
+                        <a:rPr sz="1000" b="1">
+                          <a:solidFill>
+                            <a:srgbClr val="FFFFFF"/>
+                          </a:solidFill>
+                          <a:latin typeface="Arial"/>
+                        </a:rPr>
+                        <a:t>exact, one frame (I+)</a:t>
+                      </a:r>
+                    </a:p>
+                  </a:txBody>
+                  <a:tcPr marL="54864" marR="54864" marT="18288" marB="18288">
+                    <a:solidFill>
+                      <a:srgbClr val="1F4E79"/>
+                    </a:solidFill>
+                  </a:tcPr>
+                </a:tc>
+                <a:tc>
+                  <a:txBody>
+                    <a:bodyPr wrap="square"/>
+                    <a:lstStyle/>
+                    <a:p>
+                      <a:r>
+                        <a:rPr sz="1000" b="1">
+                          <a:solidFill>
+                            <a:srgbClr val="FFFFFF"/>
+                          </a:solidFill>
+                          <a:latin typeface="Arial"/>
+                        </a:rPr>
+                        <a:t>stepped (S)</a:t>
+                      </a:r>
+                    </a:p>
+                  </a:txBody>
+                  <a:tcPr marL="54864" marR="54864" marT="18288" marB="18288">
+                    <a:solidFill>
+                      <a:srgbClr val="1F4E79"/>
+                    </a:solidFill>
+                  </a:tcPr>
+                </a:tc>
               </a:tr>
-              <a:tr h="280035">
-                <a:tc>
-                  <a:txBody>
-                    <a:bodyPr wrap="square"/>
-                    <a:lstStyle/>
-                    <a:p>
-                      <a:r>
-                        <a:rPr sz="1100" b="0">
-                          <a:solidFill>
-                            <a:srgbClr val="282828"/>
-                          </a:solidFill>
-                          <a:latin typeface="Arial"/>
-                        </a:rPr>
-                        <a:t>zwfs_run</a:t>
+              <a:tr h="262890">
+                <a:tc>
+                  <a:txBody>
+                    <a:bodyPr wrap="square"/>
+                    <a:lstStyle/>
+                    <a:p>
+                      <a:r>
+                        <a:rPr sz="1000" b="0">
+                          <a:solidFill>
+                            <a:srgbClr val="282828"/>
+                          </a:solidFill>
+                          <a:latin typeface="Arial"/>
+                        </a:rPr>
+                        <a:t>noise only</a:t>
                       </a:r>
                     </a:p>
                   </a:txBody>
@@ -5967,13 +6038,13 @@
                     <a:lstStyle/>
                     <a:p>
                       <a:r>
-                        <a:rPr sz="1100" b="0">
-                          <a:solidFill>
-                            <a:srgbClr val="282828"/>
-                          </a:solidFill>
-                          <a:latin typeface="Arial"/>
-                        </a:rPr>
-                        <a:t>the record: bench checks, the full test set, figures</a:t>
+                        <a:rPr sz="1000" b="0">
+                          <a:solidFill>
+                            <a:srgbClr val="282828"/>
+                          </a:solidFill>
+                          <a:latin typeface="Arial"/>
+                        </a:rPr>
+                        <a:t>2.1×10¹²</a:t>
                       </a:r>
                     </a:p>
                   </a:txBody>
@@ -5983,21 +6054,65 @@
                     </a:solidFill>
                   </a:tcPr>
                 </a:tc>
+                <a:tc>
+                  <a:txBody>
+                    <a:bodyPr wrap="square"/>
+                    <a:lstStyle/>
+                    <a:p>
+                      <a:r>
+                        <a:rPr sz="1000" b="0">
+                          <a:solidFill>
+                            <a:srgbClr val="282828"/>
+                          </a:solidFill>
+                          <a:latin typeface="Arial"/>
+                        </a:rPr>
+                        <a:t>runs away</a:t>
+                      </a:r>
+                    </a:p>
+                  </a:txBody>
+                  <a:tcPr marL="54864" marR="54864" marT="18288" marB="18288">
+                    <a:solidFill>
+                      <a:srgbClr val="FFFFFF"/>
+                    </a:solidFill>
+                  </a:tcPr>
+                </a:tc>
+                <a:tc>
+                  <a:txBody>
+                    <a:bodyPr wrap="square"/>
+                    <a:lstStyle/>
+                    <a:p>
+                      <a:r>
+                        <a:rPr sz="1000" b="0">
+                          <a:solidFill>
+                            <a:srgbClr val="282828"/>
+                          </a:solidFill>
+                          <a:latin typeface="Arial"/>
+                        </a:rPr>
+                        <a:t>2.6×10¹²</a:t>
+                      </a:r>
+                    </a:p>
+                  </a:txBody>
+                  <a:tcPr marL="54864" marR="54864" marT="18288" marB="18288">
+                    <a:solidFill>
+                      <a:srgbClr val="FFFFFF"/>
+                    </a:solidFill>
+                  </a:tcPr>
+                </a:tc>
               </a:tr>
-              <a:tr h="280035">
-                <a:tc>
-                  <a:txBody>
-                    <a:bodyPr wrap="square"/>
-                    <a:lstStyle/>
-                    <a:p>
-                      <a:r>
-                        <a:rPr sz="1100" b="0">
-                          <a:solidFill>
-                            <a:srgbClr val="282828"/>
-                          </a:solidFill>
-                          <a:latin typeface="Arial"/>
-                        </a:rPr>
-                        <a:t>zwfs_run('tag','ng385', 'NGRID',385)</a:t>
+              <a:tr h="434340">
+                <a:tc>
+                  <a:txBody>
+                    <a:bodyPr wrap="square"/>
+                    <a:lstStyle/>
+                    <a:p>
+                      <a:r>
+                        <a:rPr sz="1000" b="0">
+                          <a:solidFill>
+                            <a:srgbClr val="282828"/>
+                          </a:solidFill>
+                          <a:latin typeface="Arial"/>
+                        </a:rPr>
+                        <a:t>random walk, 2 pm per cycle</a:t>
                       </a:r>
                     </a:p>
                   </a:txBody>
@@ -6013,13 +6128,13 @@
                     <a:lstStyle/>
                     <a:p>
                       <a:r>
-                        <a:rPr sz="1100" b="0">
-                          <a:solidFill>
-                            <a:srgbClr val="282828"/>
-                          </a:solidFill>
-                          <a:latin typeface="Arial"/>
-                        </a:rPr>
-                        <a:t>the 1-megapixel camera</a:t>
+                        <a:rPr sz="1000" b="0">
+                          <a:solidFill>
+                            <a:srgbClr val="282828"/>
+                          </a:solidFill>
+                          <a:latin typeface="Arial"/>
+                        </a:rPr>
+                        <a:t>7.3×10¹²</a:t>
                       </a:r>
                     </a:p>
                   </a:txBody>
@@ -6029,21 +6144,65 @@
                     </a:solidFill>
                   </a:tcPr>
                 </a:tc>
+                <a:tc>
+                  <a:txBody>
+                    <a:bodyPr wrap="square"/>
+                    <a:lstStyle/>
+                    <a:p>
+                      <a:r>
+                        <a:rPr sz="1000" b="0">
+                          <a:solidFill>
+                            <a:srgbClr val="282828"/>
+                          </a:solidFill>
+                          <a:latin typeface="Arial"/>
+                        </a:rPr>
+                        <a:t>runs away</a:t>
+                      </a:r>
+                    </a:p>
+                  </a:txBody>
+                  <a:tcPr marL="54864" marR="54864" marT="18288" marB="18288">
+                    <a:solidFill>
+                      <a:srgbClr val="ECF1F6"/>
+                    </a:solidFill>
+                  </a:tcPr>
+                </a:tc>
+                <a:tc>
+                  <a:txBody>
+                    <a:bodyPr wrap="square"/>
+                    <a:lstStyle/>
+                    <a:p>
+                      <a:r>
+                        <a:rPr sz="1000" b="0">
+                          <a:solidFill>
+                            <a:srgbClr val="282828"/>
+                          </a:solidFill>
+                          <a:latin typeface="Arial"/>
+                        </a:rPr>
+                        <a:t>7.5×10¹²</a:t>
+                      </a:r>
+                    </a:p>
+                  </a:txBody>
+                  <a:tcPr marL="54864" marR="54864" marT="18288" marB="18288">
+                    <a:solidFill>
+                      <a:srgbClr val="ECF1F6"/>
+                    </a:solidFill>
+                  </a:tcPr>
+                </a:tc>
               </a:tr>
-              <a:tr h="280035">
-                <a:tc>
-                  <a:txBody>
-                    <a:bodyPr wrap="square"/>
-                    <a:lstStyle/>
-                    <a:p>
-                      <a:r>
-                        <a:rPr sz="1100" b="0">
-                          <a:solidFill>
-                            <a:srgbClr val="282828"/>
-                          </a:solidFill>
-                          <a:latin typeface="Arial"/>
-                        </a:rPr>
-                        <a:t>zwfs_run('MODEL',2048, 'NGRID',385, 'param_file','macos_param_2048.txt')</a:t>
+              <a:tr h="434340">
+                <a:tc>
+                  <a:txBody>
+                    <a:bodyPr wrap="square"/>
+                    <a:lstStyle/>
+                    <a:p>
+                      <a:r>
+                        <a:rPr sz="1000" b="0">
+                          <a:solidFill>
+                            <a:srgbClr val="282828"/>
+                          </a:solidFill>
+                          <a:latin typeface="Arial"/>
+                        </a:rPr>
+                        <a:t>thermal ramp, 5 pm per cycle</a:t>
                       </a:r>
                     </a:p>
                   </a:txBody>
@@ -6059,13 +6218,13 @@
                     <a:lstStyle/>
                     <a:p>
                       <a:r>
-                        <a:rPr sz="1100" b="0">
-                          <a:solidFill>
-                            <a:srgbClr val="282828"/>
-                          </a:solidFill>
-                          <a:latin typeface="Arial"/>
-                        </a:rPr>
-                        <a:t>the fully sampled setup on a 30 GB machine</a:t>
+                        <a:rPr sz="1000" b="0">
+                          <a:solidFill>
+                            <a:srgbClr val="282828"/>
+                          </a:solidFill>
+                          <a:latin typeface="Arial"/>
+                        </a:rPr>
+                        <a:t>27.6 pm at any light</a:t>
                       </a:r>
                     </a:p>
                   </a:txBody>
@@ -6075,21 +6234,65 @@
                     </a:solidFill>
                   </a:tcPr>
                 </a:tc>
+                <a:tc>
+                  <a:txBody>
+                    <a:bodyPr wrap="square"/>
+                    <a:lstStyle/>
+                    <a:p>
+                      <a:r>
+                        <a:rPr sz="1000" b="0">
+                          <a:solidFill>
+                            <a:srgbClr val="282828"/>
+                          </a:solidFill>
+                          <a:latin typeface="Arial"/>
+                        </a:rPr>
+                        <a:t>runs away</a:t>
+                      </a:r>
+                    </a:p>
+                  </a:txBody>
+                  <a:tcPr marL="54864" marR="54864" marT="18288" marB="18288">
+                    <a:solidFill>
+                      <a:srgbClr val="FFFFFF"/>
+                    </a:solidFill>
+                  </a:tcPr>
+                </a:tc>
+                <a:tc>
+                  <a:txBody>
+                    <a:bodyPr wrap="square"/>
+                    <a:lstStyle/>
+                    <a:p>
+                      <a:r>
+                        <a:rPr sz="1000" b="0">
+                          <a:solidFill>
+                            <a:srgbClr val="282828"/>
+                          </a:solidFill>
+                          <a:latin typeface="Arial"/>
+                        </a:rPr>
+                        <a:t>10.0 pm at any light (the loop's own lag)</a:t>
+                      </a:r>
+                    </a:p>
+                  </a:txBody>
+                  <a:tcPr marL="54864" marR="54864" marT="18288" marB="18288">
+                    <a:solidFill>
+                      <a:srgbClr val="FFFFFF"/>
+                    </a:solidFill>
+                  </a:tcPr>
+                </a:tc>
               </a:tr>
-              <a:tr h="280035">
-                <a:tc>
-                  <a:txBody>
-                    <a:bodyPr wrap="square"/>
-                    <a:lstStyle/>
-                    <a:p>
-                      <a:r>
-                        <a:rPr sz="1100" b="0">
-                          <a:solidFill>
-                            <a:srgbClr val="282828"/>
-                          </a:solidFill>
-                          <a:latin typeface="Arial"/>
-                        </a:rPr>
-                        <a:t>zwfs_run('stages',{'battery','color','noise','figs'})</a:t>
+              <a:tr h="434340">
+                <a:tc>
+                  <a:txBody>
+                    <a:bodyPr wrap="square"/>
+                    <a:lstStyle/>
+                    <a:p>
+                      <a:r>
+                        <a:rPr sz="1000" b="0">
+                          <a:solidFill>
+                            <a:srgbClr val="282828"/>
+                          </a:solidFill>
+                          <a:latin typeface="Arial"/>
+                        </a:rPr>
+                        <a:t>noise-free 1 nm step, after 60 cycles</a:t>
                       </a:r>
                     </a:p>
                   </a:txBody>
@@ -6105,13 +6308,13 @@
                     <a:lstStyle/>
                     <a:p>
                       <a:r>
-                        <a:rPr sz="1100" b="0">
-                          <a:solidFill>
-                            <a:srgbClr val="282828"/>
-                          </a:solidFill>
-                          <a:latin typeface="Arial"/>
-                        </a:rPr>
-                        <a:t>everything on this deck's later slides</a:t>
+                        <a:rPr sz="1000" b="0">
+                          <a:solidFill>
+                            <a:srgbClr val="282828"/>
+                          </a:solidFill>
+                          <a:latin typeface="Arial"/>
+                        </a:rPr>
+                        <a:t>1.2 pm and still falling</a:t>
                       </a:r>
                     </a:p>
                   </a:txBody>
@@ -6121,49 +6324,47 @@
                     </a:solidFill>
                   </a:tcPr>
                 </a:tc>
-              </a:tr>
-              <a:tr h="280035">
-                <a:tc>
-                  <a:txBody>
-                    <a:bodyPr wrap="square"/>
-                    <a:lstStyle/>
-                    <a:p>
-                      <a:r>
-                        <a:rPr sz="1100" b="0">
-                          <a:solidFill>
-                            <a:srgbClr val="282828"/>
-                          </a:solidFill>
-                          <a:latin typeface="Arial"/>
-                        </a:rPr>
-                        <a:t>./zwfs_batch.sh TAG "the same arguments"</a:t>
-                      </a:r>
-                    </a:p>
-                  </a:txBody>
-                  <a:tcPr marL="54864" marR="54864" marT="18288" marB="18288">
-                    <a:solidFill>
-                      <a:srgbClr val="FFFFFF"/>
-                    </a:solidFill>
-                  </a:tcPr>
-                </a:tc>
-                <a:tc>
-                  <a:txBody>
-                    <a:bodyPr wrap="square"/>
-                    <a:lstStyle/>
-                    <a:p>
-                      <a:r>
-                        <a:rPr sz="1100" b="0">
-                          <a:solidFill>
-                            <a:srgbClr val="282828"/>
-                          </a:solidFill>
-                          <a:latin typeface="Arial"/>
-                        </a:rPr>
-                        <a:t>unattended, memory-capped, logged</a:t>
-                      </a:r>
-                    </a:p>
-                  </a:txBody>
-                  <a:tcPr marL="54864" marR="54864" marT="18288" marB="18288">
-                    <a:solidFill>
-                      <a:srgbClr val="FFFFFF"/>
+                <a:tc>
+                  <a:txBody>
+                    <a:bodyPr wrap="square"/>
+                    <a:lstStyle/>
+                    <a:p>
+                      <a:r>
+                        <a:rPr sz="1000" b="0">
+                          <a:solidFill>
+                            <a:srgbClr val="282828"/>
+                          </a:solidFill>
+                          <a:latin typeface="Arial"/>
+                        </a:rPr>
+                        <a:t>99 nm</a:t>
+                      </a:r>
+                    </a:p>
+                  </a:txBody>
+                  <a:tcPr marL="54864" marR="54864" marT="18288" marB="18288">
+                    <a:solidFill>
+                      <a:srgbClr val="ECF1F6"/>
+                    </a:solidFill>
+                  </a:tcPr>
+                </a:tc>
+                <a:tc>
+                  <a:txBody>
+                    <a:bodyPr wrap="square"/>
+                    <a:lstStyle/>
+                    <a:p>
+                      <a:r>
+                        <a:rPr sz="1000" b="0">
+                          <a:solidFill>
+                            <a:srgbClr val="282828"/>
+                          </a:solidFill>
+                          <a:latin typeface="Arial"/>
+                        </a:rPr>
+                        <a:t>0.000 pm</a:t>
+                      </a:r>
+                    </a:p>
+                  </a:txBody>
+                  <a:tcPr marL="54864" marR="54864" marT="18288" marB="18288">
+                    <a:solidFill>
+                      <a:srgbClr val="ECF1F6"/>
                     </a:solidFill>
                   </a:tcPr>
                 </a:tc>
@@ -6174,14 +6375,14 @@
       </p:graphicFrame>
       <p:sp>
         <p:nvSpPr>
-          <p:cNvPr id="6" name="TextBox 5"/>
+          <p:cNvPr id="7" name="TextBox 6"/>
           <p:cNvSpPr txBox="1"/>
           <p:nvPr/>
         </p:nvSpPr>
         <p:spPr>
           <a:xfrm>
-            <a:off x="411480" y="4292346"/>
-            <a:ext cx="11368735" cy="274320"/>
+            <a:off x="6400800" y="3445002"/>
+            <a:ext cx="5394960" cy="274320"/>
           </a:xfrm>
           <a:prstGeom prst="rect">
             <a:avLst/>
@@ -6200,27 +6401,43 @@
               </a:spcAft>
             </a:pPr>
             <a:r>
-              <a:rPr sz="1500" b="0">
+              <a:rPr sz="1200" b="0">
                 <a:solidFill>
                   <a:srgbClr val="282828"/>
                 </a:solidFill>
                 <a:latin typeface="Arial"/>
               </a:rPr>
-              <a:t>•  Checks that run every time: the no-mask round trip through the bracket (must return the field unchanged); the reference-wave model against the engine's own field; the pupil brightness must not change with the DM shape; the sampling checks (pixels across the dimple, camera pixels per actuator); and the search for the camera-to-DM mirror/transpose and sign.</a:t>
-            </a:r>
-          </a:p>
-        </p:txBody>
-      </p:sp>
-      <p:sp>
-        <p:nvSpPr>
-          <p:cNvPr id="7" name="TextBox 6"/>
+              <a:t>•  The loop: the DM is held at the 30 nm working surface by a proportional servo (gain 0.5) closed through one reading; each cycle the state is measured with N photons, compared with the set point's frames, and half the estimated change removed.  The same loop code will run the interferometer.</a:t>
+            </a:r>
+          </a:p>
+          <a:p>
+            <a:pPr>
+              <a:spcAft>
+                <a:spcPts val="600"/>
+              </a:spcAft>
+            </a:pPr>
+            <a:r>
+              <a:rPr sz="1200" b="0">
+                <a:solidFill>
+                  <a:srgbClr val="282828"/>
+                </a:solidFill>
+                <a:latin typeface="Arial"/>
+              </a:rPr>
+              <a:t>•  What it shows: noise and a random walk propagate exactly as theory says, and L and S cost the same light.  What differs is the fixed error: S has none; L imprints a fine-scale error on the DM when a slow ramp leaves a persistent low-order residual; I+ has sites that read with the wrong sign, and no gain fixes a wrong sign.</a:t>
+            </a:r>
+          </a:p>
+        </p:txBody>
+      </p:sp>
+      <p:sp>
+        <p:nvSpPr>
+          <p:cNvPr id="8" name="TextBox 7"/>
           <p:cNvSpPr txBox="1"/>
           <p:nvPr/>
         </p:nvSpPr>
         <p:spPr>
           <a:xfrm>
-            <a:off x="411480" y="5459730"/>
-            <a:ext cx="11368735" cy="274320"/>
+            <a:off x="6400800" y="5743194"/>
+            <a:ext cx="5394960" cy="274320"/>
           </a:xfrm>
           <a:prstGeom prst="rect">
             <a:avLst/>
@@ -6245,7 +6462,7 @@
                 </a:solidFill>
                 <a:latin typeface="Arial"/>
               </a:rPr>
-              <a:t>Reproduction check: 64 lines of results against the stage-7 report, 8 differ in the last printed digit (the actuator fit's solver tolerance).  README "Run it yourself" carries the parameter table.</a:t>
+              <a:t>Gain 0.5, 60 cycles, matrix measured on the working surface, 193 rays (385-ray check: runs/loop385).  A ramp under a proportional loop always lags by rate/gain; an integral term is the fix.  Code dm_gauge_lib/dmg_loop, gated by tDmgLoop.</a:t>
             </a:r>
           </a:p>
         </p:txBody>
@@ -6302,7 +6519,7 @@
                 </a:solidFill>
                 <a:latin typeface="Arial"/>
               </a:rPr>
-              <a:t>Side by side with the Twyman–Green</a:t>
+              <a:t>Run it yourself</a:t>
             </a:r>
           </a:p>
           <a:p>
@@ -6318,7 +6535,7 @@
                 </a:solidFill>
                 <a:latin typeface="Arial"/>
               </a:rPr>
-              <a:t>The interferometer loses response at fine patterns and never fails; the sensor, calibrated on its working surface, reads a change to 5 pm up to 50–60 nm</a:t>
+              <a:t>One parameter sheet and one script reproduce every number here; the defaults reproduce the stage-7 record to the last printed digit</a:t>
             </a:r>
           </a:p>
         </p:txBody>
@@ -6367,17 +6584,56 @@
           </a:p>
         </p:txBody>
       </p:sp>
+      <p:sp>
+        <p:nvSpPr>
+          <p:cNvPr id="4" name="TextBox 3"/>
+          <p:cNvSpPr txBox="1"/>
+          <p:nvPr/>
+        </p:nvSpPr>
+        <p:spPr>
+          <a:xfrm>
+            <a:off x="411480" y="1298448"/>
+            <a:ext cx="11368735" cy="274320"/>
+          </a:xfrm>
+          <a:prstGeom prst="rect">
+            <a:avLst/>
+          </a:prstGeom>
+          <a:noFill/>
+        </p:spPr>
+        <p:txBody>
+          <a:bodyPr wrap="square">
+            <a:spAutoFit/>
+          </a:bodyPr>
+          <a:lstStyle/>
+          <a:p>
+            <a:pPr>
+              <a:spcAft>
+                <a:spcPts val="600"/>
+              </a:spcAft>
+            </a:pPr>
+            <a:r>
+              <a:rPr sz="1500" b="0">
+                <a:solidFill>
+                  <a:srgbClr val="282828"/>
+                </a:solidFill>
+                <a:latin typeface="Arial"/>
+              </a:rPr>
+              <a:t>•  Two files: zwfs_params.m returns every setting at its value of record — grid and ray count, wavelength, the bench's lengths and tuned figures, the mask's etch and spot, the sampling checks, registration, the DM sizes, the test amplitudes and seeds, the colour and photon stages.  zwfs_run.m runs the chosen stages and writes the report, a .mat file and the figures into a folder named by the run's tag.</a:t>
+            </a:r>
+          </a:p>
+        </p:txBody>
+      </p:sp>
       <p:graphicFrame>
         <p:nvGraphicFramePr>
-          <p:cNvPr id="4" name="Table 3"/>
+          <p:cNvPr id="5" name="Table 4"/>
           <p:cNvGraphicFramePr>
             <a:graphicFrameLocks noGrp="1"/>
           </p:cNvGraphicFramePr>
           <p:nvPr/>
         </p:nvGraphicFramePr>
         <p:xfrm>
-          <a:off x="411480" y="1298448"/>
-          <a:ext cx="11368734" cy="3366135"/>
+          <a:off x="411480" y="2465831"/>
+          <a:ext cx="11368735" cy="1680210"/>
         </p:xfrm>
         <a:graphic>
           <a:graphicData uri="http://schemas.openxmlformats.org/drawingml/2006/table">
@@ -6386,16 +6642,25 @@
                 <a:tableStyleId>{5C22544A-7EE6-4342-B048-85BDC9FD1C3A}</a:tableStyleId>
               </a:tblPr>
               <a:tblGrid>
-                <a:gridCol w="2399431"/>
-                <a:gridCol w="2570819"/>
-                <a:gridCol w="6398484"/>
+                <a:gridCol w="6601201"/>
+                <a:gridCol w="4767534"/>
               </a:tblGrid>
               <a:tr h="280035">
                 <a:tc>
                   <a:txBody>
                     <a:bodyPr wrap="square"/>
                     <a:lstStyle/>
-                    <a:p/>
+                    <a:p>
+                      <a:r>
+                        <a:rPr sz="1100" b="1">
+                          <a:solidFill>
+                            <a:srgbClr val="FFFFFF"/>
+                          </a:solidFill>
+                          <a:latin typeface="Arial"/>
+                        </a:rPr>
+                        <a:t>call</a:t>
+                      </a:r>
+                    </a:p>
                   </a:txBody>
                   <a:tcPr marL="54864" marR="54864" marT="18288" marB="18288">
                     <a:solidFill>
@@ -6415,29 +6680,7 @@
                           </a:solidFill>
                           <a:latin typeface="Arial"/>
                         </a:rPr>
-                        <a:t>Twyman–Green PSI (measured)</a:t>
-                      </a:r>
-                    </a:p>
-                  </a:txBody>
-                  <a:tcPr marL="54864" marR="54864" marT="18288" marB="18288">
-                    <a:solidFill>
-                      <a:srgbClr val="1F4E79"/>
-                    </a:solidFill>
-                  </a:tcPr>
-                </a:tc>
-                <a:tc>
-                  <a:txBody>
-                    <a:bodyPr wrap="square"/>
-                    <a:lstStyle/>
-                    <a:p>
-                      <a:r>
-                        <a:rPr sz="1100" b="1">
-                          <a:solidFill>
-                            <a:srgbClr val="FFFFFF"/>
-                          </a:solidFill>
-                          <a:latin typeface="Arial"/>
-                        </a:rPr>
-                        <a:t>Zernike sensor (measured)</a:t>
+                        <a:t>what it does</a:t>
                       </a:r>
                     </a:p>
                   </a:txBody>
@@ -6461,7 +6704,7 @@
                           </a:solidFill>
                           <a:latin typeface="Arial"/>
                         </a:rPr>
-                        <a:t>reference beam</a:t>
+                        <a:t>zwfs_run</a:t>
                       </a:r>
                     </a:p>
                   </a:txBody>
@@ -6483,103 +6726,13 @@
                           </a:solidFill>
                           <a:latin typeface="Arial"/>
                         </a:rPr>
-                        <a:t>the second arm's flat</a:t>
+                        <a:t>the record: bench checks, the full test set, figures</a:t>
                       </a:r>
                     </a:p>
                   </a:txBody>
                   <a:tcPr marL="54864" marR="54864" marT="18288" marB="18288">
                     <a:solidFill>
                       <a:srgbClr val="FFFFFF"/>
-                    </a:solidFill>
-                  </a:tcPr>
-                </a:tc>
-                <a:tc>
-                  <a:txBody>
-                    <a:bodyPr wrap="square"/>
-                    <a:lstStyle/>
-                    <a:p>
-                      <a:r>
-                        <a:rPr sz="1100" b="0">
-                          <a:solidFill>
-                            <a:srgbClr val="282828"/>
-                          </a:solidFill>
-                          <a:latin typeface="Arial"/>
-                        </a:rPr>
-                        <a:t>made from the beam's own focal core</a:t>
-                      </a:r>
-                    </a:p>
-                  </a:txBody>
-                  <a:tcPr marL="54864" marR="54864" marT="18288" marB="18288">
-                    <a:solidFill>
-                      <a:srgbClr val="FFFFFF"/>
-                    </a:solidFill>
-                  </a:tcPr>
-                </a:tc>
-              </a:tr>
-              <a:tr h="468630">
-                <a:tc>
-                  <a:txBody>
-                    <a:bodyPr wrap="square"/>
-                    <a:lstStyle/>
-                    <a:p>
-                      <a:r>
-                        <a:rPr sz="1100" b="0">
-                          <a:solidFill>
-                            <a:srgbClr val="282828"/>
-                          </a:solidFill>
-                          <a:latin typeface="Arial"/>
-                        </a:rPr>
-                        <a:t>one measurement costs</a:t>
-                      </a:r>
-                    </a:p>
-                  </a:txBody>
-                  <a:tcPr marL="54864" marR="54864" marT="18288" marB="18288">
-                    <a:solidFill>
-                      <a:srgbClr val="ECF1F6"/>
-                    </a:solidFill>
-                  </a:tcPr>
-                </a:tc>
-                <a:tc>
-                  <a:txBody>
-                    <a:bodyPr wrap="square"/>
-                    <a:lstStyle/>
-                    <a:p>
-                      <a:r>
-                        <a:rPr sz="1100" b="0">
-                          <a:solidFill>
-                            <a:srgbClr val="282828"/>
-                          </a:solidFill>
-                          <a:latin typeface="Arial"/>
-                        </a:rPr>
-                        <a:t>6 traces (3 per arm), 4 fringe frames</a:t>
-                      </a:r>
-                    </a:p>
-                  </a:txBody>
-                  <a:tcPr marL="54864" marR="54864" marT="18288" marB="18288">
-                    <a:solidFill>
-                      <a:srgbClr val="ECF1F6"/>
-                    </a:solidFill>
-                  </a:tcPr>
-                </a:tc>
-                <a:tc>
-                  <a:txBody>
-                    <a:bodyPr wrap="square"/>
-                    <a:lstStyle/>
-                    <a:p>
-                      <a:r>
-                        <a:rPr sz="1100" b="0">
-                          <a:solidFill>
-                            <a:srgbClr val="282828"/>
-                          </a:solidFill>
-                          <a:latin typeface="Arial"/>
-                        </a:rPr>
-                        <a:t>1 or 4 camera frames; 256 calibration frames once per working surface</a:t>
-                      </a:r>
-                    </a:p>
-                  </a:txBody>
-                  <a:tcPr marL="54864" marR="54864" marT="18288" marB="18288">
-                    <a:solidFill>
-                      <a:srgbClr val="ECF1F6"/>
                     </a:solidFill>
                   </a:tcPr>
                 </a:tc>
@@ -6597,57 +6750,35 @@
                           </a:solidFill>
                           <a:latin typeface="Arial"/>
                         </a:rPr>
-                        <a:t>polarization hardware</a:t>
-                      </a:r>
-                    </a:p>
-                  </a:txBody>
-                  <a:tcPr marL="54864" marR="54864" marT="18288" marB="18288">
-                    <a:solidFill>
-                      <a:srgbClr val="FFFFFF"/>
-                    </a:solidFill>
-                  </a:tcPr>
-                </a:tc>
-                <a:tc>
-                  <a:txBody>
-                    <a:bodyPr wrap="square"/>
-                    <a:lstStyle/>
-                    <a:p>
-                      <a:r>
-                        <a:rPr sz="1100" b="0">
-                          <a:solidFill>
-                            <a:srgbClr val="282828"/>
-                          </a:solidFill>
-                          <a:latin typeface="Arial"/>
-                        </a:rPr>
-                        <a:t>polarizer, 5 waveplates, analyzer</a:t>
-                      </a:r>
-                    </a:p>
-                  </a:txBody>
-                  <a:tcPr marL="54864" marR="54864" marT="18288" marB="18288">
-                    <a:solidFill>
-                      <a:srgbClr val="FFFFFF"/>
-                    </a:solidFill>
-                  </a:tcPr>
-                </a:tc>
-                <a:tc>
-                  <a:txBody>
-                    <a:bodyPr wrap="square"/>
-                    <a:lstStyle/>
-                    <a:p>
-                      <a:r>
-                        <a:rPr sz="1100" b="0">
-                          <a:solidFill>
-                            <a:srgbClr val="282828"/>
-                          </a:solidFill>
-                          <a:latin typeface="Arial"/>
-                        </a:rPr>
-                        <a:t>none</a:t>
-                      </a:r>
-                    </a:p>
-                  </a:txBody>
-                  <a:tcPr marL="54864" marR="54864" marT="18288" marB="18288">
-                    <a:solidFill>
-                      <a:srgbClr val="FFFFFF"/>
+                        <a:t>zwfs_run('tag','ng385', 'NGRID',385)</a:t>
+                      </a:r>
+                    </a:p>
+                  </a:txBody>
+                  <a:tcPr marL="54864" marR="54864" marT="18288" marB="18288">
+                    <a:solidFill>
+                      <a:srgbClr val="ECF1F6"/>
+                    </a:solidFill>
+                  </a:tcPr>
+                </a:tc>
+                <a:tc>
+                  <a:txBody>
+                    <a:bodyPr wrap="square"/>
+                    <a:lstStyle/>
+                    <a:p>
+                      <a:r>
+                        <a:rPr sz="1100" b="0">
+                          <a:solidFill>
+                            <a:srgbClr val="282828"/>
+                          </a:solidFill>
+                          <a:latin typeface="Arial"/>
+                        </a:rPr>
+                        <a:t>the 1-megapixel camera</a:t>
+                      </a:r>
+                    </a:p>
+                  </a:txBody>
+                  <a:tcPr marL="54864" marR="54864" marT="18288" marB="18288">
+                    <a:solidFill>
+                      <a:srgbClr val="ECF1F6"/>
                     </a:solidFill>
                   </a:tcPr>
                 </a:tc>
@@ -6665,57 +6796,35 @@
                           </a:solidFill>
                           <a:latin typeface="Arial"/>
                         </a:rPr>
-                        <a:t>moving parts</a:t>
-                      </a:r>
-                    </a:p>
-                  </a:txBody>
-                  <a:tcPr marL="54864" marR="54864" marT="18288" marB="18288">
-                    <a:solidFill>
-                      <a:srgbClr val="ECF1F6"/>
-                    </a:solidFill>
-                  </a:tcPr>
-                </a:tc>
-                <a:tc>
-                  <a:txBody>
-                    <a:bodyPr wrap="square"/>
-                    <a:lstStyle/>
-                    <a:p>
-                      <a:r>
-                        <a:rPr sz="1100" b="0">
-                          <a:solidFill>
-                            <a:srgbClr val="282828"/>
-                          </a:solidFill>
-                          <a:latin typeface="Arial"/>
-                        </a:rPr>
-                        <a:t>none (polarization-stepped)</a:t>
-                      </a:r>
-                    </a:p>
-                  </a:txBody>
-                  <a:tcPr marL="54864" marR="54864" marT="18288" marB="18288">
-                    <a:solidFill>
-                      <a:srgbClr val="ECF1F6"/>
-                    </a:solidFill>
-                  </a:tcPr>
-                </a:tc>
-                <a:tc>
-                  <a:txBody>
-                    <a:bodyPr wrap="square"/>
-                    <a:lstStyle/>
-                    <a:p>
-                      <a:r>
-                        <a:rPr sz="1100" b="0">
-                          <a:solidFill>
-                            <a:srgbClr val="282828"/>
-                          </a:solidFill>
-                          <a:latin typeface="Arial"/>
-                        </a:rPr>
-                        <a:t>none</a:t>
-                      </a:r>
-                    </a:p>
-                  </a:txBody>
-                  <a:tcPr marL="54864" marR="54864" marT="18288" marB="18288">
-                    <a:solidFill>
-                      <a:srgbClr val="ECF1F6"/>
+                        <a:t>zwfs_run('MODEL',2048, 'NGRID',385, 'param_file','macos_param_2048.txt')</a:t>
+                      </a:r>
+                    </a:p>
+                  </a:txBody>
+                  <a:tcPr marL="54864" marR="54864" marT="18288" marB="18288">
+                    <a:solidFill>
+                      <a:srgbClr val="FFFFFF"/>
+                    </a:solidFill>
+                  </a:tcPr>
+                </a:tc>
+                <a:tc>
+                  <a:txBody>
+                    <a:bodyPr wrap="square"/>
+                    <a:lstStyle/>
+                    <a:p>
+                      <a:r>
+                        <a:rPr sz="1100" b="0">
+                          <a:solidFill>
+                            <a:srgbClr val="282828"/>
+                          </a:solidFill>
+                          <a:latin typeface="Arial"/>
+                        </a:rPr>
+                        <a:t>the fully sampled setup on a 30 GB machine</a:t>
+                      </a:r>
+                    </a:p>
+                  </a:txBody>
+                  <a:tcPr marL="54864" marR="54864" marT="18288" marB="18288">
+                    <a:solidFill>
+                      <a:srgbClr val="FFFFFF"/>
                     </a:solidFill>
                   </a:tcPr>
                 </a:tc>
@@ -6733,75 +6842,7 @@
                           </a:solidFill>
                           <a:latin typeface="Arial"/>
                         </a:rPr>
-                        <a:t>null, nothing aligned</a:t>
-                      </a:r>
-                    </a:p>
-                  </a:txBody>
-                  <a:tcPr marL="54864" marR="54864" marT="18288" marB="18288">
-                    <a:solidFill>
-                      <a:srgbClr val="FFFFFF"/>
-                    </a:solidFill>
-                  </a:tcPr>
-                </a:tc>
-                <a:tc>
-                  <a:txBody>
-                    <a:bodyPr wrap="square"/>
-                    <a:lstStyle/>
-                    <a:p>
-                      <a:r>
-                        <a:rPr sz="1100" b="0">
-                          <a:solidFill>
-                            <a:srgbClr val="282828"/>
-                          </a:solidFill>
-                          <a:latin typeface="Arial"/>
-                        </a:rPr>
-                        <a:t>0.134 nm</a:t>
-                      </a:r>
-                    </a:p>
-                  </a:txBody>
-                  <a:tcPr marL="54864" marR="54864" marT="18288" marB="18288">
-                    <a:solidFill>
-                      <a:srgbClr val="FFFFFF"/>
-                    </a:solidFill>
-                  </a:tcPr>
-                </a:tc>
-                <a:tc>
-                  <a:txBody>
-                    <a:bodyPr wrap="square"/>
-                    <a:lstStyle/>
-                    <a:p>
-                      <a:r>
-                        <a:rPr sz="1100" b="0">
-                          <a:solidFill>
-                            <a:srgbClr val="282828"/>
-                          </a:solidFill>
-                          <a:latin typeface="Arial"/>
-                        </a:rPr>
-                        <a:t>0 by construction (the flat is the reference)</a:t>
-                      </a:r>
-                    </a:p>
-                  </a:txBody>
-                  <a:tcPr marL="54864" marR="54864" marT="18288" marB="18288">
-                    <a:solidFill>
-                      <a:srgbClr val="FFFFFF"/>
-                    </a:solidFill>
-                  </a:tcPr>
-                </a:tc>
-              </a:tr>
-              <a:tr h="468630">
-                <a:tc>
-                  <a:txBody>
-                    <a:bodyPr wrap="square"/>
-                    <a:lstStyle/>
-                    <a:p>
-                      <a:r>
-                        <a:rPr sz="1100" b="0">
-                          <a:solidFill>
-                            <a:srgbClr val="282828"/>
-                          </a:solidFill>
-                          <a:latin typeface="Arial"/>
-                        </a:rPr>
-                        <a:t>response falls off at</a:t>
+                        <a:t>zwfs_run('stages',{'battery','color','noise','figs'})</a:t>
                       </a:r>
                     </a:p>
                   </a:txBody>
@@ -6823,29 +6864,7 @@
                           </a:solidFill>
                           <a:latin typeface="Arial"/>
                         </a:rPr>
-                        <a:t>fine patterns: 0.50 at the 96×96 checkerboard</a:t>
-                      </a:r>
-                    </a:p>
-                  </a:txBody>
-                  <a:tcPr marL="54864" marR="54864" marT="18288" marB="18288">
-                    <a:solidFill>
-                      <a:srgbClr val="ECF1F6"/>
-                    </a:solidFill>
-                  </a:tcPr>
-                </a:tc>
-                <a:tc>
-                  <a:txBody>
-                    <a:bodyPr wrap="square"/>
-                    <a:lstStyle/>
-                    <a:p>
-                      <a:r>
-                        <a:rPr sz="1100" b="0">
-                          <a:solidFill>
-                            <a:srgbClr val="282828"/>
-                          </a:solidFill>
-                          <a:latin typeface="Arial"/>
-                        </a:rPr>
-                        <a:t>0.5 to 1 cycle across the pupil (0.5 at 1); piston unseen</a:t>
+                        <a:t>everything on this deck's later slides</a:t>
                       </a:r>
                     </a:p>
                   </a:txBody>
@@ -6869,7 +6888,7 @@
                           </a:solidFill>
                           <a:latin typeface="Arial"/>
                         </a:rPr>
-                        <a:t>working surface it can handle</a:t>
+                        <a:t>./zwfs_batch.sh TAG "the same arguments"</a:t>
                       </a:r>
                     </a:p>
                   </a:txBody>
@@ -6891,165 +6910,7 @@
                           </a:solidFill>
                           <a:latin typeface="Arial"/>
                         </a:rPr>
-                        <a:t>480 nm rms and beyond</a:t>
-                      </a:r>
-                    </a:p>
-                  </a:txBody>
-                  <a:tcPr marL="54864" marR="54864" marT="18288" marB="18288">
-                    <a:solidFill>
-                      <a:srgbClr val="FFFFFF"/>
-                    </a:solidFill>
-                  </a:tcPr>
-                </a:tc>
-                <a:tc>
-                  <a:txBody>
-                    <a:bodyPr wrap="square"/>
-                    <a:lstStyle/>
-                    <a:p>
-                      <a:r>
-                        <a:rPr sz="1100" b="0">
-                          <a:solidFill>
-                            <a:srgbClr val="282828"/>
-                          </a:solidFill>
-                          <a:latin typeface="Arial"/>
-                        </a:rPr>
-                        <a:t>40 nm rms one-frame (1 mm actuators), 50–60 nm four-frame</a:t>
-                      </a:r>
-                    </a:p>
-                  </a:txBody>
-                  <a:tcPr marL="54864" marR="54864" marT="18288" marB="18288">
-                    <a:solidFill>
-                      <a:srgbClr val="FFFFFF"/>
-                    </a:solidFill>
-                  </a:tcPr>
-                </a:tc>
-              </a:tr>
-              <a:tr h="468630">
-                <a:tc>
-                  <a:txBody>
-                    <a:bodyPr wrap="square"/>
-                    <a:lstStyle/>
-                    <a:p>
-                      <a:r>
-                        <a:rPr sz="1100" b="0">
-                          <a:solidFill>
-                            <a:srgbClr val="282828"/>
-                          </a:solidFill>
-                          <a:latin typeface="Arial"/>
-                        </a:rPr>
-                        <a:t>a 10 nm actuator change on a 30 nm surface</a:t>
-                      </a:r>
-                    </a:p>
-                  </a:txBody>
-                  <a:tcPr marL="54864" marR="54864" marT="18288" marB="18288">
-                    <a:solidFill>
-                      <a:srgbClr val="ECF1F6"/>
-                    </a:solidFill>
-                  </a:tcPr>
-                </a:tc>
-                <a:tc>
-                  <a:txBody>
-                    <a:bodyPr wrap="square"/>
-                    <a:lstStyle/>
-                    <a:p>
-                      <a:r>
-                        <a:rPr sz="1100" b="0">
-                          <a:solidFill>
-                            <a:srgbClr val="282828"/>
-                          </a:solidFill>
-                          <a:latin typeface="Arial"/>
-                        </a:rPr>
-                        <a:t>gain 0.92, floor 46 pm</a:t>
-                      </a:r>
-                    </a:p>
-                  </a:txBody>
-                  <a:tcPr marL="54864" marR="54864" marT="18288" marB="18288">
-                    <a:solidFill>
-                      <a:srgbClr val="ECF1F6"/>
-                    </a:solidFill>
-                  </a:tcPr>
-                </a:tc>
-                <a:tc>
-                  <a:txBody>
-                    <a:bodyPr wrap="square"/>
-                    <a:lstStyle/>
-                    <a:p>
-                      <a:r>
-                        <a:rPr sz="1100" b="0">
-                          <a:solidFill>
-                            <a:srgbClr val="282828"/>
-                          </a:solidFill>
-                          <a:latin typeface="Arial"/>
-                        </a:rPr>
-                        <a:t>gain 0.99, floor 5 pm (stepped, four frames; matrix on the surface) — gain 1.05, floor 23 pm (linear, one frame)</a:t>
-                      </a:r>
-                    </a:p>
-                  </a:txBody>
-                  <a:tcPr marL="54864" marR="54864" marT="18288" marB="18288">
-                    <a:solidFill>
-                      <a:srgbClr val="ECF1F6"/>
-                    </a:solidFill>
-                  </a:tcPr>
-                </a:tc>
-              </a:tr>
-              <a:tr h="280035">
-                <a:tc>
-                  <a:txBody>
-                    <a:bodyPr wrap="square"/>
-                    <a:lstStyle/>
-                    <a:p>
-                      <a:r>
-                        <a:rPr sz="1100" b="0">
-                          <a:solidFill>
-                            <a:srgbClr val="282828"/>
-                          </a:solidFill>
-                          <a:latin typeface="Arial"/>
-                        </a:rPr>
-                        <a:t>photons per state for 1 pm</a:t>
-                      </a:r>
-                    </a:p>
-                  </a:txBody>
-                  <a:tcPr marL="54864" marR="54864" marT="18288" marB="18288">
-                    <a:solidFill>
-                      <a:srgbClr val="FFFFFF"/>
-                    </a:solidFill>
-                  </a:tcPr>
-                </a:tc>
-                <a:tc>
-                  <a:txBody>
-                    <a:bodyPr wrap="square"/>
-                    <a:lstStyle/>
-                    <a:p>
-                      <a:r>
-                        <a:rPr sz="1100" b="0">
-                          <a:solidFill>
-                            <a:srgbClr val="282828"/>
-                          </a:solidFill>
-                          <a:latin typeface="Arial"/>
-                        </a:rPr>
-                        <a:t>8×10¹⁴</a:t>
-                      </a:r>
-                    </a:p>
-                  </a:txBody>
-                  <a:tcPr marL="54864" marR="54864" marT="18288" marB="18288">
-                    <a:solidFill>
-                      <a:srgbClr val="FFFFFF"/>
-                    </a:solidFill>
-                  </a:tcPr>
-                </a:tc>
-                <a:tc>
-                  <a:txBody>
-                    <a:bodyPr wrap="square"/>
-                    <a:lstStyle/>
-                    <a:p>
-                      <a:r>
-                        <a:rPr sz="1100" b="0">
-                          <a:solidFill>
-                            <a:srgbClr val="282828"/>
-                          </a:solidFill>
-                          <a:latin typeface="Arial"/>
-                        </a:rPr>
-                        <a:t>0.4 to 1×10¹⁴</a:t>
+                        <a:t>unattended, memory-capped, logged</a:t>
                       </a:r>
                     </a:p>
                   </a:txBody>
@@ -7066,13 +6927,13 @@
       </p:graphicFrame>
       <p:sp>
         <p:nvSpPr>
-          <p:cNvPr id="5" name="TextBox 4"/>
+          <p:cNvPr id="6" name="TextBox 5"/>
           <p:cNvSpPr txBox="1"/>
           <p:nvPr/>
         </p:nvSpPr>
         <p:spPr>
           <a:xfrm>
-            <a:off x="411480" y="4810887"/>
+            <a:off x="411480" y="4292346"/>
             <a:ext cx="11368735" cy="274320"/>
           </a:xfrm>
           <a:prstGeom prst="rect">
@@ -7098,20 +6959,20 @@
                 </a:solidFill>
                 <a:latin typeface="Arial"/>
               </a:rPr>
-              <a:t>•  Reading: the interferometer measures any surface and pays at fine patterns; the sensor measures small changes on a small working surface more cheaply — no polarization train, a floor ten times lower once its response matrix is measured on that surface — and pays at the lowest spatial frequencies and in the surface it can handle.</a:t>
-            </a:r>
-          </a:p>
-        </p:txBody>
-      </p:sp>
-      <p:sp>
-        <p:nvSpPr>
-          <p:cNvPr id="6" name="TextBox 5"/>
+              <a:t>•  Checks that run every time: the no-mask round trip through the bracket (must return the field unchanged); the reference-wave model against the engine's own field; the pupil brightness must not change with the DM shape; the sampling checks (pixels across the dimple, camera pixels per actuator); and the search for the camera-to-DM mirror/transpose and sign.</a:t>
+            </a:r>
+          </a:p>
+        </p:txBody>
+      </p:sp>
+      <p:sp>
+        <p:nvSpPr>
+          <p:cNvPr id="7" name="TextBox 6"/>
           <p:cNvSpPr txBox="1"/>
           <p:nvPr/>
         </p:nvSpPr>
         <p:spPr>
           <a:xfrm>
-            <a:off x="411480" y="5730621"/>
+            <a:off x="411480" y="5459730"/>
             <a:ext cx="11368735" cy="274320"/>
           </a:xfrm>
           <a:prstGeom prst="rect">
@@ -7137,7 +6998,7 @@
                 </a:solidFill>
                 <a:latin typeface="Arial"/>
               </a:rPr>
-              <a:t>PSI column: tg_psi_dm96 run 10 and S4/S5; sensor column: 385 rays, matrix calibration on the working surface (slide 10), photons at development sampling.  Both in actuator units through the same code (dm_gauge_lib).</a:t>
+              <a:t>Reproduction check: 64 lines of results against the stage-7 report, 8 differ in the last printed digit (the actuator fit's solver tolerance).  README "Run it yourself" carries the parameter table.</a:t>
             </a:r>
           </a:p>
         </p:txBody>
@@ -7194,7 +7055,7 @@
                 </a:solidFill>
                 <a:latin typeface="Arial"/>
               </a:rPr>
-              <a:t>What the Zernike-sensor literature offers, in priority order</a:t>
+              <a:t>Side by side with the Twyman–Green</a:t>
             </a:r>
           </a:p>
           <a:p>
@@ -7210,7 +7071,7 @@
                 </a:solidFill>
                 <a:latin typeface="Arial"/>
               </a:rPr>
-              <a:t>Twelve papers read; the first import — re-computing the reference wave — is now built and measured (slide 8)</a:t>
+              <a:t>The interferometer loses response at fine patterns and never fails; the sensor, calibrated on its working surface, reads a change to 5 pm up to 50–60 nm</a:t>
             </a:r>
           </a:p>
         </p:txBody>
@@ -7269,7 +7130,7 @@
         </p:nvGraphicFramePr>
         <p:xfrm>
           <a:off x="411480" y="1298448"/>
-          <a:ext cx="11368734" cy="3091815"/>
+          <a:ext cx="11368733" cy="4023360"/>
         </p:xfrm>
         <a:graphic>
           <a:graphicData uri="http://schemas.openxmlformats.org/drawingml/2006/table">
@@ -7278,15 +7139,27 @@
                 <a:tableStyleId>{5C22544A-7EE6-4342-B048-85BDC9FD1C3A}</a:tableStyleId>
               </a:tblPr>
               <a:tblGrid>
-                <a:gridCol w="218948"/>
-                <a:gridCol w="2691327"/>
-                <a:gridCol w="8458459"/>
+                <a:gridCol w="3608337"/>
+                <a:gridCol w="2224317"/>
+                <a:gridCol w="5536079"/>
               </a:tblGrid>
               <a:tr h="280035">
                 <a:tc>
                   <a:txBody>
                     <a:bodyPr wrap="square"/>
                     <a:lstStyle/>
+                    <a:p/>
+                  </a:txBody>
+                  <a:tcPr marL="54864" marR="54864" marT="18288" marB="18288">
+                    <a:solidFill>
+                      <a:srgbClr val="1F4E79"/>
+                    </a:solidFill>
+                  </a:tcPr>
+                </a:tc>
+                <a:tc>
+                  <a:txBody>
+                    <a:bodyPr wrap="square"/>
+                    <a:lstStyle/>
                     <a:p>
                       <a:r>
                         <a:rPr sz="1100" b="1">
@@ -7295,7 +7168,7 @@
                           </a:solidFill>
                           <a:latin typeface="Arial"/>
                         </a:rPr>
-                        <a:t>#</a:t>
+                        <a:t>Twyman–Green PSI (measured)</a:t>
                       </a:r>
                     </a:p>
                   </a:txBody>
@@ -7317,7 +7190,7 @@
                           </a:solidFill>
                           <a:latin typeface="Arial"/>
                         </a:rPr>
-                        <a:t>paper</a:t>
+                        <a:t>Zernike sensor (measured)</a:t>
                       </a:r>
                     </a:p>
                   </a:txBody>
@@ -7327,25 +7200,71 @@
                     </a:solidFill>
                   </a:tcPr>
                 </a:tc>
-                <a:tc>
-                  <a:txBody>
-                    <a:bodyPr wrap="square"/>
-                    <a:lstStyle/>
-                    <a:p>
-                      <a:r>
-                        <a:rPr sz="1100" b="1">
-                          <a:solidFill>
-                            <a:srgbClr val="FFFFFF"/>
-                          </a:solidFill>
-                          <a:latin typeface="Arial"/>
-                        </a:rPr>
-                        <a:t>what it gives this model</a:t>
-                      </a:r>
-                    </a:p>
-                  </a:txBody>
-                  <a:tcPr marL="54864" marR="54864" marT="18288" marB="18288">
-                    <a:solidFill>
-                      <a:srgbClr val="1F4E79"/>
+              </a:tr>
+              <a:tr h="280035">
+                <a:tc>
+                  <a:txBody>
+                    <a:bodyPr wrap="square"/>
+                    <a:lstStyle/>
+                    <a:p>
+                      <a:r>
+                        <a:rPr sz="1100" b="0">
+                          <a:solidFill>
+                            <a:srgbClr val="282828"/>
+                          </a:solidFill>
+                          <a:latin typeface="Arial"/>
+                        </a:rPr>
+                        <a:t>reference beam</a:t>
+                      </a:r>
+                    </a:p>
+                  </a:txBody>
+                  <a:tcPr marL="54864" marR="54864" marT="18288" marB="18288">
+                    <a:solidFill>
+                      <a:srgbClr val="FFFFFF"/>
+                    </a:solidFill>
+                  </a:tcPr>
+                </a:tc>
+                <a:tc>
+                  <a:txBody>
+                    <a:bodyPr wrap="square"/>
+                    <a:lstStyle/>
+                    <a:p>
+                      <a:r>
+                        <a:rPr sz="1100" b="0">
+                          <a:solidFill>
+                            <a:srgbClr val="282828"/>
+                          </a:solidFill>
+                          <a:latin typeface="Arial"/>
+                        </a:rPr>
+                        <a:t>the second arm's flat</a:t>
+                      </a:r>
+                    </a:p>
+                  </a:txBody>
+                  <a:tcPr marL="54864" marR="54864" marT="18288" marB="18288">
+                    <a:solidFill>
+                      <a:srgbClr val="FFFFFF"/>
+                    </a:solidFill>
+                  </a:tcPr>
+                </a:tc>
+                <a:tc>
+                  <a:txBody>
+                    <a:bodyPr wrap="square"/>
+                    <a:lstStyle/>
+                    <a:p>
+                      <a:r>
+                        <a:rPr sz="1100" b="0">
+                          <a:solidFill>
+                            <a:srgbClr val="282828"/>
+                          </a:solidFill>
+                          <a:latin typeface="Arial"/>
+                        </a:rPr>
+                        <a:t>made from the beam's own focal core</a:t>
+                      </a:r>
+                    </a:p>
+                  </a:txBody>
+                  <a:tcPr marL="54864" marR="54864" marT="18288" marB="18288">
+                    <a:solidFill>
+                      <a:srgbClr val="FFFFFF"/>
                     </a:solidFill>
                   </a:tcPr>
                 </a:tc>
@@ -7363,57 +7282,57 @@
                           </a:solidFill>
                           <a:latin typeface="Arial"/>
                         </a:rPr>
-                        <a:t>1</a:t>
-                      </a:r>
-                    </a:p>
-                  </a:txBody>
-                  <a:tcPr marL="54864" marR="54864" marT="18288" marB="18288">
-                    <a:solidFill>
-                      <a:srgbClr val="FFFFFF"/>
-                    </a:solidFill>
-                  </a:tcPr>
-                </a:tc>
-                <a:tc>
-                  <a:txBody>
-                    <a:bodyPr wrap="square"/>
-                    <a:lstStyle/>
-                    <a:p>
-                      <a:r>
-                        <a:rPr sz="1100" b="0">
-                          <a:solidFill>
-                            <a:srgbClr val="282828"/>
-                          </a:solidFill>
-                          <a:latin typeface="Arial"/>
-                        </a:rPr>
-                        <a:t>Ruane, Wallace, Steeves et al. 2020, JATIS 6, 045005</a:t>
-                      </a:r>
-                    </a:p>
-                  </a:txBody>
-                  <a:tcPr marL="54864" marR="54864" marT="18288" marB="18288">
-                    <a:solidFill>
-                      <a:srgbClr val="FFFFFF"/>
-                    </a:solidFill>
-                  </a:tcPr>
-                </a:tc>
-                <a:tc>
-                  <a:txBody>
-                    <a:bodyPr wrap="square"/>
-                    <a:lstStyle/>
-                    <a:p>
-                      <a:r>
-                        <a:rPr sz="1100" b="0">
-                          <a:solidFill>
-                            <a:srgbClr val="282828"/>
-                          </a:solidFill>
-                          <a:latin typeface="Arial"/>
-                        </a:rPr>
-                        <a:t>Exact per-pixel reconstruction from the pupil amplitude, the reference wave b and the masked image; a sensitivity factor per pixel; a four-term systematic budget; 1 pm reached at 4.4×10⁵ frames; no loss to 25 % bandwidth</a:t>
-                      </a:r>
-                    </a:p>
-                  </a:txBody>
-                  <a:tcPr marL="54864" marR="54864" marT="18288" marB="18288">
-                    <a:solidFill>
-                      <a:srgbClr val="FFFFFF"/>
+                        <a:t>one measurement costs</a:t>
+                      </a:r>
+                    </a:p>
+                  </a:txBody>
+                  <a:tcPr marL="54864" marR="54864" marT="18288" marB="18288">
+                    <a:solidFill>
+                      <a:srgbClr val="ECF1F6"/>
+                    </a:solidFill>
+                  </a:tcPr>
+                </a:tc>
+                <a:tc>
+                  <a:txBody>
+                    <a:bodyPr wrap="square"/>
+                    <a:lstStyle/>
+                    <a:p>
+                      <a:r>
+                        <a:rPr sz="1100" b="0">
+                          <a:solidFill>
+                            <a:srgbClr val="282828"/>
+                          </a:solidFill>
+                          <a:latin typeface="Arial"/>
+                        </a:rPr>
+                        <a:t>6 traces (3 per arm), 4 fringe frames</a:t>
+                      </a:r>
+                    </a:p>
+                  </a:txBody>
+                  <a:tcPr marL="54864" marR="54864" marT="18288" marB="18288">
+                    <a:solidFill>
+                      <a:srgbClr val="ECF1F6"/>
+                    </a:solidFill>
+                  </a:tcPr>
+                </a:tc>
+                <a:tc>
+                  <a:txBody>
+                    <a:bodyPr wrap="square"/>
+                    <a:lstStyle/>
+                    <a:p>
+                      <a:r>
+                        <a:rPr sz="1100" b="0">
+                          <a:solidFill>
+                            <a:srgbClr val="282828"/>
+                          </a:solidFill>
+                          <a:latin typeface="Arial"/>
+                        </a:rPr>
+                        <a:t>1 or 4 camera frames; 256 calibration frames once per working surface</a:t>
+                      </a:r>
+                    </a:p>
+                  </a:txBody>
+                  <a:tcPr marL="54864" marR="54864" marT="18288" marB="18288">
+                    <a:solidFill>
+                      <a:srgbClr val="ECF1F6"/>
                     </a:solidFill>
                   </a:tcPr>
                 </a:tc>
@@ -7431,7 +7350,75 @@
                           </a:solidFill>
                           <a:latin typeface="Arial"/>
                         </a:rPr>
-                        <a:t>2</a:t>
+                        <a:t>polarization hardware</a:t>
+                      </a:r>
+                    </a:p>
+                  </a:txBody>
+                  <a:tcPr marL="54864" marR="54864" marT="18288" marB="18288">
+                    <a:solidFill>
+                      <a:srgbClr val="FFFFFF"/>
+                    </a:solidFill>
+                  </a:tcPr>
+                </a:tc>
+                <a:tc>
+                  <a:txBody>
+                    <a:bodyPr wrap="square"/>
+                    <a:lstStyle/>
+                    <a:p>
+                      <a:r>
+                        <a:rPr sz="1100" b="0">
+                          <a:solidFill>
+                            <a:srgbClr val="282828"/>
+                          </a:solidFill>
+                          <a:latin typeface="Arial"/>
+                        </a:rPr>
+                        <a:t>polarizer, 5 waveplates, analyzer</a:t>
+                      </a:r>
+                    </a:p>
+                  </a:txBody>
+                  <a:tcPr marL="54864" marR="54864" marT="18288" marB="18288">
+                    <a:solidFill>
+                      <a:srgbClr val="FFFFFF"/>
+                    </a:solidFill>
+                  </a:tcPr>
+                </a:tc>
+                <a:tc>
+                  <a:txBody>
+                    <a:bodyPr wrap="square"/>
+                    <a:lstStyle/>
+                    <a:p>
+                      <a:r>
+                        <a:rPr sz="1100" b="0">
+                          <a:solidFill>
+                            <a:srgbClr val="282828"/>
+                          </a:solidFill>
+                          <a:latin typeface="Arial"/>
+                        </a:rPr>
+                        <a:t>none</a:t>
+                      </a:r>
+                    </a:p>
+                  </a:txBody>
+                  <a:tcPr marL="54864" marR="54864" marT="18288" marB="18288">
+                    <a:solidFill>
+                      <a:srgbClr val="FFFFFF"/>
+                    </a:solidFill>
+                  </a:tcPr>
+                </a:tc>
+              </a:tr>
+              <a:tr h="280035">
+                <a:tc>
+                  <a:txBody>
+                    <a:bodyPr wrap="square"/>
+                    <a:lstStyle/>
+                    <a:p>
+                      <a:r>
+                        <a:rPr sz="1100" b="0">
+                          <a:solidFill>
+                            <a:srgbClr val="282828"/>
+                          </a:solidFill>
+                          <a:latin typeface="Arial"/>
+                        </a:rPr>
+                        <a:t>moving parts</a:t>
                       </a:r>
                     </a:p>
                   </a:txBody>
@@ -7453,7 +7440,7 @@
                           </a:solidFill>
                           <a:latin typeface="Arial"/>
                         </a:rPr>
-                        <a:t>Doelman, Fagginger Auer, Escuti, Snik 2019, Opt. Lett. 44, 17</a:t>
+                        <a:t>none (polarization-stepped)</a:t>
                       </a:r>
                     </a:p>
                   </a:txBody>
@@ -7475,13 +7462,81 @@
                           </a:solidFill>
                           <a:latin typeface="Arial"/>
                         </a:rPr>
-                        <a:t>Vector Zernike: ±π/2 on opposite circular polarizations gives two pupil images, an exact phase-and-amplitude solution, an iterated b, achromatic to 100 % bandwidth; the leakage terms are written down</a:t>
+                        <a:t>none</a:t>
                       </a:r>
                     </a:p>
                   </a:txBody>
                   <a:tcPr marL="54864" marR="54864" marT="18288" marB="18288">
                     <a:solidFill>
                       <a:srgbClr val="ECF1F6"/>
+                    </a:solidFill>
+                  </a:tcPr>
+                </a:tc>
+              </a:tr>
+              <a:tr h="280035">
+                <a:tc>
+                  <a:txBody>
+                    <a:bodyPr wrap="square"/>
+                    <a:lstStyle/>
+                    <a:p>
+                      <a:r>
+                        <a:rPr sz="1100" b="0">
+                          <a:solidFill>
+                            <a:srgbClr val="282828"/>
+                          </a:solidFill>
+                          <a:latin typeface="Arial"/>
+                        </a:rPr>
+                        <a:t>null, nothing aligned</a:t>
+                      </a:r>
+                    </a:p>
+                  </a:txBody>
+                  <a:tcPr marL="54864" marR="54864" marT="18288" marB="18288">
+                    <a:solidFill>
+                      <a:srgbClr val="FFFFFF"/>
+                    </a:solidFill>
+                  </a:tcPr>
+                </a:tc>
+                <a:tc>
+                  <a:txBody>
+                    <a:bodyPr wrap="square"/>
+                    <a:lstStyle/>
+                    <a:p>
+                      <a:r>
+                        <a:rPr sz="1100" b="0">
+                          <a:solidFill>
+                            <a:srgbClr val="282828"/>
+                          </a:solidFill>
+                          <a:latin typeface="Arial"/>
+                        </a:rPr>
+                        <a:t>0.134 nm</a:t>
+                      </a:r>
+                    </a:p>
+                  </a:txBody>
+                  <a:tcPr marL="54864" marR="54864" marT="18288" marB="18288">
+                    <a:solidFill>
+                      <a:srgbClr val="FFFFFF"/>
+                    </a:solidFill>
+                  </a:tcPr>
+                </a:tc>
+                <a:tc>
+                  <a:txBody>
+                    <a:bodyPr wrap="square"/>
+                    <a:lstStyle/>
+                    <a:p>
+                      <a:r>
+                        <a:rPr sz="1100" b="0">
+                          <a:solidFill>
+                            <a:srgbClr val="282828"/>
+                          </a:solidFill>
+                          <a:latin typeface="Arial"/>
+                        </a:rPr>
+                        <a:t>0 by construction (the flat is the reference)</a:t>
+                      </a:r>
+                    </a:p>
+                  </a:txBody>
+                  <a:tcPr marL="54864" marR="54864" marT="18288" marB="18288">
+                    <a:solidFill>
+                      <a:srgbClr val="FFFFFF"/>
                     </a:solidFill>
                   </a:tcPr>
                 </a:tc>
@@ -7499,7 +7554,75 @@
                           </a:solidFill>
                           <a:latin typeface="Arial"/>
                         </a:rPr>
-                        <a:t>3</a:t>
+                        <a:t>response falls off at</a:t>
+                      </a:r>
+                    </a:p>
+                  </a:txBody>
+                  <a:tcPr marL="54864" marR="54864" marT="18288" marB="18288">
+                    <a:solidFill>
+                      <a:srgbClr val="ECF1F6"/>
+                    </a:solidFill>
+                  </a:tcPr>
+                </a:tc>
+                <a:tc>
+                  <a:txBody>
+                    <a:bodyPr wrap="square"/>
+                    <a:lstStyle/>
+                    <a:p>
+                      <a:r>
+                        <a:rPr sz="1100" b="0">
+                          <a:solidFill>
+                            <a:srgbClr val="282828"/>
+                          </a:solidFill>
+                          <a:latin typeface="Arial"/>
+                        </a:rPr>
+                        <a:t>fine patterns: 0.50 at the 96×96 checkerboard</a:t>
+                      </a:r>
+                    </a:p>
+                  </a:txBody>
+                  <a:tcPr marL="54864" marR="54864" marT="18288" marB="18288">
+                    <a:solidFill>
+                      <a:srgbClr val="ECF1F6"/>
+                    </a:solidFill>
+                  </a:tcPr>
+                </a:tc>
+                <a:tc>
+                  <a:txBody>
+                    <a:bodyPr wrap="square"/>
+                    <a:lstStyle/>
+                    <a:p>
+                      <a:r>
+                        <a:rPr sz="1100" b="0">
+                          <a:solidFill>
+                            <a:srgbClr val="282828"/>
+                          </a:solidFill>
+                          <a:latin typeface="Arial"/>
+                        </a:rPr>
+                        <a:t>0.5 to 1 cycle across the pupil (0.5 at 1); piston unseen</a:t>
+                      </a:r>
+                    </a:p>
+                  </a:txBody>
+                  <a:tcPr marL="54864" marR="54864" marT="18288" marB="18288">
+                    <a:solidFill>
+                      <a:srgbClr val="ECF1F6"/>
+                    </a:solidFill>
+                  </a:tcPr>
+                </a:tc>
+              </a:tr>
+              <a:tr h="280035">
+                <a:tc>
+                  <a:txBody>
+                    <a:bodyPr wrap="square"/>
+                    <a:lstStyle/>
+                    <a:p>
+                      <a:r>
+                        <a:rPr sz="1100" b="0">
+                          <a:solidFill>
+                            <a:srgbClr val="282828"/>
+                          </a:solidFill>
+                          <a:latin typeface="Arial"/>
+                        </a:rPr>
+                        <a:t>working surface it can handle</a:t>
                       </a:r>
                     </a:p>
                   </a:txBody>
@@ -7521,7 +7644,7 @@
                           </a:solidFill>
                           <a:latin typeface="Arial"/>
                         </a:rPr>
-                        <a:t>N'Diaye, Vigan, Dohlen et al. 2016, A&amp;A 592, A79 (ZELDA II)</a:t>
+                        <a:t>480 nm rms and beyond</a:t>
                       </a:r>
                     </a:p>
                   </a:txBody>
@@ -7543,7 +7666,7 @@
                           </a:solidFill>
                           <a:latin typeface="Arial"/>
                         </a:rPr>
-                        <a:t>Second-order reconstruction with b from the mask model; 1.06 λ/D at π/2; range −0.14 to +0.36 λ; the sensitivity factor drifts 10 % day to day on SPHERE</a:t>
+                        <a:t>40 nm rms one-frame (1 mm actuators), 50–60 nm four-frame</a:t>
                       </a:r>
                     </a:p>
                   </a:txBody>
@@ -7567,7 +7690,7 @@
                           </a:solidFill>
                           <a:latin typeface="Arial"/>
                         </a:rPr>
-                        <a:t>4</a:t>
+                        <a:t>a 10 nm actuator change on a 30 nm surface</a:t>
                       </a:r>
                     </a:p>
                   </a:txBody>
@@ -7589,7 +7712,7 @@
                           </a:solidFill>
                           <a:latin typeface="Arial"/>
                         </a:rPr>
-                        <a:t>Chambouleyron, Cissé, Salama, Haffert, Wallace et al. 2024, SPIE 13097</a:t>
+                        <a:t>gain 0.92, floor 46 pm</a:t>
                       </a:r>
                     </a:p>
                   </a:txBody>
@@ -7611,13 +7734,81 @@
                           </a:solidFill>
                           <a:latin typeface="Arial"/>
                         </a:rPr>
-                        <a:t>A phase-shifted pair (±π/2) yields cos φ and sin φ; iterative reconstructors reach about 1 rad rms; the bench limits were polarization crosstalk and defocus between the two pupils</a:t>
+                        <a:t>gain 0.99, floor 5 pm (stepped, four frames; matrix on the surface) — gain 1.05, floor 23 pm (linear, one frame)</a:t>
                       </a:r>
                     </a:p>
                   </a:txBody>
                   <a:tcPr marL="54864" marR="54864" marT="18288" marB="18288">
                     <a:solidFill>
                       <a:srgbClr val="ECF1F6"/>
+                    </a:solidFill>
+                  </a:tcPr>
+                </a:tc>
+              </a:tr>
+              <a:tr h="280035">
+                <a:tc>
+                  <a:txBody>
+                    <a:bodyPr wrap="square"/>
+                    <a:lstStyle/>
+                    <a:p>
+                      <a:r>
+                        <a:rPr sz="1100" b="0">
+                          <a:solidFill>
+                            <a:srgbClr val="282828"/>
+                          </a:solidFill>
+                          <a:latin typeface="Arial"/>
+                        </a:rPr>
+                        <a:t>photons per state for 1 pm</a:t>
+                      </a:r>
+                    </a:p>
+                  </a:txBody>
+                  <a:tcPr marL="54864" marR="54864" marT="18288" marB="18288">
+                    <a:solidFill>
+                      <a:srgbClr val="FFFFFF"/>
+                    </a:solidFill>
+                  </a:tcPr>
+                </a:tc>
+                <a:tc>
+                  <a:txBody>
+                    <a:bodyPr wrap="square"/>
+                    <a:lstStyle/>
+                    <a:p>
+                      <a:r>
+                        <a:rPr sz="1100" b="0">
+                          <a:solidFill>
+                            <a:srgbClr val="282828"/>
+                          </a:solidFill>
+                          <a:latin typeface="Arial"/>
+                        </a:rPr>
+                        <a:t>8×10¹⁴</a:t>
+                      </a:r>
+                    </a:p>
+                  </a:txBody>
+                  <a:tcPr marL="54864" marR="54864" marT="18288" marB="18288">
+                    <a:solidFill>
+                      <a:srgbClr val="FFFFFF"/>
+                    </a:solidFill>
+                  </a:tcPr>
+                </a:tc>
+                <a:tc>
+                  <a:txBody>
+                    <a:bodyPr wrap="square"/>
+                    <a:lstStyle/>
+                    <a:p>
+                      <a:r>
+                        <a:rPr sz="1100" b="0">
+                          <a:solidFill>
+                            <a:srgbClr val="282828"/>
+                          </a:solidFill>
+                          <a:latin typeface="Arial"/>
+                        </a:rPr>
+                        <a:t>0.4 to 1×10¹⁴</a:t>
+                      </a:r>
+                    </a:p>
+                  </a:txBody>
+                  <a:tcPr marL="54864" marR="54864" marT="18288" marB="18288">
+                    <a:solidFill>
+                      <a:srgbClr val="FFFFFF"/>
                     </a:solidFill>
                   </a:tcPr>
                 </a:tc>
@@ -7635,75 +7826,7 @@
                           </a:solidFill>
                           <a:latin typeface="Arial"/>
                         </a:rPr>
-                        <a:t>5</a:t>
-                      </a:r>
-                    </a:p>
-                  </a:txBody>
-                  <a:tcPr marL="54864" marR="54864" marT="18288" marB="18288">
-                    <a:solidFill>
-                      <a:srgbClr val="FFFFFF"/>
-                    </a:solidFill>
-                  </a:tcPr>
-                </a:tc>
-                <a:tc>
-                  <a:txBody>
-                    <a:bodyPr wrap="square"/>
-                    <a:lstStyle/>
-                    <a:p>
-                      <a:r>
-                        <a:rPr sz="1100" b="0">
-                          <a:solidFill>
-                            <a:srgbClr val="282828"/>
-                          </a:solidFill>
-                          <a:latin typeface="Arial"/>
-                        </a:rPr>
-                        <a:t>Haffert 2024, A&amp;A 683, A113</a:t>
-                      </a:r>
-                    </a:p>
-                  </a:txBody>
-                  <a:tcPr marL="54864" marR="54864" marT="18288" marB="18288">
-                    <a:solidFill>
-                      <a:srgbClr val="FFFFFF"/>
-                    </a:solidFill>
-                  </a:tcPr>
-                </a:tc>
-                <a:tc>
-                  <a:txBody>
-                    <a:bodyPr wrap="square"/>
-                    <a:lstStyle/>
-                    <a:p>
-                      <a:r>
-                        <a:rPr sz="1100" b="0">
-                          <a:solidFill>
-                            <a:srgbClr val="282828"/>
-                          </a:solidFill>
-                          <a:latin typeface="Arial"/>
-                        </a:rPr>
-                        <a:t>Iterative nonlinear reconstructors reach machine precision below 0.25 rad rms; phase sorting extends to 0.75 rad; adding wavelengths to 1.4 rad rms</a:t>
-                      </a:r>
-                    </a:p>
-                  </a:txBody>
-                  <a:tcPr marL="54864" marR="54864" marT="18288" marB="18288">
-                    <a:solidFill>
-                      <a:srgbClr val="FFFFFF"/>
-                    </a:solidFill>
-                  </a:tcPr>
-                </a:tc>
-              </a:tr>
-              <a:tr h="468630">
-                <a:tc>
-                  <a:txBody>
-                    <a:bodyPr wrap="square"/>
-                    <a:lstStyle/>
-                    <a:p>
-                      <a:r>
-                        <a:rPr sz="1100" b="0">
-                          <a:solidFill>
-                            <a:srgbClr val="282828"/>
-                          </a:solidFill>
-                          <a:latin typeface="Arial"/>
-                        </a:rPr>
-                        <a:t>6</a:t>
+                        <a:t>held in closed loop to 3 pm against a 2 pm random walk: photons per cycle</a:t>
                       </a:r>
                     </a:p>
                   </a:txBody>
@@ -7725,7 +7848,7 @@
                           </a:solidFill>
                           <a:latin typeface="Arial"/>
                         </a:rPr>
-                        <a:t>Darcis, Haffert, Chambouleyron, Doelman et al. 2025, A&amp;A</a:t>
+                        <a:t>pending (same loop code, CCMac)</a:t>
                       </a:r>
                     </a:p>
                   </a:txBody>
@@ -7747,7 +7870,7 @@
                           </a:solidFill>
                           <a:latin typeface="Arial"/>
                         </a:rPr>
-                        <a:t>Multi-wavelength gradient descent through the forward model: dynamic range for the scalar sensor, photon robustness across a wider band, two-wavelength unwrapping of petal errors</a:t>
+                        <a:t>7.5×10¹² (stepped), 7.3×10¹² (linear)</a:t>
                       </a:r>
                     </a:p>
                   </a:txBody>
@@ -7770,7 +7893,7 @@
         </p:nvSpPr>
         <p:spPr>
           <a:xfrm>
-            <a:off x="411480" y="4536567"/>
+            <a:off x="411480" y="5468112"/>
             <a:ext cx="11368735" cy="274320"/>
           </a:xfrm>
           <a:prstGeom prst="rect">
@@ -7790,13 +7913,52 @@
               </a:spcAft>
             </a:pPr>
             <a:r>
-              <a:rPr sz="1050" b="0">
-                <a:solidFill>
-                  <a:srgbClr val="6E6E6E"/>
+              <a:rPr sz="1500" b="0">
+                <a:solidFill>
+                  <a:srgbClr val="282828"/>
                 </a:solidFill>
                 <a:latin typeface="Arial"/>
               </a:rPr>
-              <a:t>Priority = payoff against this campaign's measured weak results.  Synopses and links: macos/REPORT_zwfs_lit_scan.md.</a:t>
+              <a:t>•  Reading: the interferometer measures any surface and pays at fine patterns; the sensor measures small changes on a small working surface more cheaply — no polarization train, a floor ten times lower once its response matrix is measured on that surface — and pays at the lowest spatial frequencies and in the surface it can handle.</a:t>
+            </a:r>
+          </a:p>
+        </p:txBody>
+      </p:sp>
+      <p:sp>
+        <p:nvSpPr>
+          <p:cNvPr id="6" name="TextBox 5"/>
+          <p:cNvSpPr txBox="1"/>
+          <p:nvPr/>
+        </p:nvSpPr>
+        <p:spPr>
+          <a:xfrm>
+            <a:off x="411480" y="6387846"/>
+            <a:ext cx="11368735" cy="274320"/>
+          </a:xfrm>
+          <a:prstGeom prst="rect">
+            <a:avLst/>
+          </a:prstGeom>
+          <a:noFill/>
+        </p:spPr>
+        <p:txBody>
+          <a:bodyPr wrap="square">
+            <a:spAutoFit/>
+          </a:bodyPr>
+          <a:lstStyle/>
+          <a:p>
+            <a:pPr>
+              <a:spcAft>
+                <a:spcPts val="600"/>
+              </a:spcAft>
+            </a:pPr>
+            <a:r>
+              <a:rPr sz="1050" b="0">
+                <a:solidFill>
+                  <a:srgbClr val="6E6E6E"/>
+                </a:solidFill>
+                <a:latin typeface="Arial"/>
+              </a:rPr>
+              <a:t>PSI column: tg_psi_dm96 run 10 and S4/S5; sensor column: 385 rays, matrix calibration on the working surface (slide 10), photons at development sampling.  Both in actuator units through the same code (dm_gauge_lib).</a:t>
             </a:r>
           </a:p>
         </p:txBody>
@@ -7853,7 +8015,7 @@
                 </a:solidFill>
                 <a:latin typeface="Arial"/>
               </a:rPr>
-              <a:t>Demonstrations, segmented mirrors, and the in-house precedent</a:t>
+              <a:t>What the Zernike-sensor literature offers, in priority order</a:t>
             </a:r>
           </a:p>
           <a:p>
@@ -7869,7 +8031,7 @@
                 </a:solidFill>
                 <a:latin typeface="Arial"/>
               </a:rPr>
-              <a:t>Picometres by alternating DM shapes and averaging; segment piston by model iteration, underestimated below 50 % Strehl</a:t>
+              <a:t>Twelve papers read; the first import — re-computing the reference wave — is now built and measured (slide 8)</a:t>
             </a:r>
           </a:p>
         </p:txBody>
@@ -7937,9 +8099,9 @@
                 <a:tableStyleId>{5C22544A-7EE6-4342-B048-85BDC9FD1C3A}</a:tableStyleId>
               </a:tblPr>
               <a:tblGrid>
-                <a:gridCol w="291592"/>
-                <a:gridCol w="3730058"/>
-                <a:gridCol w="7347084"/>
+                <a:gridCol w="218948"/>
+                <a:gridCol w="2691327"/>
+                <a:gridCol w="8458459"/>
               </a:tblGrid>
               <a:tr h="280035">
                 <a:tc>
@@ -8022,7 +8184,7 @@
                           </a:solidFill>
                           <a:latin typeface="Arial"/>
                         </a:rPr>
-                        <a:t>7</a:t>
+                        <a:t>1</a:t>
                       </a:r>
                     </a:p>
                   </a:txBody>
@@ -8044,7 +8206,7 @@
                           </a:solidFill>
                           <a:latin typeface="Arial"/>
                         </a:rPr>
-                        <a:t>Steeves, Wallace, Kettenbeil, Jewell 2020, Optica 7, 1267</a:t>
+                        <a:t>Ruane, Wallace, Steeves et al. 2020, JATIS 6, 045005</a:t>
                       </a:r>
                     </a:p>
                   </a:txBody>
@@ -8066,7 +8228,7 @@
                           </a:solidFill>
                           <a:latin typeface="Arial"/>
                         </a:rPr>
-                        <a:t>1.6 pm repeatability in 4.3 s by alternating flat and waffle DM states and averaging the differences; a reconstruction robust at the highest spatial frequencies</a:t>
+                        <a:t>Exact per-pixel reconstruction from the pupil amplitude, the reference wave b and the masked image; a sensitivity factor per pixel; a four-term systematic budget; 1 pm reached at 4.4×10⁵ frames; no loss to 25 % bandwidth</a:t>
                       </a:r>
                     </a:p>
                   </a:txBody>
@@ -8090,7 +8252,7 @@
                           </a:solidFill>
                           <a:latin typeface="Arial"/>
                         </a:rPr>
-                        <a:t>8</a:t>
+                        <a:t>2</a:t>
                       </a:r>
                     </a:p>
                   </a:txBody>
@@ -8112,7 +8274,7 @@
                           </a:solidFill>
                           <a:latin typeface="Arial"/>
                         </a:rPr>
-                        <a:t>Wallace, Rao, Jensen-Clem, Serabyn 2011, SPIE 8126</a:t>
+                        <a:t>Doelman, Fagginger Auer, Escuti, Snik 2019, Opt. Lett. 44, 17</a:t>
                       </a:r>
                     </a:p>
                   </a:txBody>
@@ -8134,7 +8296,7 @@
                           </a:solidFill>
                           <a:latin typeface="Arial"/>
                         </a:rPr>
-                        <a:t>All-reflective phase-shifting Zernike interferometer: a dynamic, arbitrary core phase shift read in four steps gives phase and amplitude; low sensitivity to vibration, polarization and wavelength</a:t>
+                        <a:t>Vector Zernike: ±π/2 on opposite circular polarizations gives two pupil images, an exact phase-and-amplitude solution, an iterated b, achromatic to 100 % bandwidth; the leakage terms are written down</a:t>
                       </a:r>
                     </a:p>
                   </a:txBody>
@@ -8158,7 +8320,7 @@
                           </a:solidFill>
                           <a:latin typeface="Arial"/>
                         </a:rPr>
-                        <a:t>9</a:t>
+                        <a:t>3</a:t>
                       </a:r>
                     </a:p>
                   </a:txBody>
@@ -8180,7 +8342,7 @@
                           </a:solidFill>
                           <a:latin typeface="Arial"/>
                         </a:rPr>
-                        <a:t>Moore and Redding 2018, SPIE 10698</a:t>
+                        <a:t>N'Diaye, Vigan, Dohlen et al. 2016, A&amp;A 592, A79 (ZELDA II)</a:t>
                       </a:r>
                     </a:p>
                   </a:txBody>
@@ -8202,7 +8364,7 @@
                           </a:solidFill>
                           <a:latin typeface="Arial"/>
                         </a:rPr>
-                        <a:t>Nonlinear polychromatic physical-optics reconstruction for picometer differential metrology on LUVOIR; the in-house precedent for the reconstructor above</a:t>
+                        <a:t>Second-order reconstruction with b from the mask model; 1.06 λ/D at π/2; range −0.14 to +0.36 λ; the sensitivity factor drifts 10 % day to day on SPHERE</a:t>
                       </a:r>
                     </a:p>
                   </a:txBody>
@@ -8226,7 +8388,7 @@
                           </a:solidFill>
                           <a:latin typeface="Arial"/>
                         </a:rPr>
-                        <a:t>10</a:t>
+                        <a:t>4</a:t>
                       </a:r>
                     </a:p>
                   </a:txBody>
@@ -8248,7 +8410,7 @@
                           </a:solidFill>
                           <a:latin typeface="Arial"/>
                         </a:rPr>
-                        <a:t>Keck vector-Zernike segment control 2024 (arXiv 2404.08728); Wallace et al. 2022 (arXiv 2205.02241)</a:t>
+                        <a:t>Chambouleyron, Cissé, Salama, Haffert, Wallace et al. 2024, SPIE 13097</a:t>
                       </a:r>
                     </a:p>
                   </a:txBody>
@@ -8270,7 +8432,7 @@
                           </a:solidFill>
                           <a:latin typeface="Arial"/>
                         </a:rPr>
-                        <a:t>Segment piston by model-based iteration; 11 nm rms piston uncertainty; underestimation 2 to 4× below 50 % Strehl; fabricated shifts 0.30π and 0.68π instead of ±0.5π</a:t>
+                        <a:t>A phase-shifted pair (±π/2) yields cos φ and sin φ; iterative reconstructors reach about 1 rad rms; the bench limits were polarization crosstalk and defocus between the two pupils</a:t>
                       </a:r>
                     </a:p>
                   </a:txBody>
@@ -8294,7 +8456,7 @@
                           </a:solidFill>
                           <a:latin typeface="Arial"/>
                         </a:rPr>
-                        <a:t>11</a:t>
+                        <a:t>5</a:t>
                       </a:r>
                     </a:p>
                   </a:txBody>
@@ -8316,7 +8478,7 @@
                           </a:solidFill>
                           <a:latin typeface="Arial"/>
                         </a:rPr>
-                        <a:t>HiCAT mid-order Zernike sensor 2024 (arXiv 2409.03411)</a:t>
+                        <a:t>Haffert 2024, A&amp;A 683, A113</a:t>
                       </a:r>
                     </a:p>
                   </a:txBody>
@@ -8338,7 +8500,7 @@
                           </a:solidFill>
                           <a:latin typeface="Arial"/>
                         </a:rPr>
-                        <a:t>Per-segment piston, tip and tilt by interaction matrix; a minimal step of 125 ± 31 pm at SNR 4; 14-bit DM quantization reads as steps in the response</a:t>
+                        <a:t>Iterative nonlinear reconstructors reach machine precision below 0.25 rad rms; phase sorting extends to 0.75 rad; adding wavelengths to 1.4 rad rms</a:t>
                       </a:r>
                     </a:p>
                   </a:txBody>
@@ -8362,7 +8524,7 @@
                           </a:solidFill>
                           <a:latin typeface="Arial"/>
                         </a:rPr>
-                        <a:t>12</a:t>
+                        <a:t>6</a:t>
                       </a:r>
                     </a:p>
                   </a:txBody>
@@ -8384,7 +8546,7 @@
                           </a:solidFill>
                           <a:latin typeface="Arial"/>
                         </a:rPr>
-                        <a:t>Shi et al. 2015, SPIE 9605 (Roman low-order sensor)</a:t>
+                        <a:t>Darcis, Haffert, Chambouleyron, Doelman et al. 2025, A&amp;A</a:t>
                       </a:r>
                     </a:p>
                   </a:txBody>
@@ -8406,7 +8568,7 @@
                           </a:solidFill>
                           <a:latin typeface="Arial"/>
                         </a:rPr>
-                        <a:t>A reflective dimple on the focal-plane mask senses Z2 to Z11 from the rejected starlight: the spatially filtered form of the same sensor</a:t>
+                        <a:t>Multi-wavelength gradient descent through the forward model: dynamic range for the scalar sensor, photon robustness across a wider band, two-wavelength unwrapping of petal errors</a:t>
                       </a:r>
                     </a:p>
                   </a:txBody>
@@ -8455,7 +8617,7 @@
                 </a:solidFill>
                 <a:latin typeface="Arial"/>
               </a:rPr>
-              <a:t>Also read: PIAA-ZWFS (2026, arXiv 2606.28136), lossless pupil apodization that closes the gap to the fundamental sensitivity limit by 10× — a design lever, not a model change.</a:t>
+              <a:t>Priority = payoff against this campaign's measured weak results.  Synopses and links: macos/REPORT_zwfs_lit_scan.md.</a:t>
             </a:r>
           </a:p>
         </p:txBody>
@@ -8512,7 +8674,7 @@
                 </a:solidFill>
                 <a:latin typeface="Arial"/>
               </a:rPr>
-              <a:t>Conclusions: what the corrected model and the exact reading settled</a:t>
+              <a:t>Demonstrations, segmented mirrors, and the in-house precedent</a:t>
             </a:r>
           </a:p>
           <a:p>
@@ -8528,7 +8690,7 @@
                 </a:solidFill>
                 <a:latin typeface="Arial"/>
               </a:rPr>
-              <a:t>Fixing the model was the bigger gain; a response matrix measured on the working surface takes the stepped reading to 5 pm; colour and photons are not the limit</a:t>
+              <a:t>Picometres by alternating DM shapes and averaging; segment piston by model iteration, underestimated below 50 % Strehl</a:t>
             </a:r>
           </a:p>
         </p:txBody>
@@ -8577,15 +8739,518 @@
           </a:p>
         </p:txBody>
       </p:sp>
-      <p:sp>
-        <p:nvSpPr>
-          <p:cNvPr id="4" name="TextBox 3"/>
+      <p:graphicFrame>
+        <p:nvGraphicFramePr>
+          <p:cNvPr id="4" name="Table 3"/>
+          <p:cNvGraphicFramePr>
+            <a:graphicFrameLocks noGrp="1"/>
+          </p:cNvGraphicFramePr>
+          <p:nvPr/>
+        </p:nvGraphicFramePr>
+        <p:xfrm>
+          <a:off x="411480" y="1298448"/>
+          <a:ext cx="11368734" cy="3091815"/>
+        </p:xfrm>
+        <a:graphic>
+          <a:graphicData uri="http://schemas.openxmlformats.org/drawingml/2006/table">
+            <a:tbl>
+              <a:tblPr firstRow="1" bandRow="1">
+                <a:tableStyleId>{5C22544A-7EE6-4342-B048-85BDC9FD1C3A}</a:tableStyleId>
+              </a:tblPr>
+              <a:tblGrid>
+                <a:gridCol w="291592"/>
+                <a:gridCol w="3730058"/>
+                <a:gridCol w="7347084"/>
+              </a:tblGrid>
+              <a:tr h="280035">
+                <a:tc>
+                  <a:txBody>
+                    <a:bodyPr wrap="square"/>
+                    <a:lstStyle/>
+                    <a:p>
+                      <a:r>
+                        <a:rPr sz="1100" b="1">
+                          <a:solidFill>
+                            <a:srgbClr val="FFFFFF"/>
+                          </a:solidFill>
+                          <a:latin typeface="Arial"/>
+                        </a:rPr>
+                        <a:t>#</a:t>
+                      </a:r>
+                    </a:p>
+                  </a:txBody>
+                  <a:tcPr marL="54864" marR="54864" marT="18288" marB="18288">
+                    <a:solidFill>
+                      <a:srgbClr val="1F4E79"/>
+                    </a:solidFill>
+                  </a:tcPr>
+                </a:tc>
+                <a:tc>
+                  <a:txBody>
+                    <a:bodyPr wrap="square"/>
+                    <a:lstStyle/>
+                    <a:p>
+                      <a:r>
+                        <a:rPr sz="1100" b="1">
+                          <a:solidFill>
+                            <a:srgbClr val="FFFFFF"/>
+                          </a:solidFill>
+                          <a:latin typeface="Arial"/>
+                        </a:rPr>
+                        <a:t>paper</a:t>
+                      </a:r>
+                    </a:p>
+                  </a:txBody>
+                  <a:tcPr marL="54864" marR="54864" marT="18288" marB="18288">
+                    <a:solidFill>
+                      <a:srgbClr val="1F4E79"/>
+                    </a:solidFill>
+                  </a:tcPr>
+                </a:tc>
+                <a:tc>
+                  <a:txBody>
+                    <a:bodyPr wrap="square"/>
+                    <a:lstStyle/>
+                    <a:p>
+                      <a:r>
+                        <a:rPr sz="1100" b="1">
+                          <a:solidFill>
+                            <a:srgbClr val="FFFFFF"/>
+                          </a:solidFill>
+                          <a:latin typeface="Arial"/>
+                        </a:rPr>
+                        <a:t>what it gives this model</a:t>
+                      </a:r>
+                    </a:p>
+                  </a:txBody>
+                  <a:tcPr marL="54864" marR="54864" marT="18288" marB="18288">
+                    <a:solidFill>
+                      <a:srgbClr val="1F4E79"/>
+                    </a:solidFill>
+                  </a:tcPr>
+                </a:tc>
+              </a:tr>
+              <a:tr h="468630">
+                <a:tc>
+                  <a:txBody>
+                    <a:bodyPr wrap="square"/>
+                    <a:lstStyle/>
+                    <a:p>
+                      <a:r>
+                        <a:rPr sz="1100" b="0">
+                          <a:solidFill>
+                            <a:srgbClr val="282828"/>
+                          </a:solidFill>
+                          <a:latin typeface="Arial"/>
+                        </a:rPr>
+                        <a:t>7</a:t>
+                      </a:r>
+                    </a:p>
+                  </a:txBody>
+                  <a:tcPr marL="54864" marR="54864" marT="18288" marB="18288">
+                    <a:solidFill>
+                      <a:srgbClr val="FFFFFF"/>
+                    </a:solidFill>
+                  </a:tcPr>
+                </a:tc>
+                <a:tc>
+                  <a:txBody>
+                    <a:bodyPr wrap="square"/>
+                    <a:lstStyle/>
+                    <a:p>
+                      <a:r>
+                        <a:rPr sz="1100" b="0">
+                          <a:solidFill>
+                            <a:srgbClr val="282828"/>
+                          </a:solidFill>
+                          <a:latin typeface="Arial"/>
+                        </a:rPr>
+                        <a:t>Steeves, Wallace, Kettenbeil, Jewell 2020, Optica 7, 1267</a:t>
+                      </a:r>
+                    </a:p>
+                  </a:txBody>
+                  <a:tcPr marL="54864" marR="54864" marT="18288" marB="18288">
+                    <a:solidFill>
+                      <a:srgbClr val="FFFFFF"/>
+                    </a:solidFill>
+                  </a:tcPr>
+                </a:tc>
+                <a:tc>
+                  <a:txBody>
+                    <a:bodyPr wrap="square"/>
+                    <a:lstStyle/>
+                    <a:p>
+                      <a:r>
+                        <a:rPr sz="1100" b="0">
+                          <a:solidFill>
+                            <a:srgbClr val="282828"/>
+                          </a:solidFill>
+                          <a:latin typeface="Arial"/>
+                        </a:rPr>
+                        <a:t>1.6 pm repeatability in 4.3 s by alternating flat and waffle DM states and averaging the differences; a reconstruction robust at the highest spatial frequencies</a:t>
+                      </a:r>
+                    </a:p>
+                  </a:txBody>
+                  <a:tcPr marL="54864" marR="54864" marT="18288" marB="18288">
+                    <a:solidFill>
+                      <a:srgbClr val="FFFFFF"/>
+                    </a:solidFill>
+                  </a:tcPr>
+                </a:tc>
+              </a:tr>
+              <a:tr h="468630">
+                <a:tc>
+                  <a:txBody>
+                    <a:bodyPr wrap="square"/>
+                    <a:lstStyle/>
+                    <a:p>
+                      <a:r>
+                        <a:rPr sz="1100" b="0">
+                          <a:solidFill>
+                            <a:srgbClr val="282828"/>
+                          </a:solidFill>
+                          <a:latin typeface="Arial"/>
+                        </a:rPr>
+                        <a:t>8</a:t>
+                      </a:r>
+                    </a:p>
+                  </a:txBody>
+                  <a:tcPr marL="54864" marR="54864" marT="18288" marB="18288">
+                    <a:solidFill>
+                      <a:srgbClr val="ECF1F6"/>
+                    </a:solidFill>
+                  </a:tcPr>
+                </a:tc>
+                <a:tc>
+                  <a:txBody>
+                    <a:bodyPr wrap="square"/>
+                    <a:lstStyle/>
+                    <a:p>
+                      <a:r>
+                        <a:rPr sz="1100" b="0">
+                          <a:solidFill>
+                            <a:srgbClr val="282828"/>
+                          </a:solidFill>
+                          <a:latin typeface="Arial"/>
+                        </a:rPr>
+                        <a:t>Wallace, Rao, Jensen-Clem, Serabyn 2011, SPIE 8126</a:t>
+                      </a:r>
+                    </a:p>
+                  </a:txBody>
+                  <a:tcPr marL="54864" marR="54864" marT="18288" marB="18288">
+                    <a:solidFill>
+                      <a:srgbClr val="ECF1F6"/>
+                    </a:solidFill>
+                  </a:tcPr>
+                </a:tc>
+                <a:tc>
+                  <a:txBody>
+                    <a:bodyPr wrap="square"/>
+                    <a:lstStyle/>
+                    <a:p>
+                      <a:r>
+                        <a:rPr sz="1100" b="0">
+                          <a:solidFill>
+                            <a:srgbClr val="282828"/>
+                          </a:solidFill>
+                          <a:latin typeface="Arial"/>
+                        </a:rPr>
+                        <a:t>All-reflective phase-shifting Zernike interferometer: a dynamic, arbitrary core phase shift read in four steps gives phase and amplitude; low sensitivity to vibration, polarization and wavelength</a:t>
+                      </a:r>
+                    </a:p>
+                  </a:txBody>
+                  <a:tcPr marL="54864" marR="54864" marT="18288" marB="18288">
+                    <a:solidFill>
+                      <a:srgbClr val="ECF1F6"/>
+                    </a:solidFill>
+                  </a:tcPr>
+                </a:tc>
+              </a:tr>
+              <a:tr h="468630">
+                <a:tc>
+                  <a:txBody>
+                    <a:bodyPr wrap="square"/>
+                    <a:lstStyle/>
+                    <a:p>
+                      <a:r>
+                        <a:rPr sz="1100" b="0">
+                          <a:solidFill>
+                            <a:srgbClr val="282828"/>
+                          </a:solidFill>
+                          <a:latin typeface="Arial"/>
+                        </a:rPr>
+                        <a:t>9</a:t>
+                      </a:r>
+                    </a:p>
+                  </a:txBody>
+                  <a:tcPr marL="54864" marR="54864" marT="18288" marB="18288">
+                    <a:solidFill>
+                      <a:srgbClr val="FFFFFF"/>
+                    </a:solidFill>
+                  </a:tcPr>
+                </a:tc>
+                <a:tc>
+                  <a:txBody>
+                    <a:bodyPr wrap="square"/>
+                    <a:lstStyle/>
+                    <a:p>
+                      <a:r>
+                        <a:rPr sz="1100" b="0">
+                          <a:solidFill>
+                            <a:srgbClr val="282828"/>
+                          </a:solidFill>
+                          <a:latin typeface="Arial"/>
+                        </a:rPr>
+                        <a:t>Moore and Redding 2018, SPIE 10698</a:t>
+                      </a:r>
+                    </a:p>
+                  </a:txBody>
+                  <a:tcPr marL="54864" marR="54864" marT="18288" marB="18288">
+                    <a:solidFill>
+                      <a:srgbClr val="FFFFFF"/>
+                    </a:solidFill>
+                  </a:tcPr>
+                </a:tc>
+                <a:tc>
+                  <a:txBody>
+                    <a:bodyPr wrap="square"/>
+                    <a:lstStyle/>
+                    <a:p>
+                      <a:r>
+                        <a:rPr sz="1100" b="0">
+                          <a:solidFill>
+                            <a:srgbClr val="282828"/>
+                          </a:solidFill>
+                          <a:latin typeface="Arial"/>
+                        </a:rPr>
+                        <a:t>Nonlinear polychromatic physical-optics reconstruction for picometer differential metrology on LUVOIR; the in-house precedent for the reconstructor above</a:t>
+                      </a:r>
+                    </a:p>
+                  </a:txBody>
+                  <a:tcPr marL="54864" marR="54864" marT="18288" marB="18288">
+                    <a:solidFill>
+                      <a:srgbClr val="FFFFFF"/>
+                    </a:solidFill>
+                  </a:tcPr>
+                </a:tc>
+              </a:tr>
+              <a:tr h="468630">
+                <a:tc>
+                  <a:txBody>
+                    <a:bodyPr wrap="square"/>
+                    <a:lstStyle/>
+                    <a:p>
+                      <a:r>
+                        <a:rPr sz="1100" b="0">
+                          <a:solidFill>
+                            <a:srgbClr val="282828"/>
+                          </a:solidFill>
+                          <a:latin typeface="Arial"/>
+                        </a:rPr>
+                        <a:t>10</a:t>
+                      </a:r>
+                    </a:p>
+                  </a:txBody>
+                  <a:tcPr marL="54864" marR="54864" marT="18288" marB="18288">
+                    <a:solidFill>
+                      <a:srgbClr val="ECF1F6"/>
+                    </a:solidFill>
+                  </a:tcPr>
+                </a:tc>
+                <a:tc>
+                  <a:txBody>
+                    <a:bodyPr wrap="square"/>
+                    <a:lstStyle/>
+                    <a:p>
+                      <a:r>
+                        <a:rPr sz="1100" b="0">
+                          <a:solidFill>
+                            <a:srgbClr val="282828"/>
+                          </a:solidFill>
+                          <a:latin typeface="Arial"/>
+                        </a:rPr>
+                        <a:t>Keck vector-Zernike segment control 2024 (arXiv 2404.08728); Wallace et al. 2022 (arXiv 2205.02241)</a:t>
+                      </a:r>
+                    </a:p>
+                  </a:txBody>
+                  <a:tcPr marL="54864" marR="54864" marT="18288" marB="18288">
+                    <a:solidFill>
+                      <a:srgbClr val="ECF1F6"/>
+                    </a:solidFill>
+                  </a:tcPr>
+                </a:tc>
+                <a:tc>
+                  <a:txBody>
+                    <a:bodyPr wrap="square"/>
+                    <a:lstStyle/>
+                    <a:p>
+                      <a:r>
+                        <a:rPr sz="1100" b="0">
+                          <a:solidFill>
+                            <a:srgbClr val="282828"/>
+                          </a:solidFill>
+                          <a:latin typeface="Arial"/>
+                        </a:rPr>
+                        <a:t>Segment piston by model-based iteration; 11 nm rms piston uncertainty; underestimation 2 to 4× below 50 % Strehl; fabricated shifts 0.30π and 0.68π instead of ±0.5π</a:t>
+                      </a:r>
+                    </a:p>
+                  </a:txBody>
+                  <a:tcPr marL="54864" marR="54864" marT="18288" marB="18288">
+                    <a:solidFill>
+                      <a:srgbClr val="ECF1F6"/>
+                    </a:solidFill>
+                  </a:tcPr>
+                </a:tc>
+              </a:tr>
+              <a:tr h="468630">
+                <a:tc>
+                  <a:txBody>
+                    <a:bodyPr wrap="square"/>
+                    <a:lstStyle/>
+                    <a:p>
+                      <a:r>
+                        <a:rPr sz="1100" b="0">
+                          <a:solidFill>
+                            <a:srgbClr val="282828"/>
+                          </a:solidFill>
+                          <a:latin typeface="Arial"/>
+                        </a:rPr>
+                        <a:t>11</a:t>
+                      </a:r>
+                    </a:p>
+                  </a:txBody>
+                  <a:tcPr marL="54864" marR="54864" marT="18288" marB="18288">
+                    <a:solidFill>
+                      <a:srgbClr val="FFFFFF"/>
+                    </a:solidFill>
+                  </a:tcPr>
+                </a:tc>
+                <a:tc>
+                  <a:txBody>
+                    <a:bodyPr wrap="square"/>
+                    <a:lstStyle/>
+                    <a:p>
+                      <a:r>
+                        <a:rPr sz="1100" b="0">
+                          <a:solidFill>
+                            <a:srgbClr val="282828"/>
+                          </a:solidFill>
+                          <a:latin typeface="Arial"/>
+                        </a:rPr>
+                        <a:t>HiCAT mid-order Zernike sensor 2024 (arXiv 2409.03411)</a:t>
+                      </a:r>
+                    </a:p>
+                  </a:txBody>
+                  <a:tcPr marL="54864" marR="54864" marT="18288" marB="18288">
+                    <a:solidFill>
+                      <a:srgbClr val="FFFFFF"/>
+                    </a:solidFill>
+                  </a:tcPr>
+                </a:tc>
+                <a:tc>
+                  <a:txBody>
+                    <a:bodyPr wrap="square"/>
+                    <a:lstStyle/>
+                    <a:p>
+                      <a:r>
+                        <a:rPr sz="1100" b="0">
+                          <a:solidFill>
+                            <a:srgbClr val="282828"/>
+                          </a:solidFill>
+                          <a:latin typeface="Arial"/>
+                        </a:rPr>
+                        <a:t>Per-segment piston, tip and tilt by interaction matrix; a minimal step of 125 ± 31 pm at SNR 4; 14-bit DM quantization reads as steps in the response</a:t>
+                      </a:r>
+                    </a:p>
+                  </a:txBody>
+                  <a:tcPr marL="54864" marR="54864" marT="18288" marB="18288">
+                    <a:solidFill>
+                      <a:srgbClr val="FFFFFF"/>
+                    </a:solidFill>
+                  </a:tcPr>
+                </a:tc>
+              </a:tr>
+              <a:tr h="468630">
+                <a:tc>
+                  <a:txBody>
+                    <a:bodyPr wrap="square"/>
+                    <a:lstStyle/>
+                    <a:p>
+                      <a:r>
+                        <a:rPr sz="1100" b="0">
+                          <a:solidFill>
+                            <a:srgbClr val="282828"/>
+                          </a:solidFill>
+                          <a:latin typeface="Arial"/>
+                        </a:rPr>
+                        <a:t>12</a:t>
+                      </a:r>
+                    </a:p>
+                  </a:txBody>
+                  <a:tcPr marL="54864" marR="54864" marT="18288" marB="18288">
+                    <a:solidFill>
+                      <a:srgbClr val="ECF1F6"/>
+                    </a:solidFill>
+                  </a:tcPr>
+                </a:tc>
+                <a:tc>
+                  <a:txBody>
+                    <a:bodyPr wrap="square"/>
+                    <a:lstStyle/>
+                    <a:p>
+                      <a:r>
+                        <a:rPr sz="1100" b="0">
+                          <a:solidFill>
+                            <a:srgbClr val="282828"/>
+                          </a:solidFill>
+                          <a:latin typeface="Arial"/>
+                        </a:rPr>
+                        <a:t>Shi et al. 2015, SPIE 9605 (Roman low-order sensor)</a:t>
+                      </a:r>
+                    </a:p>
+                  </a:txBody>
+                  <a:tcPr marL="54864" marR="54864" marT="18288" marB="18288">
+                    <a:solidFill>
+                      <a:srgbClr val="ECF1F6"/>
+                    </a:solidFill>
+                  </a:tcPr>
+                </a:tc>
+                <a:tc>
+                  <a:txBody>
+                    <a:bodyPr wrap="square"/>
+                    <a:lstStyle/>
+                    <a:p>
+                      <a:r>
+                        <a:rPr sz="1100" b="0">
+                          <a:solidFill>
+                            <a:srgbClr val="282828"/>
+                          </a:solidFill>
+                          <a:latin typeface="Arial"/>
+                        </a:rPr>
+                        <a:t>A reflective dimple on the focal-plane mask senses Z2 to Z11 from the rejected starlight: the spatially filtered form of the same sensor</a:t>
+                      </a:r>
+                    </a:p>
+                  </a:txBody>
+                  <a:tcPr marL="54864" marR="54864" marT="18288" marB="18288">
+                    <a:solidFill>
+                      <a:srgbClr val="ECF1F6"/>
+                    </a:solidFill>
+                  </a:tcPr>
+                </a:tc>
+              </a:tr>
+            </a:tbl>
+          </a:graphicData>
+        </a:graphic>
+      </p:graphicFrame>
+      <p:sp>
+        <p:nvSpPr>
+          <p:cNvPr id="5" name="TextBox 4"/>
           <p:cNvSpPr txBox="1"/>
           <p:nvPr/>
         </p:nvSpPr>
         <p:spPr>
           <a:xfrm>
-            <a:off x="411480" y="1298448"/>
+            <a:off x="411480" y="4536567"/>
             <a:ext cx="11368735" cy="274320"/>
           </a:xfrm>
           <a:prstGeom prst="rect">
@@ -8605,116 +9270,13 @@
               </a:spcAft>
             </a:pPr>
             <a:r>
-              <a:rPr sz="1500" b="0">
-                <a:solidFill>
-                  <a:srgbClr val="282828"/>
+              <a:rPr sz="1050" b="0">
+                <a:solidFill>
+                  <a:srgbClr val="6E6E6E"/>
                 </a:solidFill>
                 <a:latin typeface="Arial"/>
               </a:rPr>
-              <a:t>•  The model must keep the pupil image in focus: the two spheres around the mask share one radius, and the script checks the no-mask round trip on every run.  The correction alone took the single-actuator floor from 744 to 67 pm and made the undetected grid case detectable.</a:t>
-            </a:r>
-          </a:p>
-          <a:p>
-            <a:pPr>
-              <a:spcAft>
-                <a:spcPts val="600"/>
-              </a:spcAft>
-            </a:pPr>
-            <a:r>
-              <a:rPr sz="1500" b="0">
-                <a:solidFill>
-                  <a:srgbClr val="282828"/>
-                </a:solidFill>
-                <a:latin typeface="Arial"/>
-              </a:rPr>
-              <a:t>•  The exact reading with a re-computed reference is the import that paid (paper 1): 26 pm from one frame on a 30 nm working surface, SNR 355 — with the sign fold settled once from four stepped frames and refined.  The plain stepped sign map misses 3% of pixels and can flip a single actuator's sign.</a:t>
-            </a:r>
-          </a:p>
-          <a:p>
-            <a:pPr>
-              <a:spcAft>
-                <a:spcPts val="600"/>
-              </a:spcAft>
-            </a:pPr>
-            <a:r>
-              <a:rPr sz="1500" b="0">
-                <a:solidFill>
-                  <a:srgbClr val="282828"/>
-                </a:solidFill>
-                <a:latin typeface="Arial"/>
-              </a:rPr>
-              <a:t>•  Calibrate with a measured response matrix, on the working surface: the sparse-grid measurement of every actuator's response (with the sensor's piston null carried) reads a single actuator on the flat at 0.994 with a 4 pm floor; measured on the working surface it gives the stepped reading 0.99 and 5 pm there and makes the linear one-frame reading usable (1.05, 23 pm).  The floors fall ten times; what remains is gain stability as the surface drifts (7% over 20 nm rms) and the one-frame exact readings' sign fold.</a:t>
-            </a:r>
-          </a:p>
-          <a:p>
-            <a:pPr>
-              <a:spcAft>
-                <a:spcPts val="600"/>
-              </a:spcAft>
-            </a:pPr>
-            <a:r>
-              <a:rPr sz="1500" b="0">
-                <a:solidFill>
-                  <a:srgbClr val="282828"/>
-                </a:solidFill>
-                <a:latin typeface="Arial"/>
-              </a:rPr>
-              <a:t>•  Sampling is settled, and a bias in the fit is fixed: camera pixels per actuator (the ray count) set the gain on a test actuator; sampling the single-site response pattern at the actuator centre took that gain to 0.996 at 5 pixels per actuator.</a:t>
-            </a:r>
-          </a:p>
-          <a:p>
-            <a:pPr>
-              <a:spcAft>
-                <a:spcPts val="600"/>
-              </a:spcAft>
-            </a:pPr>
-            <a:r>
-              <a:rPr sz="1500" b="0">
-                <a:solidFill>
-                  <a:srgbClr val="282828"/>
-                </a:solidFill>
-                <a:latin typeface="Arial"/>
-              </a:rPr>
-              <a:t>•  Colour and photons are not levers: the chromatic null was the defocus; 10¹⁴ photons per state reach 1 pm.  The budget is systematic error: the 25 to 60 pm floors and the gain's stability.</a:t>
-            </a:r>
-          </a:p>
-        </p:txBody>
-      </p:sp>
-      <p:sp>
-        <p:nvSpPr>
-          <p:cNvPr id="5" name="TextBox 4"/>
-          <p:cNvSpPr txBox="1"/>
-          <p:nvPr/>
-        </p:nvSpPr>
-        <p:spPr>
-          <a:xfrm>
-            <a:off x="411480" y="5998464"/>
-            <a:ext cx="11368735" cy="274320"/>
-          </a:xfrm>
-          <a:prstGeom prst="rect">
-            <a:avLst/>
-          </a:prstGeom>
-          <a:noFill/>
-        </p:spPr>
-        <p:txBody>
-          <a:bodyPr wrap="square">
-            <a:spAutoFit/>
-          </a:bodyPr>
-          <a:lstStyle/>
-          <a:p>
-            <a:pPr>
-              <a:spcAft>
-                <a:spcPts val="600"/>
-              </a:spcAft>
-            </a:pPr>
-            <a:r>
-              <a:rPr sz="1050" b="0">
-                <a:solidFill>
-                  <a:srgbClr val="6E6E6E"/>
-                </a:solidFill>
-                <a:latin typeface="Arial"/>
-              </a:rPr>
-              <a:t>Script and records: templates/40_benches/zwfs_dm96 (README S7/S8; runs/rec193, ng385, ng385s3, m2048, rec193full).</a:t>
+              <a:t>Also read: PIAA-ZWFS (2026, arXiv 2606.28136), lossless pupil apodization that closes the gap to the fundamental sensitivity limit by 10× — a design lever, not a model change.</a:t>
             </a:r>
           </a:p>
         </p:txBody>
@@ -8771,7 +9333,7 @@
                 </a:solidFill>
                 <a:latin typeface="Arial"/>
               </a:rPr>
-              <a:t>Conclusions: what to import next, in order</a:t>
+              <a:t>Conclusions: what the corrected model and the exact reading settled</a:t>
             </a:r>
           </a:p>
           <a:p>
@@ -8787,7 +9349,7 @@
                 </a:solidFill>
                 <a:latin typeface="Arial"/>
               </a:rPr>
-              <a:t>The JPL budget form, DM calibration through the sensor's own images, the vector sensor priced before it is built, and the interferometer's lever</a:t>
+              <a:t>Fixing the model was the bigger gain; a response matrix measured on the working surface takes the stepped reading to 5 pm; colour and photons are not the limit</a:t>
             </a:r>
           </a:p>
         </p:txBody>
@@ -8870,7 +9432,7 @@
                 </a:solidFill>
                 <a:latin typeface="Arial"/>
               </a:rPr>
-              <a:t>•  The JPL budget form: a sensitivity factor per pixel from the measured fields — the quantity the working-surface effect on slide 10 is made of — predicts the photon-noise stage analytically, and four systematic terms (pupil calibration at ½, reference wave at 1, dimple depth, initial phase) become the rows of the error budget.</a:t>
+              <a:t>•  The model must keep the pupil image in focus: the two spheres around the mask share one radius, and the script checks the no-mask round trip on every run.  The correction alone took the single-actuator floor from 744 to 67 pm and made the undetected grid case detectable.</a:t>
             </a:r>
           </a:p>
           <a:p>
@@ -8886,7 +9448,7 @@
                 </a:solidFill>
                 <a:latin typeface="Arial"/>
               </a:rPr>
-              <a:t>•  The response matrix for the interferometer too: its calibration still uses a single-site response pattern, with the stencil bias fixed here (slide 9); the sparse-grid measured matrix is the calibration its reflective build should carry.  Model-matched DM calibration (actuator positions and gains through the sensor's own images) remains the lever for a real DM's geometry.</a:t>
+              <a:t>•  The exact reading with a re-computed reference is the import that paid (paper 1): 26 pm from one frame on a 30 nm working surface, SNR 355 — with the sign fold settled once from four stepped frames and refined.  The plain stepped sign map misses 3% of pixels and can flip a single actuator's sign.</a:t>
             </a:r>
           </a:p>
           <a:p>
@@ -8902,7 +9464,7 @@
                 </a:solidFill>
                 <a:latin typeface="Arial"/>
               </a:rPr>
-              <a:t>•  Colour as a joint fit, not a combination: an equal-weight combination inherits a bad channel; a joint fit through the exact reading would use 700 to 780 nm for range and 632.8 nm for the calibration of record.</a:t>
+              <a:t>•  Calibrate with a measured response matrix, on the working surface: the sparse-grid measurement of every actuator's response (with the sensor's piston null carried) reads a single actuator on the flat at 0.994 with a 4 pm floor; measured on the working surface it gives the stepped reading 0.99 and 5 pm there and makes the linear one-frame reading usable (1.05, 23 pm).  The floors fall ten times; what remains is gain stability as the surface drifts (7% over 20 nm rms) and the one-frame exact readings' sign fold.</a:t>
             </a:r>
           </a:p>
           <a:p>
@@ -8918,7 +9480,7 @@
                 </a:solidFill>
                 <a:latin typeface="Arial"/>
               </a:rPr>
-              <a:t>•  Model the vector sensor before the metasurface is built: the exact two-image solution and its leakage terms (retardance offsets, splitter rotation) run on the engine's polarization machinery; the bench limits at Keck and SEAL were defocus and crosstalk between the two pupil images, both priceable here.</a:t>
+              <a:t>•  Sampling is settled, and a bias in the fit is fixed: camera pixels per actuator (the ray count) set the gain on a test actuator; sampling the single-site response pattern at the actuator centre took that gain to 0.996 at 5 pixels per actuator.</a:t>
             </a:r>
           </a:p>
           <a:p>
@@ -8934,7 +9496,23 @@
                 </a:solidFill>
                 <a:latin typeface="Arial"/>
               </a:rPr>
-              <a:t>•  The interferometer, for balance: a PZT phase shift buys no model gain — its floors are geometric and colour-independent — but on hardware an absolute phase scale and freedom from polarization systematics; the recommended form is a hybrid: polarization snapshot for the change measurements, a PZT on the reference flat as calibrator.  Its all-mirror (OAP) version is in build.</a:t>
+              <a:t>•  Colour and photons are not levers: the chromatic null was the defocus; 10¹⁴ photons per state reach 1 pm.  The budget is systematic error: the 25 to 60 pm floors and the gain's stability.</a:t>
+            </a:r>
+          </a:p>
+          <a:p>
+            <a:pPr>
+              <a:spcAft>
+                <a:spcPts val="600"/>
+              </a:spcAft>
+            </a:pPr>
+            <a:r>
+              <a:rPr sz="1500" b="0">
+                <a:solidFill>
+                  <a:srgbClr val="282828"/>
+                </a:solidFill>
+                <a:latin typeface="Arial"/>
+              </a:rPr>
+              <a:t>•  In closed loop the stepped reading has no fixed error: it holds a 2 pm-per-cycle walk to 3 pm from 7.5×10¹² photons per cycle and returns to zero after a step; the linear reading costs the same light but leaves a fine-scale error under a slow ramp; the one-frame exact reading runs away.</a:t>
             </a:r>
           </a:p>
         </p:txBody>
@@ -8947,7 +9525,7 @@
         </p:nvSpPr>
         <p:spPr>
           <a:xfrm>
-            <a:off x="411480" y="5998464"/>
+            <a:off x="411480" y="6881622"/>
             <a:ext cx="11368735" cy="274320"/>
           </a:xfrm>
           <a:prstGeom prst="rect">
@@ -8973,7 +9551,7 @@
                 </a:solidFill>
                 <a:latin typeface="Arial"/>
               </a:rPr>
-              <a:t>Segmented-mirror lessons carried forward: the sensor reads segment piston but not global piston, DM quantization appears as steps in the response, and piston is underestimated below 50 % Strehl (Keck) — all three enter the e5-class segmented gauges.</a:t>
+              <a:t>Script and records: templates/40_benches/zwfs_dm96 (README S7/S8; runs/rec193, ng385, ng385s3, m2048, rec193full).</a:t>
             </a:r>
           </a:p>
         </p:txBody>
@@ -9294,63 +9872,6 @@
         </p:nvSpPr>
         <p:spPr>
           <a:xfrm>
-            <a:off x="822960" y="2743200"/>
-            <a:ext cx="10545775" cy="1280160"/>
-          </a:xfrm>
-          <a:prstGeom prst="rect">
-            <a:avLst/>
-          </a:prstGeom>
-          <a:noFill/>
-        </p:spPr>
-        <p:txBody>
-          <a:bodyPr wrap="square">
-            <a:spAutoFit/>
-          </a:bodyPr>
-          <a:lstStyle/>
-          <a:p>
-            <a:pPr algn="ctr">
-              <a:spcAft>
-                <a:spcPts val="400"/>
-              </a:spcAft>
-            </a:pPr>
-            <a:r>
-              <a:rPr sz="4000" b="1">
-                <a:solidFill>
-                  <a:srgbClr val="1F4E79"/>
-                </a:solidFill>
-                <a:latin typeface="Arial"/>
-              </a:rPr>
-              <a:t>Backup</a:t>
-            </a:r>
-          </a:p>
-        </p:txBody>
-      </p:sp>
-    </p:spTree>
-  </p:cSld>
-  <p:clrMapOvr>
-    <a:masterClrMapping/>
-  </p:clrMapOvr>
-</p:sld>
-</file>
-
-<file path=ppt/slides/slide21.xml><?xml version="1.0" encoding="utf-8"?>
-<p:sld xmlns:a="http://schemas.openxmlformats.org/drawingml/2006/main" xmlns:p="http://schemas.openxmlformats.org/presentationml/2006/main" xmlns:r="http://schemas.openxmlformats.org/officeDocument/2006/relationships">
-  <p:cSld>
-    <p:spTree>
-      <p:nvGrpSpPr>
-        <p:cNvPr id="1" name=""/>
-        <p:cNvGrpSpPr/>
-        <p:nvPr/>
-      </p:nvGrpSpPr>
-      <p:grpSpPr/>
-      <p:sp>
-        <p:nvSpPr>
-          <p:cNvPr id="2" name="TextBox 1"/>
-          <p:cNvSpPr txBox="1"/>
-          <p:nvPr/>
-        </p:nvSpPr>
-        <p:spPr>
-          <a:xfrm>
             <a:off x="411480" y="201168"/>
             <a:ext cx="11368735" cy="914400"/>
           </a:xfrm>
@@ -9377,7 +9898,7 @@
                 </a:solidFill>
                 <a:latin typeface="Arial"/>
               </a:rPr>
-              <a:t>Before the correction: the first poke and colour results</a:t>
+              <a:t>Conclusions: what to import next, in order</a:t>
             </a:r>
           </a:p>
           <a:p>
@@ -9393,7 +9914,7 @@
                 </a:solidFill>
                 <a:latin typeface="Arial"/>
               </a:rPr>
-              <a:t>Kept for the record; every number on this slide is from the out-of-focus model</a:t>
+              <a:t>The JPL budget form, DM calibration through the sensor's own images, the vector sensor priced before it is built, and the interferometer's lever</a:t>
             </a:r>
           </a:p>
         </p:txBody>
@@ -9442,6 +9963,322 @@
           </a:p>
         </p:txBody>
       </p:sp>
+      <p:sp>
+        <p:nvSpPr>
+          <p:cNvPr id="4" name="TextBox 3"/>
+          <p:cNvSpPr txBox="1"/>
+          <p:nvPr/>
+        </p:nvSpPr>
+        <p:spPr>
+          <a:xfrm>
+            <a:off x="411480" y="1298448"/>
+            <a:ext cx="11368735" cy="274320"/>
+          </a:xfrm>
+          <a:prstGeom prst="rect">
+            <a:avLst/>
+          </a:prstGeom>
+          <a:noFill/>
+        </p:spPr>
+        <p:txBody>
+          <a:bodyPr wrap="square">
+            <a:spAutoFit/>
+          </a:bodyPr>
+          <a:lstStyle/>
+          <a:p>
+            <a:pPr>
+              <a:spcAft>
+                <a:spcPts val="600"/>
+              </a:spcAft>
+            </a:pPr>
+            <a:r>
+              <a:rPr sz="1500" b="0">
+                <a:solidFill>
+                  <a:srgbClr val="282828"/>
+                </a:solidFill>
+                <a:latin typeface="Arial"/>
+              </a:rPr>
+              <a:t>•  The JPL budget form: a sensitivity factor per pixel from the measured fields — the quantity the working-surface effect on slide 10 is made of — predicts the photon-noise stage analytically, and four systematic terms (pupil calibration at ½, reference wave at 1, dimple depth, initial phase) become the rows of the error budget.</a:t>
+            </a:r>
+          </a:p>
+          <a:p>
+            <a:pPr>
+              <a:spcAft>
+                <a:spcPts val="600"/>
+              </a:spcAft>
+            </a:pPr>
+            <a:r>
+              <a:rPr sz="1500" b="0">
+                <a:solidFill>
+                  <a:srgbClr val="282828"/>
+                </a:solidFill>
+                <a:latin typeface="Arial"/>
+              </a:rPr>
+              <a:t>•  The response matrix for the interferometer too: its calibration still uses a single-site response pattern, with the stencil bias fixed here (slide 9); the sparse-grid measured matrix is the calibration its reflective build should carry.  Model-matched DM calibration (actuator positions and gains through the sensor's own images) remains the lever for a real DM's geometry.</a:t>
+            </a:r>
+          </a:p>
+          <a:p>
+            <a:pPr>
+              <a:spcAft>
+                <a:spcPts val="600"/>
+              </a:spcAft>
+            </a:pPr>
+            <a:r>
+              <a:rPr sz="1500" b="0">
+                <a:solidFill>
+                  <a:srgbClr val="282828"/>
+                </a:solidFill>
+                <a:latin typeface="Arial"/>
+              </a:rPr>
+              <a:t>•  Colour as a joint fit, not a combination: an equal-weight combination inherits a bad channel; a joint fit through the exact reading would use 700 to 780 nm for range and 632.8 nm for the calibration of record.</a:t>
+            </a:r>
+          </a:p>
+          <a:p>
+            <a:pPr>
+              <a:spcAft>
+                <a:spcPts val="600"/>
+              </a:spcAft>
+            </a:pPr>
+            <a:r>
+              <a:rPr sz="1500" b="0">
+                <a:solidFill>
+                  <a:srgbClr val="282828"/>
+                </a:solidFill>
+                <a:latin typeface="Arial"/>
+              </a:rPr>
+              <a:t>•  Model the vector sensor before the metasurface is built: the exact two-image solution and its leakage terms (retardance offsets, splitter rotation) run on the engine's polarization machinery; the bench limits at Keck and SEAL were defocus and crosstalk between the two pupil images, both priceable here.</a:t>
+            </a:r>
+          </a:p>
+          <a:p>
+            <a:pPr>
+              <a:spcAft>
+                <a:spcPts val="600"/>
+              </a:spcAft>
+            </a:pPr>
+            <a:r>
+              <a:rPr sz="1500" b="0">
+                <a:solidFill>
+                  <a:srgbClr val="282828"/>
+                </a:solidFill>
+                <a:latin typeface="Arial"/>
+              </a:rPr>
+              <a:t>•  The interferometer, for balance: a PZT phase shift buys no model gain — its floors are geometric and colour-independent — but on hardware an absolute phase scale and freedom from polarization systematics; the recommended form is a hybrid: polarization snapshot for the change measurements, a PZT on the reference flat as calibrator.  Its all-mirror (OAP) version is in build.</a:t>
+            </a:r>
+          </a:p>
+        </p:txBody>
+      </p:sp>
+      <p:sp>
+        <p:nvSpPr>
+          <p:cNvPr id="5" name="TextBox 4"/>
+          <p:cNvSpPr txBox="1"/>
+          <p:nvPr/>
+        </p:nvSpPr>
+        <p:spPr>
+          <a:xfrm>
+            <a:off x="411480" y="5998464"/>
+            <a:ext cx="11368735" cy="274320"/>
+          </a:xfrm>
+          <a:prstGeom prst="rect">
+            <a:avLst/>
+          </a:prstGeom>
+          <a:noFill/>
+        </p:spPr>
+        <p:txBody>
+          <a:bodyPr wrap="square">
+            <a:spAutoFit/>
+          </a:bodyPr>
+          <a:lstStyle/>
+          <a:p>
+            <a:pPr>
+              <a:spcAft>
+                <a:spcPts val="600"/>
+              </a:spcAft>
+            </a:pPr>
+            <a:r>
+              <a:rPr sz="1050" b="0">
+                <a:solidFill>
+                  <a:srgbClr val="6E6E6E"/>
+                </a:solidFill>
+                <a:latin typeface="Arial"/>
+              </a:rPr>
+              <a:t>Segmented-mirror lessons carried forward: the sensor reads segment piston but not global piston, DM quantization appears as steps in the response, and piston is underestimated below 50 % Strehl (Keck) — all three enter the e5-class segmented gauges.</a:t>
+            </a:r>
+          </a:p>
+        </p:txBody>
+      </p:sp>
+    </p:spTree>
+  </p:cSld>
+  <p:clrMapOvr>
+    <a:masterClrMapping/>
+  </p:clrMapOvr>
+</p:sld>
+</file>
+
+<file path=ppt/slides/slide21.xml><?xml version="1.0" encoding="utf-8"?>
+<p:sld xmlns:a="http://schemas.openxmlformats.org/drawingml/2006/main" xmlns:p="http://schemas.openxmlformats.org/presentationml/2006/main" xmlns:r="http://schemas.openxmlformats.org/officeDocument/2006/relationships">
+  <p:cSld>
+    <p:spTree>
+      <p:nvGrpSpPr>
+        <p:cNvPr id="1" name=""/>
+        <p:cNvGrpSpPr/>
+        <p:nvPr/>
+      </p:nvGrpSpPr>
+      <p:grpSpPr/>
+      <p:sp>
+        <p:nvSpPr>
+          <p:cNvPr id="2" name="TextBox 1"/>
+          <p:cNvSpPr txBox="1"/>
+          <p:nvPr/>
+        </p:nvSpPr>
+        <p:spPr>
+          <a:xfrm>
+            <a:off x="822960" y="2743200"/>
+            <a:ext cx="10545775" cy="1280160"/>
+          </a:xfrm>
+          <a:prstGeom prst="rect">
+            <a:avLst/>
+          </a:prstGeom>
+          <a:noFill/>
+        </p:spPr>
+        <p:txBody>
+          <a:bodyPr wrap="square">
+            <a:spAutoFit/>
+          </a:bodyPr>
+          <a:lstStyle/>
+          <a:p>
+            <a:pPr algn="ctr">
+              <a:spcAft>
+                <a:spcPts val="400"/>
+              </a:spcAft>
+            </a:pPr>
+            <a:r>
+              <a:rPr sz="4000" b="1">
+                <a:solidFill>
+                  <a:srgbClr val="1F4E79"/>
+                </a:solidFill>
+                <a:latin typeface="Arial"/>
+              </a:rPr>
+              <a:t>Backup</a:t>
+            </a:r>
+          </a:p>
+        </p:txBody>
+      </p:sp>
+    </p:spTree>
+  </p:cSld>
+  <p:clrMapOvr>
+    <a:masterClrMapping/>
+  </p:clrMapOvr>
+</p:sld>
+</file>
+
+<file path=ppt/slides/slide22.xml><?xml version="1.0" encoding="utf-8"?>
+<p:sld xmlns:a="http://schemas.openxmlformats.org/drawingml/2006/main" xmlns:p="http://schemas.openxmlformats.org/presentationml/2006/main" xmlns:r="http://schemas.openxmlformats.org/officeDocument/2006/relationships">
+  <p:cSld>
+    <p:spTree>
+      <p:nvGrpSpPr>
+        <p:cNvPr id="1" name=""/>
+        <p:cNvGrpSpPr/>
+        <p:nvPr/>
+      </p:nvGrpSpPr>
+      <p:grpSpPr/>
+      <p:sp>
+        <p:nvSpPr>
+          <p:cNvPr id="2" name="TextBox 1"/>
+          <p:cNvSpPr txBox="1"/>
+          <p:nvPr/>
+        </p:nvSpPr>
+        <p:spPr>
+          <a:xfrm>
+            <a:off x="411480" y="201168"/>
+            <a:ext cx="11368735" cy="914400"/>
+          </a:xfrm>
+          <a:prstGeom prst="rect">
+            <a:avLst/>
+          </a:prstGeom>
+          <a:noFill/>
+        </p:spPr>
+        <p:txBody>
+          <a:bodyPr wrap="square">
+            <a:spAutoFit/>
+          </a:bodyPr>
+          <a:lstStyle/>
+          <a:p>
+            <a:pPr>
+              <a:spcAft>
+                <a:spcPts val="400"/>
+              </a:spcAft>
+            </a:pPr>
+            <a:r>
+              <a:rPr sz="2400" b="1">
+                <a:solidFill>
+                  <a:srgbClr val="1F4E79"/>
+                </a:solidFill>
+                <a:latin typeface="Arial"/>
+              </a:rPr>
+              <a:t>Before the correction: the first poke and colour results</a:t>
+            </a:r>
+          </a:p>
+          <a:p>
+            <a:pPr>
+              <a:spcAft>
+                <a:spcPts val="0"/>
+              </a:spcAft>
+            </a:pPr>
+            <a:r>
+              <a:rPr sz="1250" b="0">
+                <a:solidFill>
+                  <a:srgbClr val="6E6E6E"/>
+                </a:solidFill>
+                <a:latin typeface="Arial"/>
+              </a:rPr>
+              <a:t>Kept for the record; every number on this slide is from the out-of-focus model</a:t>
+            </a:r>
+          </a:p>
+        </p:txBody>
+      </p:sp>
+      <p:sp>
+        <p:nvSpPr>
+          <p:cNvPr id="3" name="Rectangle 2"/>
+          <p:cNvSpPr/>
+          <p:nvPr/>
+        </p:nvSpPr>
+        <p:spPr>
+          <a:xfrm>
+            <a:off x="411480" y="1133856"/>
+            <a:ext cx="11368735" cy="20320"/>
+          </a:xfrm>
+          <a:prstGeom prst="rect">
+            <a:avLst/>
+          </a:prstGeom>
+          <a:solidFill>
+            <a:srgbClr val="B8C6D4"/>
+          </a:solidFill>
+          <a:ln>
+            <a:noFill/>
+          </a:ln>
+          <a:effectLst/>
+        </p:spPr>
+        <p:style>
+          <a:lnRef idx="1">
+            <a:schemeClr val="accent1"/>
+          </a:lnRef>
+          <a:fillRef idx="3">
+            <a:schemeClr val="accent1"/>
+          </a:fillRef>
+          <a:effectRef idx="2">
+            <a:schemeClr val="accent1"/>
+          </a:effectRef>
+          <a:fontRef idx="minor">
+            <a:schemeClr val="lt1"/>
+          </a:fontRef>
+        </p:style>
+        <p:txBody>
+          <a:bodyPr rtlCol="0" anchor="ctr"/>
+          <a:lstStyle/>
+          <a:p>
+            <a:pPr algn="ctr"/>
+          </a:p>
+        </p:txBody>
+      </p:sp>
       <p:pic>
         <p:nvPicPr>
           <p:cNvPr id="4" name="Picture 3" descr="zwfs_poke_triptych.png"/>
@@ -9670,7 +10507,7 @@
 </p:sld>
 </file>
 
-<file path=ppt/slides/slide22.xml><?xml version="1.0" encoding="utf-8"?>
+<file path=ppt/slides/slide23.xml><?xml version="1.0" encoding="utf-8"?>
 <p:sld xmlns:a="http://schemas.openxmlformats.org/drawingml/2006/main" xmlns:p="http://schemas.openxmlformats.org/presentationml/2006/main" xmlns:r="http://schemas.openxmlformats.org/officeDocument/2006/relationships">
   <p:cSld>
     <p:spTree>

</xml_diff>

<commit_message>
ZWFS V1: the polarized-dimple reading -- campaign brief section, deck slide 15 + loop table column + conclusion (DRAFT), slice
Co-Authored-By: Claude Fable 5.1 <noreply@anthropic.com>
</commit_message>
<xml_diff>
--- a/demo_session/deck_zwfs.pptx
+++ b/demo_session/deck_zwfs.pptx
@@ -28,6 +28,7 @@
     <p:sldId id="276" r:id="rId27"/>
     <p:sldId id="277" r:id="rId28"/>
     <p:sldId id="278" r:id="rId29"/>
+    <p:sldId id="279" r:id="rId30"/>
   </p:sldIdLst>
   <p:sldSz cx="12191695" cy="6858000" type="screen4x3"/>
   <p:notesSz cx="6858000" cy="9144000"/>
@@ -5921,7 +5922,7 @@
         </p:nvGraphicFramePr>
         <p:xfrm>
           <a:off x="6400800" y="1298448"/>
-          <a:ext cx="5394959" cy="2000250"/>
+          <a:ext cx="5394958" cy="2000250"/>
         </p:xfrm>
         <a:graphic>
           <a:graphicData uri="http://schemas.openxmlformats.org/drawingml/2006/table">
@@ -5930,10 +5931,11 @@
                 <a:tableStyleId>{5C22544A-7EE6-4342-B048-85BDC9FD1C3A}</a:tableStyleId>
               </a:tblPr>
               <a:tblGrid>
-                <a:gridCol w="1622874"/>
-                <a:gridCol w="1052675"/>
-                <a:gridCol w="921090"/>
-                <a:gridCol w="1798320"/>
+                <a:gridCol w="1304663"/>
+                <a:gridCol w="846268"/>
+                <a:gridCol w="740484"/>
+                <a:gridCol w="1445708"/>
+                <a:gridCol w="1057835"/>
               </a:tblGrid>
               <a:tr h="434340">
                 <a:tc>
@@ -6024,6 +6026,28 @@
                     </a:solidFill>
                   </a:tcPr>
                 </a:tc>
+                <a:tc>
+                  <a:txBody>
+                    <a:bodyPr wrap="square"/>
+                    <a:lstStyle/>
+                    <a:p>
+                      <a:r>
+                        <a:rPr sz="1000" b="1">
+                          <a:solidFill>
+                            <a:srgbClr val="FFFFFF"/>
+                          </a:solidFill>
+                          <a:latin typeface="Arial"/>
+                        </a:rPr>
+                        <a:t>polarized pair (V, next slide)</a:t>
+                      </a:r>
+                    </a:p>
+                  </a:txBody>
+                  <a:tcPr marL="54864" marR="54864" marT="18288" marB="18288">
+                    <a:solidFill>
+                      <a:srgbClr val="1F4E79"/>
+                    </a:solidFill>
+                  </a:tcPr>
+                </a:tc>
               </a:tr>
               <a:tr h="262890">
                 <a:tc>
@@ -6114,6 +6138,28 @@
                     </a:solidFill>
                   </a:tcPr>
                 </a:tc>
+                <a:tc>
+                  <a:txBody>
+                    <a:bodyPr wrap="square"/>
+                    <a:lstStyle/>
+                    <a:p>
+                      <a:r>
+                        <a:rPr sz="1000" b="0">
+                          <a:solidFill>
+                            <a:srgbClr val="282828"/>
+                          </a:solidFill>
+                          <a:latin typeface="Arial"/>
+                        </a:rPr>
+                        <a:t>1.5×10¹²</a:t>
+                      </a:r>
+                    </a:p>
+                  </a:txBody>
+                  <a:tcPr marL="54864" marR="54864" marT="18288" marB="18288">
+                    <a:solidFill>
+                      <a:srgbClr val="FFFFFF"/>
+                    </a:solidFill>
+                  </a:tcPr>
+                </a:tc>
               </a:tr>
               <a:tr h="434340">
                 <a:tc>
@@ -6204,6 +6250,28 @@
                     </a:solidFill>
                   </a:tcPr>
                 </a:tc>
+                <a:tc>
+                  <a:txBody>
+                    <a:bodyPr wrap="square"/>
+                    <a:lstStyle/>
+                    <a:p>
+                      <a:r>
+                        <a:rPr sz="1000" b="0">
+                          <a:solidFill>
+                            <a:srgbClr val="282828"/>
+                          </a:solidFill>
+                          <a:latin typeface="Arial"/>
+                        </a:rPr>
+                        <a:t>5.3×10¹²</a:t>
+                      </a:r>
+                    </a:p>
+                  </a:txBody>
+                  <a:tcPr marL="54864" marR="54864" marT="18288" marB="18288">
+                    <a:solidFill>
+                      <a:srgbClr val="ECF1F6"/>
+                    </a:solidFill>
+                  </a:tcPr>
+                </a:tc>
               </a:tr>
               <a:tr h="434340">
                 <a:tc>
@@ -6294,6 +6362,28 @@
                     </a:solidFill>
                   </a:tcPr>
                 </a:tc>
+                <a:tc>
+                  <a:txBody>
+                    <a:bodyPr wrap="square"/>
+                    <a:lstStyle/>
+                    <a:p>
+                      <a:r>
+                        <a:rPr sz="1000" b="0">
+                          <a:solidFill>
+                            <a:srgbClr val="282828"/>
+                          </a:solidFill>
+                          <a:latin typeface="Arial"/>
+                        </a:rPr>
+                        <a:t>9.9 pm</a:t>
+                      </a:r>
+                    </a:p>
+                  </a:txBody>
+                  <a:tcPr marL="54864" marR="54864" marT="18288" marB="18288">
+                    <a:solidFill>
+                      <a:srgbClr val="FFFFFF"/>
+                    </a:solidFill>
+                  </a:tcPr>
+                </a:tc>
               </a:tr>
               <a:tr h="434340">
                 <a:tc>
@@ -6353,6 +6443,28 @@
                           <a:latin typeface="Arial"/>
                         </a:rPr>
                         <a:t>99 nm</a:t>
+                      </a:r>
+                    </a:p>
+                  </a:txBody>
+                  <a:tcPr marL="54864" marR="54864" marT="18288" marB="18288">
+                    <a:solidFill>
+                      <a:srgbClr val="ECF1F6"/>
+                    </a:solidFill>
+                  </a:tcPr>
+                </a:tc>
+                <a:tc>
+                  <a:txBody>
+                    <a:bodyPr wrap="square"/>
+                    <a:lstStyle/>
+                    <a:p>
+                      <a:r>
+                        <a:rPr sz="1000" b="0">
+                          <a:solidFill>
+                            <a:srgbClr val="282828"/>
+                          </a:solidFill>
+                          <a:latin typeface="Arial"/>
+                        </a:rPr>
+                        <a:t>0.000 pm</a:t>
                       </a:r>
                     </a:p>
                   </a:txBody>
@@ -6535,7 +6647,7 @@
                 </a:solidFill>
                 <a:latin typeface="Arial"/>
               </a:rPr>
-              <a:t>Run it yourself</a:t>
+              <a:t>The polarized dimple: two images at once, no fold</a:t>
             </a:r>
           </a:p>
           <a:p>
@@ -6551,7 +6663,7 @@
                 </a:solidFill>
                 <a:latin typeface="Arial"/>
               </a:rPr>
-              <a:t>One parameter sheet and one script reproduce every number here; the defaults reproduce the stage-7 record to the last printed digit</a:t>
+              <a:t>A dimple that shifts the two circular polarizations by opposite phases gives an exact reading from two simultaneous frames; it is the best reading on every line</a:t>
             </a:r>
           </a:p>
         </p:txBody>
@@ -6600,16 +6712,40 @@
           </a:p>
         </p:txBody>
       </p:sp>
-      <p:sp>
-        <p:nvSpPr>
-          <p:cNvPr id="4" name="TextBox 3"/>
+      <p:pic>
+        <p:nvPicPr>
+          <p:cNvPr id="4" name="Picture 3" descr="crop_zwfs_vloop193_right.png"/>
+          <p:cNvPicPr>
+            <a:picLocks noChangeAspect="1"/>
+          </p:cNvPicPr>
+          <p:nvPr/>
+        </p:nvPicPr>
+        <p:blipFill>
+          <a:blip r:embed="rId2"/>
+          <a:stretch>
+            <a:fillRect/>
+          </a:stretch>
+        </p:blipFill>
+        <p:spPr>
+          <a:xfrm>
+            <a:off x="1639392" y="1298448"/>
+            <a:ext cx="3350615" cy="2823972"/>
+          </a:xfrm>
+          <a:prstGeom prst="rect">
+            <a:avLst/>
+          </a:prstGeom>
+        </p:spPr>
+      </p:pic>
+      <p:sp>
+        <p:nvSpPr>
+          <p:cNvPr id="5" name="TextBox 4"/>
           <p:cNvSpPr txBox="1"/>
           <p:nvPr/>
         </p:nvSpPr>
         <p:spPr>
           <a:xfrm>
-            <a:off x="411480" y="1298448"/>
-            <a:ext cx="11368735" cy="274320"/>
+            <a:off x="411480" y="4140708"/>
+            <a:ext cx="5806440" cy="559307"/>
           </a:xfrm>
           <a:prstGeom prst="rect">
             <a:avLst/>
@@ -6622,34 +6758,34 @@
           </a:bodyPr>
           <a:lstStyle/>
           <a:p>
-            <a:pPr>
+            <a:pPr algn="ctr">
               <a:spcAft>
-                <a:spcPts val="600"/>
+                <a:spcPts val="0"/>
               </a:spcAft>
             </a:pPr>
             <a:r>
-              <a:rPr sz="1500" b="0">
-                <a:solidFill>
-                  <a:srgbClr val="282828"/>
+              <a:rPr sz="1000" b="0">
+                <a:solidFill>
+                  <a:srgbClr val="6E6E6E"/>
                 </a:solidFill>
                 <a:latin typeface="Arial"/>
               </a:rPr>
-              <a:t>•  Two files: zwfs_params.m returns every setting at its value of record — grid and ray count, wavelength, the bench's lengths and tuned figures, the mask's etch and spot, the sampling checks, registration, the DM sizes, the test amplitudes and seeds, the color and photon stages.  zwfs_run.m runs the chosen stages and writes the report, a .mat file and the figures into a folder named by the run's tag.</a:t>
+              <a:t>Steady-state hold error against photons per cycle for the stepped reading (green) and the polarized-dimple pair (purple), under no drift (dotted), a 2 pm random walk (solid) and a 5 pm thermal ramp (dashed).  Right panel of the runner's figure.</a:t>
             </a:r>
           </a:p>
         </p:txBody>
       </p:sp>
       <p:graphicFrame>
         <p:nvGraphicFramePr>
-          <p:cNvPr id="5" name="Table 4"/>
+          <p:cNvPr id="6" name="Table 5"/>
           <p:cNvGraphicFramePr>
             <a:graphicFrameLocks noGrp="1"/>
           </p:cNvGraphicFramePr>
           <p:nvPr/>
         </p:nvGraphicFramePr>
         <p:xfrm>
-          <a:off x="411480" y="2465831"/>
-          <a:ext cx="11368735" cy="1680210"/>
+          <a:off x="6400800" y="1298448"/>
+          <a:ext cx="5394960" cy="2354580"/>
         </p:xfrm>
         <a:graphic>
           <a:graphicData uri="http://schemas.openxmlformats.org/drawingml/2006/table">
@@ -6658,23 +6794,24 @@
                 <a:tableStyleId>{5C22544A-7EE6-4342-B048-85BDC9FD1C3A}</a:tableStyleId>
               </a:tblPr>
               <a:tblGrid>
-                <a:gridCol w="6601201"/>
-                <a:gridCol w="4767534"/>
+                <a:gridCol w="2697480"/>
+                <a:gridCol w="1198880"/>
+                <a:gridCol w="1498600"/>
               </a:tblGrid>
-              <a:tr h="280035">
-                <a:tc>
-                  <a:txBody>
-                    <a:bodyPr wrap="square"/>
-                    <a:lstStyle/>
-                    <a:p>
-                      <a:r>
-                        <a:rPr sz="1100" b="1">
+              <a:tr h="434340">
+                <a:tc>
+                  <a:txBody>
+                    <a:bodyPr wrap="square"/>
+                    <a:lstStyle/>
+                    <a:p>
+                      <a:r>
+                        <a:rPr sz="1000" b="1">
                           <a:solidFill>
                             <a:srgbClr val="FFFFFF"/>
                           </a:solidFill>
                           <a:latin typeface="Arial"/>
                         </a:rPr>
-                        <a:t>call</a:t>
+                        <a:t>matrix measured on the 30 nm surface; 193 rays</a:t>
                       </a:r>
                     </a:p>
                   </a:txBody>
@@ -6690,13 +6827,13 @@
                     <a:lstStyle/>
                     <a:p>
                       <a:r>
-                        <a:rPr sz="1100" b="1">
+                        <a:rPr sz="1000" b="1">
                           <a:solidFill>
                             <a:srgbClr val="FFFFFF"/>
                           </a:solidFill>
                           <a:latin typeface="Arial"/>
                         </a:rPr>
-                        <a:t>what it does</a:t>
+                        <a:t>stepped (S), four frames</a:t>
                       </a:r>
                     </a:p>
                   </a:txBody>
@@ -6706,21 +6843,43 @@
                     </a:solidFill>
                   </a:tcPr>
                 </a:tc>
+                <a:tc>
+                  <a:txBody>
+                    <a:bodyPr wrap="square"/>
+                    <a:lstStyle/>
+                    <a:p>
+                      <a:r>
+                        <a:rPr sz="1000" b="1">
+                          <a:solidFill>
+                            <a:srgbClr val="FFFFFF"/>
+                          </a:solidFill>
+                          <a:latin typeface="Arial"/>
+                        </a:rPr>
+                        <a:t>polarized pair (V), two frames</a:t>
+                      </a:r>
+                    </a:p>
+                  </a:txBody>
+                  <a:tcPr marL="54864" marR="54864" marT="18288" marB="18288">
+                    <a:solidFill>
+                      <a:srgbClr val="1F4E79"/>
+                    </a:solidFill>
+                  </a:tcPr>
+                </a:tc>
               </a:tr>
-              <a:tr h="280035">
-                <a:tc>
-                  <a:txBody>
-                    <a:bodyPr wrap="square"/>
-                    <a:lstStyle/>
-                    <a:p>
-                      <a:r>
-                        <a:rPr sz="1100" b="0">
-                          <a:solidFill>
-                            <a:srgbClr val="282828"/>
-                          </a:solidFill>
-                          <a:latin typeface="Arial"/>
-                        </a:rPr>
-                        <a:t>zwfs_run</a:t>
+              <a:tr h="262890">
+                <a:tc>
+                  <a:txBody>
+                    <a:bodyPr wrap="square"/>
+                    <a:lstStyle/>
+                    <a:p>
+                      <a:r>
+                        <a:rPr sz="1000" b="0">
+                          <a:solidFill>
+                            <a:srgbClr val="282828"/>
+                          </a:solidFill>
+                          <a:latin typeface="Arial"/>
+                        </a:rPr>
+                        <a:t>single 10 nm change: gain, floor</a:t>
                       </a:r>
                     </a:p>
                   </a:txBody>
@@ -6736,13 +6895,13 @@
                     <a:lstStyle/>
                     <a:p>
                       <a:r>
-                        <a:rPr sz="1100" b="0">
-                          <a:solidFill>
-                            <a:srgbClr val="282828"/>
-                          </a:solidFill>
-                          <a:latin typeface="Arial"/>
-                        </a:rPr>
-                        <a:t>the record: bench checks, the full test set, figures</a:t>
+                        <a:rPr sz="1000" b="0">
+                          <a:solidFill>
+                            <a:srgbClr val="282828"/>
+                          </a:solidFill>
+                          <a:latin typeface="Arial"/>
+                        </a:rPr>
+                        <a:t>0.989, 5 pm</a:t>
                       </a:r>
                     </a:p>
                   </a:txBody>
@@ -6752,21 +6911,43 @@
                     </a:solidFill>
                   </a:tcPr>
                 </a:tc>
+                <a:tc>
+                  <a:txBody>
+                    <a:bodyPr wrap="square"/>
+                    <a:lstStyle/>
+                    <a:p>
+                      <a:r>
+                        <a:rPr sz="1000" b="0">
+                          <a:solidFill>
+                            <a:srgbClr val="282828"/>
+                          </a:solidFill>
+                          <a:latin typeface="Arial"/>
+                        </a:rPr>
+                        <a:t>0.994, 4 pm</a:t>
+                      </a:r>
+                    </a:p>
+                  </a:txBody>
+                  <a:tcPr marL="54864" marR="54864" marT="18288" marB="18288">
+                    <a:solidFill>
+                      <a:srgbClr val="FFFFFF"/>
+                    </a:solidFill>
+                  </a:tcPr>
+                </a:tc>
               </a:tr>
-              <a:tr h="280035">
-                <a:tc>
-                  <a:txBody>
-                    <a:bodyPr wrap="square"/>
-                    <a:lstStyle/>
-                    <a:p>
-                      <a:r>
-                        <a:rPr sz="1100" b="0">
-                          <a:solidFill>
-                            <a:srgbClr val="282828"/>
-                          </a:solidFill>
-                          <a:latin typeface="Arial"/>
-                        </a:rPr>
-                        <a:t>zwfs_run('tag','ng385', 'NGRID',385)</a:t>
+              <a:tr h="262890">
+                <a:tc>
+                  <a:txBody>
+                    <a:bodyPr wrap="square"/>
+                    <a:lstStyle/>
+                    <a:p>
+                      <a:r>
+                        <a:rPr sz="1000" b="0">
+                          <a:solidFill>
+                            <a:srgbClr val="282828"/>
+                          </a:solidFill>
+                          <a:latin typeface="Arial"/>
+                        </a:rPr>
+                        <a:t>47 actuators changed 1 nm</a:t>
                       </a:r>
                     </a:p>
                   </a:txBody>
@@ -6782,13 +6963,13 @@
                     <a:lstStyle/>
                     <a:p>
                       <a:r>
-                        <a:rPr sz="1100" b="0">
-                          <a:solidFill>
-                            <a:srgbClr val="282828"/>
-                          </a:solidFill>
-                          <a:latin typeface="Arial"/>
-                        </a:rPr>
-                        <a:t>the 1-megapixel camera</a:t>
+                        <a:rPr sz="1000" b="0">
+                          <a:solidFill>
+                            <a:srgbClr val="282828"/>
+                          </a:solidFill>
+                          <a:latin typeface="Arial"/>
+                        </a:rPr>
+                        <a:t>0.999, 4 pm</a:t>
                       </a:r>
                     </a:p>
                   </a:txBody>
@@ -6798,21 +6979,43 @@
                     </a:solidFill>
                   </a:tcPr>
                 </a:tc>
+                <a:tc>
+                  <a:txBody>
+                    <a:bodyPr wrap="square"/>
+                    <a:lstStyle/>
+                    <a:p>
+                      <a:r>
+                        <a:rPr sz="1000" b="0">
+                          <a:solidFill>
+                            <a:srgbClr val="282828"/>
+                          </a:solidFill>
+                          <a:latin typeface="Arial"/>
+                        </a:rPr>
+                        <a:t>0.999, 3 pm</a:t>
+                      </a:r>
+                    </a:p>
+                  </a:txBody>
+                  <a:tcPr marL="54864" marR="54864" marT="18288" marB="18288">
+                    <a:solidFill>
+                      <a:srgbClr val="ECF1F6"/>
+                    </a:solidFill>
+                  </a:tcPr>
+                </a:tc>
               </a:tr>
-              <a:tr h="280035">
-                <a:tc>
-                  <a:txBody>
-                    <a:bodyPr wrap="square"/>
-                    <a:lstStyle/>
-                    <a:p>
-                      <a:r>
-                        <a:rPr sz="1100" b="0">
-                          <a:solidFill>
-                            <a:srgbClr val="282828"/>
-                          </a:solidFill>
-                          <a:latin typeface="Arial"/>
-                        </a:rPr>
-                        <a:t>zwfs_run('MODEL',2048, 'NGRID',385, 'param_file','macos_param_2048.txt')</a:t>
+              <a:tr h="262890">
+                <a:tc>
+                  <a:txBody>
+                    <a:bodyPr wrap="square"/>
+                    <a:lstStyle/>
+                    <a:p>
+                      <a:r>
+                        <a:rPr sz="1000" b="0">
+                          <a:solidFill>
+                            <a:srgbClr val="282828"/>
+                          </a:solidFill>
+                          <a:latin typeface="Arial"/>
+                        </a:rPr>
+                        <a:t>dense random 10 nm: gain, error</a:t>
                       </a:r>
                     </a:p>
                   </a:txBody>
@@ -6828,13 +7031,13 @@
                     <a:lstStyle/>
                     <a:p>
                       <a:r>
-                        <a:rPr sz="1100" b="0">
-                          <a:solidFill>
-                            <a:srgbClr val="282828"/>
-                          </a:solidFill>
-                          <a:latin typeface="Arial"/>
-                        </a:rPr>
-                        <a:t>the fully sampled setup on a 30 GB machine</a:t>
+                        <a:rPr sz="1000" b="0">
+                          <a:solidFill>
+                            <a:srgbClr val="282828"/>
+                          </a:solidFill>
+                          <a:latin typeface="Arial"/>
+                        </a:rPr>
+                        <a:t>0.98, 0.68 nm</a:t>
                       </a:r>
                     </a:p>
                   </a:txBody>
@@ -6844,21 +7047,43 @@
                     </a:solidFill>
                   </a:tcPr>
                 </a:tc>
+                <a:tc>
+                  <a:txBody>
+                    <a:bodyPr wrap="square"/>
+                    <a:lstStyle/>
+                    <a:p>
+                      <a:r>
+                        <a:rPr sz="1000" b="0">
+                          <a:solidFill>
+                            <a:srgbClr val="282828"/>
+                          </a:solidFill>
+                          <a:latin typeface="Arial"/>
+                        </a:rPr>
+                        <a:t>1.000, 0.33 nm</a:t>
+                      </a:r>
+                    </a:p>
+                  </a:txBody>
+                  <a:tcPr marL="54864" marR="54864" marT="18288" marB="18288">
+                    <a:solidFill>
+                      <a:srgbClr val="FFFFFF"/>
+                    </a:solidFill>
+                  </a:tcPr>
+                </a:tc>
               </a:tr>
-              <a:tr h="280035">
-                <a:tc>
-                  <a:txBody>
-                    <a:bodyPr wrap="square"/>
-                    <a:lstStyle/>
-                    <a:p>
-                      <a:r>
-                        <a:rPr sz="1100" b="0">
-                          <a:solidFill>
-                            <a:srgbClr val="282828"/>
-                          </a:solidFill>
-                          <a:latin typeface="Arial"/>
-                        </a:rPr>
-                        <a:t>zwfs_run('stages',{'battery','color','noise','figs'})</a:t>
+              <a:tr h="434340">
+                <a:tc>
+                  <a:txBody>
+                    <a:bodyPr wrap="square"/>
+                    <a:lstStyle/>
+                    <a:p>
+                      <a:r>
+                        <a:rPr sz="1000" b="0">
+                          <a:solidFill>
+                            <a:srgbClr val="282828"/>
+                          </a:solidFill>
+                          <a:latin typeface="Arial"/>
+                        </a:rPr>
+                        <a:t>gain at 40 / 50 / 60 nm rms with the 30 nm calibration</a:t>
                       </a:r>
                     </a:p>
                   </a:txBody>
@@ -6874,13 +7099,13 @@
                     <a:lstStyle/>
                     <a:p>
                       <a:r>
-                        <a:rPr sz="1100" b="0">
-                          <a:solidFill>
-                            <a:srgbClr val="282828"/>
-                          </a:solidFill>
-                          <a:latin typeface="Arial"/>
-                        </a:rPr>
-                        <a:t>everything on this deck's later slides</a:t>
+                        <a:rPr sz="1000" b="0">
+                          <a:solidFill>
+                            <a:srgbClr val="282828"/>
+                          </a:solidFill>
+                          <a:latin typeface="Arial"/>
+                        </a:rPr>
+                        <a:t>0.91 / 0.86 / 0.66</a:t>
                       </a:r>
                     </a:p>
                   </a:txBody>
@@ -6890,21 +7115,43 @@
                     </a:solidFill>
                   </a:tcPr>
                 </a:tc>
+                <a:tc>
+                  <a:txBody>
+                    <a:bodyPr wrap="square"/>
+                    <a:lstStyle/>
+                    <a:p>
+                      <a:r>
+                        <a:rPr sz="1000" b="0">
+                          <a:solidFill>
+                            <a:srgbClr val="282828"/>
+                          </a:solidFill>
+                          <a:latin typeface="Arial"/>
+                        </a:rPr>
+                        <a:t>0.996 / 0.991 / 0.981</a:t>
+                      </a:r>
+                    </a:p>
+                  </a:txBody>
+                  <a:tcPr marL="54864" marR="54864" marT="18288" marB="18288">
+                    <a:solidFill>
+                      <a:srgbClr val="ECF1F6"/>
+                    </a:solidFill>
+                  </a:tcPr>
+                </a:tc>
               </a:tr>
-              <a:tr h="280035">
-                <a:tc>
-                  <a:txBody>
-                    <a:bodyPr wrap="square"/>
-                    <a:lstStyle/>
-                    <a:p>
-                      <a:r>
-                        <a:rPr sz="1100" b="0">
-                          <a:solidFill>
-                            <a:srgbClr val="282828"/>
-                          </a:solidFill>
-                          <a:latin typeface="Arial"/>
-                        </a:rPr>
-                        <a:t>./zwfs_batch.sh TAG "the same arguments"</a:t>
+              <a:tr h="262890">
+                <a:tc>
+                  <a:txBody>
+                    <a:bodyPr wrap="square"/>
+                    <a:lstStyle/>
+                    <a:p>
+                      <a:r>
+                        <a:rPr sz="1000" b="0">
+                          <a:solidFill>
+                            <a:srgbClr val="282828"/>
+                          </a:solidFill>
+                          <a:latin typeface="Arial"/>
+                        </a:rPr>
+                        <a:t>photons per measurement for 1 pm</a:t>
                       </a:r>
                     </a:p>
                   </a:txBody>
@@ -6920,19 +7167,109 @@
                     <a:lstStyle/>
                     <a:p>
                       <a:r>
-                        <a:rPr sz="1100" b="0">
-                          <a:solidFill>
-                            <a:srgbClr val="282828"/>
-                          </a:solidFill>
-                          <a:latin typeface="Arial"/>
-                        </a:rPr>
-                        <a:t>unattended, memory-capped, logged</a:t>
+                        <a:rPr sz="1000" b="0">
+                          <a:solidFill>
+                            <a:srgbClr val="282828"/>
+                          </a:solidFill>
+                          <a:latin typeface="Arial"/>
+                        </a:rPr>
+                        <a:t>5.6×10¹³</a:t>
                       </a:r>
                     </a:p>
                   </a:txBody>
                   <a:tcPr marL="54864" marR="54864" marT="18288" marB="18288">
                     <a:solidFill>
                       <a:srgbClr val="FFFFFF"/>
+                    </a:solidFill>
+                  </a:tcPr>
+                </a:tc>
+                <a:tc>
+                  <a:txBody>
+                    <a:bodyPr wrap="square"/>
+                    <a:lstStyle/>
+                    <a:p>
+                      <a:r>
+                        <a:rPr sz="1000" b="0">
+                          <a:solidFill>
+                            <a:srgbClr val="282828"/>
+                          </a:solidFill>
+                          <a:latin typeface="Arial"/>
+                        </a:rPr>
+                        <a:t>4.7×10¹³</a:t>
+                      </a:r>
+                    </a:p>
+                  </a:txBody>
+                  <a:tcPr marL="54864" marR="54864" marT="18288" marB="18288">
+                    <a:solidFill>
+                      <a:srgbClr val="FFFFFF"/>
+                    </a:solidFill>
+                  </a:tcPr>
+                </a:tc>
+              </a:tr>
+              <a:tr h="434340">
+                <a:tc>
+                  <a:txBody>
+                    <a:bodyPr wrap="square"/>
+                    <a:lstStyle/>
+                    <a:p>
+                      <a:r>
+                        <a:rPr sz="1000" b="0">
+                          <a:solidFill>
+                            <a:srgbClr val="282828"/>
+                          </a:solidFill>
+                          <a:latin typeface="Arial"/>
+                        </a:rPr>
+                        <a:t>held to 3 pm in closed loop: noise only / 2 pm walk</a:t>
+                      </a:r>
+                    </a:p>
+                  </a:txBody>
+                  <a:tcPr marL="54864" marR="54864" marT="18288" marB="18288">
+                    <a:solidFill>
+                      <a:srgbClr val="ECF1F6"/>
+                    </a:solidFill>
+                  </a:tcPr>
+                </a:tc>
+                <a:tc>
+                  <a:txBody>
+                    <a:bodyPr wrap="square"/>
+                    <a:lstStyle/>
+                    <a:p>
+                      <a:r>
+                        <a:rPr sz="1000" b="0">
+                          <a:solidFill>
+                            <a:srgbClr val="282828"/>
+                          </a:solidFill>
+                          <a:latin typeface="Arial"/>
+                        </a:rPr>
+                        <a:t>2.6×10¹² / 7.5×10¹²</a:t>
+                      </a:r>
+                    </a:p>
+                  </a:txBody>
+                  <a:tcPr marL="54864" marR="54864" marT="18288" marB="18288">
+                    <a:solidFill>
+                      <a:srgbClr val="ECF1F6"/>
+                    </a:solidFill>
+                  </a:tcPr>
+                </a:tc>
+                <a:tc>
+                  <a:txBody>
+                    <a:bodyPr wrap="square"/>
+                    <a:lstStyle/>
+                    <a:p>
+                      <a:r>
+                        <a:rPr sz="1000" b="0">
+                          <a:solidFill>
+                            <a:srgbClr val="282828"/>
+                          </a:solidFill>
+                          <a:latin typeface="Arial"/>
+                        </a:rPr>
+                        <a:t>1.5×10¹² / 5.3×10¹²</a:t>
+                      </a:r>
+                    </a:p>
+                  </a:txBody>
+                  <a:tcPr marL="54864" marR="54864" marT="18288" marB="18288">
+                    <a:solidFill>
+                      <a:srgbClr val="ECF1F6"/>
                     </a:solidFill>
                   </a:tcPr>
                 </a:tc>
@@ -6943,14 +7280,14 @@
       </p:graphicFrame>
       <p:sp>
         <p:nvSpPr>
-          <p:cNvPr id="6" name="TextBox 5"/>
+          <p:cNvPr id="7" name="TextBox 6"/>
           <p:cNvSpPr txBox="1"/>
           <p:nvPr/>
         </p:nvSpPr>
         <p:spPr>
           <a:xfrm>
-            <a:off x="411480" y="4292346"/>
-            <a:ext cx="11368735" cy="274320"/>
+            <a:off x="6400800" y="3799331"/>
+            <a:ext cx="5394960" cy="274320"/>
           </a:xfrm>
           <a:prstGeom prst="rect">
             <a:avLst/>
@@ -6969,27 +7306,43 @@
               </a:spcAft>
             </a:pPr>
             <a:r>
-              <a:rPr sz="1500" b="0">
+              <a:rPr sz="1200" b="0">
                 <a:solidFill>
                   <a:srgbClr val="282828"/>
                 </a:solidFill>
                 <a:latin typeface="Arial"/>
               </a:rPr>
-              <a:t>•  Checks that run every time: the no-mask round trip through the bracket (must return the field unchanged); the reference-wave model against the engine's own field; the pupil brightness must not change with the DM shape; the sampling checks (pixels across the dimple, camera pixels per actuator); and the search for the camera-to-DM mirror/transpose and sign.</a:t>
-            </a:r>
-          </a:p>
-        </p:txBody>
-      </p:sp>
-      <p:sp>
-        <p:nvSpPr>
-          <p:cNvPr id="7" name="TextBox 6"/>
+              <a:t>•  How it works: a geometric-phase (metasurface) dimple applies +90° to one circular polarization and −90° to the other; a polarization splitter behind the pupil relay gives both pupil images in one exposure.  Per pixel the difference of the pair gives the sine of the phase and the sum the cosine, so the phase is solved exactly with no sign fold, and the reference wave is refined as for the exact reading.</a:t>
+            </a:r>
+          </a:p>
+          <a:p>
+            <a:pPr>
+              <a:spcAft>
+                <a:spcPts val="600"/>
+              </a:spcAft>
+            </a:pPr>
+            <a:r>
+              <a:rPr sz="1200" b="0">
+                <a:solidFill>
+                  <a:srgbClr val="282828"/>
+                </a:solidFill>
+                <a:latin typeface="Arial"/>
+              </a:rPr>
+              <a:t>•  What it buys: the one-frame exact reading's fold is gone (a 100 nm poke reads to 0.05 pm where the single frame errs by 9 nm), the calibration ages five times slower, and nothing moves between the two frames.  What it does not change: the sensor's range is still set by the focal core (all readings fail past 120 nm rms) and by half a wavelength.</a:t>
+            </a:r>
+          </a:p>
+        </p:txBody>
+      </p:sp>
+      <p:sp>
+        <p:nvSpPr>
+          <p:cNvPr id="8" name="TextBox 7"/>
           <p:cNvSpPr txBox="1"/>
           <p:nvPr/>
         </p:nvSpPr>
         <p:spPr>
           <a:xfrm>
-            <a:off x="411480" y="5459730"/>
-            <a:ext cx="11368735" cy="274320"/>
+            <a:off x="6400800" y="6295643"/>
+            <a:ext cx="5394960" cy="274320"/>
           </a:xfrm>
           <a:prstGeom prst="rect">
             <a:avLst/>
@@ -7014,7 +7367,7 @@
                 </a:solidFill>
                 <a:latin typeface="Arial"/>
               </a:rPr>
-              <a:t>Reproduction check: 64 lines of results against the stage-7 report, 8 differ in the last printed digit (the actuator fit's solver tolerance).  README "Run it yourself" carries the parameter table.</a:t>
+              <a:t>Ideal metasurface: each image is the scalar sensor with its own dimple sign.  Next: metasurface retardance error, the arm's polarization aberrations, the stepped reading's between-frame drift.  Records: runs/v193base, v193noise, vloop193.</a:t>
             </a:r>
           </a:p>
         </p:txBody>
@@ -7071,7 +7424,7 @@
                 </a:solidFill>
                 <a:latin typeface="Arial"/>
               </a:rPr>
-              <a:t>Side by side with the Twyman–Green</a:t>
+              <a:t>Run it yourself</a:t>
             </a:r>
           </a:p>
           <a:p>
@@ -7087,7 +7440,7 @@
                 </a:solidFill>
                 <a:latin typeface="Arial"/>
               </a:rPr>
-              <a:t>The interferometer loses response at fine patterns and never fails; the sensor, calibrated on its working surface, reads a change to 5 pm up to 50–60 nm</a:t>
+              <a:t>One parameter sheet and one script reproduce every number here; the defaults reproduce the stage-7 record to the last printed digit</a:t>
             </a:r>
           </a:p>
         </p:txBody>
@@ -7136,17 +7489,56 @@
           </a:p>
         </p:txBody>
       </p:sp>
+      <p:sp>
+        <p:nvSpPr>
+          <p:cNvPr id="4" name="TextBox 3"/>
+          <p:cNvSpPr txBox="1"/>
+          <p:nvPr/>
+        </p:nvSpPr>
+        <p:spPr>
+          <a:xfrm>
+            <a:off x="411480" y="1298448"/>
+            <a:ext cx="11368735" cy="274320"/>
+          </a:xfrm>
+          <a:prstGeom prst="rect">
+            <a:avLst/>
+          </a:prstGeom>
+          <a:noFill/>
+        </p:spPr>
+        <p:txBody>
+          <a:bodyPr wrap="square">
+            <a:spAutoFit/>
+          </a:bodyPr>
+          <a:lstStyle/>
+          <a:p>
+            <a:pPr>
+              <a:spcAft>
+                <a:spcPts val="600"/>
+              </a:spcAft>
+            </a:pPr>
+            <a:r>
+              <a:rPr sz="1500" b="0">
+                <a:solidFill>
+                  <a:srgbClr val="282828"/>
+                </a:solidFill>
+                <a:latin typeface="Arial"/>
+              </a:rPr>
+              <a:t>•  Two files: zwfs_params.m returns every setting at its value of record — grid and ray count, wavelength, the bench's lengths and tuned figures, the mask's etch and spot, the sampling checks, registration, the DM sizes, the test amplitudes and seeds, the color and photon stages.  zwfs_run.m runs the chosen stages and writes the report, a .mat file and the figures into a folder named by the run's tag.</a:t>
+            </a:r>
+          </a:p>
+        </p:txBody>
+      </p:sp>
       <p:graphicFrame>
         <p:nvGraphicFramePr>
-          <p:cNvPr id="4" name="Table 3"/>
+          <p:cNvPr id="5" name="Table 4"/>
           <p:cNvGraphicFramePr>
             <a:graphicFrameLocks noGrp="1"/>
           </p:cNvGraphicFramePr>
           <p:nvPr/>
         </p:nvGraphicFramePr>
         <p:xfrm>
-          <a:off x="411480" y="1298448"/>
-          <a:ext cx="11368733" cy="4023360"/>
+          <a:off x="411480" y="2465831"/>
+          <a:ext cx="11368735" cy="1680210"/>
         </p:xfrm>
         <a:graphic>
           <a:graphicData uri="http://schemas.openxmlformats.org/drawingml/2006/table">
@@ -7155,16 +7547,25 @@
                 <a:tableStyleId>{5C22544A-7EE6-4342-B048-85BDC9FD1C3A}</a:tableStyleId>
               </a:tblPr>
               <a:tblGrid>
-                <a:gridCol w="3608337"/>
-                <a:gridCol w="2224317"/>
-                <a:gridCol w="5536079"/>
+                <a:gridCol w="6601201"/>
+                <a:gridCol w="4767534"/>
               </a:tblGrid>
               <a:tr h="280035">
                 <a:tc>
                   <a:txBody>
                     <a:bodyPr wrap="square"/>
                     <a:lstStyle/>
-                    <a:p/>
+                    <a:p>
+                      <a:r>
+                        <a:rPr sz="1100" b="1">
+                          <a:solidFill>
+                            <a:srgbClr val="FFFFFF"/>
+                          </a:solidFill>
+                          <a:latin typeface="Arial"/>
+                        </a:rPr>
+                        <a:t>call</a:t>
+                      </a:r>
+                    </a:p>
                   </a:txBody>
                   <a:tcPr marL="54864" marR="54864" marT="18288" marB="18288">
                     <a:solidFill>
@@ -7184,29 +7585,7 @@
                           </a:solidFill>
                           <a:latin typeface="Arial"/>
                         </a:rPr>
-                        <a:t>Twyman–Green PSI (measured)</a:t>
-                      </a:r>
-                    </a:p>
-                  </a:txBody>
-                  <a:tcPr marL="54864" marR="54864" marT="18288" marB="18288">
-                    <a:solidFill>
-                      <a:srgbClr val="1F4E79"/>
-                    </a:solidFill>
-                  </a:tcPr>
-                </a:tc>
-                <a:tc>
-                  <a:txBody>
-                    <a:bodyPr wrap="square"/>
-                    <a:lstStyle/>
-                    <a:p>
-                      <a:r>
-                        <a:rPr sz="1100" b="1">
-                          <a:solidFill>
-                            <a:srgbClr val="FFFFFF"/>
-                          </a:solidFill>
-                          <a:latin typeface="Arial"/>
-                        </a:rPr>
-                        <a:t>Zernike sensor (measured)</a:t>
+                        <a:t>what it does</a:t>
                       </a:r>
                     </a:p>
                   </a:txBody>
@@ -7230,7 +7609,7 @@
                           </a:solidFill>
                           <a:latin typeface="Arial"/>
                         </a:rPr>
-                        <a:t>reference beam</a:t>
+                        <a:t>zwfs_run</a:t>
                       </a:r>
                     </a:p>
                   </a:txBody>
@@ -7252,165 +7631,7 @@
                           </a:solidFill>
                           <a:latin typeface="Arial"/>
                         </a:rPr>
-                        <a:t>the second arm's flat</a:t>
-                      </a:r>
-                    </a:p>
-                  </a:txBody>
-                  <a:tcPr marL="54864" marR="54864" marT="18288" marB="18288">
-                    <a:solidFill>
-                      <a:srgbClr val="FFFFFF"/>
-                    </a:solidFill>
-                  </a:tcPr>
-                </a:tc>
-                <a:tc>
-                  <a:txBody>
-                    <a:bodyPr wrap="square"/>
-                    <a:lstStyle/>
-                    <a:p>
-                      <a:r>
-                        <a:rPr sz="1100" b="0">
-                          <a:solidFill>
-                            <a:srgbClr val="282828"/>
-                          </a:solidFill>
-                          <a:latin typeface="Arial"/>
-                        </a:rPr>
-                        <a:t>made from the beam's own focal core</a:t>
-                      </a:r>
-                    </a:p>
-                  </a:txBody>
-                  <a:tcPr marL="54864" marR="54864" marT="18288" marB="18288">
-                    <a:solidFill>
-                      <a:srgbClr val="FFFFFF"/>
-                    </a:solidFill>
-                  </a:tcPr>
-                </a:tc>
-              </a:tr>
-              <a:tr h="468630">
-                <a:tc>
-                  <a:txBody>
-                    <a:bodyPr wrap="square"/>
-                    <a:lstStyle/>
-                    <a:p>
-                      <a:r>
-                        <a:rPr sz="1100" b="0">
-                          <a:solidFill>
-                            <a:srgbClr val="282828"/>
-                          </a:solidFill>
-                          <a:latin typeface="Arial"/>
-                        </a:rPr>
-                        <a:t>one measurement costs</a:t>
-                      </a:r>
-                    </a:p>
-                  </a:txBody>
-                  <a:tcPr marL="54864" marR="54864" marT="18288" marB="18288">
-                    <a:solidFill>
-                      <a:srgbClr val="ECF1F6"/>
-                    </a:solidFill>
-                  </a:tcPr>
-                </a:tc>
-                <a:tc>
-                  <a:txBody>
-                    <a:bodyPr wrap="square"/>
-                    <a:lstStyle/>
-                    <a:p>
-                      <a:r>
-                        <a:rPr sz="1100" b="0">
-                          <a:solidFill>
-                            <a:srgbClr val="282828"/>
-                          </a:solidFill>
-                          <a:latin typeface="Arial"/>
-                        </a:rPr>
-                        <a:t>6 traces (3 per arm), 4 fringe frames</a:t>
-                      </a:r>
-                    </a:p>
-                  </a:txBody>
-                  <a:tcPr marL="54864" marR="54864" marT="18288" marB="18288">
-                    <a:solidFill>
-                      <a:srgbClr val="ECF1F6"/>
-                    </a:solidFill>
-                  </a:tcPr>
-                </a:tc>
-                <a:tc>
-                  <a:txBody>
-                    <a:bodyPr wrap="square"/>
-                    <a:lstStyle/>
-                    <a:p>
-                      <a:r>
-                        <a:rPr sz="1100" b="0">
-                          <a:solidFill>
-                            <a:srgbClr val="282828"/>
-                          </a:solidFill>
-                          <a:latin typeface="Arial"/>
-                        </a:rPr>
-                        <a:t>1 or 4 camera frames; 256 calibration frames once per working surface</a:t>
-                      </a:r>
-                    </a:p>
-                  </a:txBody>
-                  <a:tcPr marL="54864" marR="54864" marT="18288" marB="18288">
-                    <a:solidFill>
-                      <a:srgbClr val="ECF1F6"/>
-                    </a:solidFill>
-                  </a:tcPr>
-                </a:tc>
-              </a:tr>
-              <a:tr h="468630">
-                <a:tc>
-                  <a:txBody>
-                    <a:bodyPr wrap="square"/>
-                    <a:lstStyle/>
-                    <a:p>
-                      <a:r>
-                        <a:rPr sz="1100" b="0">
-                          <a:solidFill>
-                            <a:srgbClr val="282828"/>
-                          </a:solidFill>
-                          <a:latin typeface="Arial"/>
-                        </a:rPr>
-                        <a:t>polarization hardware</a:t>
-                      </a:r>
-                    </a:p>
-                  </a:txBody>
-                  <a:tcPr marL="54864" marR="54864" marT="18288" marB="18288">
-                    <a:solidFill>
-                      <a:srgbClr val="FFFFFF"/>
-                    </a:solidFill>
-                  </a:tcPr>
-                </a:tc>
-                <a:tc>
-                  <a:txBody>
-                    <a:bodyPr wrap="square"/>
-                    <a:lstStyle/>
-                    <a:p>
-                      <a:r>
-                        <a:rPr sz="1100" b="0">
-                          <a:solidFill>
-                            <a:srgbClr val="282828"/>
-                          </a:solidFill>
-                          <a:latin typeface="Arial"/>
-                        </a:rPr>
-                        <a:t>polarizer, 5 waveplates, analyzer</a:t>
-                      </a:r>
-                    </a:p>
-                  </a:txBody>
-                  <a:tcPr marL="54864" marR="54864" marT="18288" marB="18288">
-                    <a:solidFill>
-                      <a:srgbClr val="FFFFFF"/>
-                    </a:solidFill>
-                  </a:tcPr>
-                </a:tc>
-                <a:tc>
-                  <a:txBody>
-                    <a:bodyPr wrap="square"/>
-                    <a:lstStyle/>
-                    <a:p>
-                      <a:r>
-                        <a:rPr sz="1100" b="0">
-                          <a:solidFill>
-                            <a:srgbClr val="282828"/>
-                          </a:solidFill>
-                          <a:latin typeface="Arial"/>
-                        </a:rPr>
-                        <a:t>none</a:t>
+                        <a:t>the record: bench checks, the full test set, figures</a:t>
                       </a:r>
                     </a:p>
                   </a:txBody>
@@ -7434,7 +7655,7 @@
                           </a:solidFill>
                           <a:latin typeface="Arial"/>
                         </a:rPr>
-                        <a:t>moving parts</a:t>
+                        <a:t>zwfs_run('tag','ng385', 'NGRID',385)</a:t>
                       </a:r>
                     </a:p>
                   </a:txBody>
@@ -7456,29 +7677,7 @@
                           </a:solidFill>
                           <a:latin typeface="Arial"/>
                         </a:rPr>
-                        <a:t>none (polarization-stepped)</a:t>
-                      </a:r>
-                    </a:p>
-                  </a:txBody>
-                  <a:tcPr marL="54864" marR="54864" marT="18288" marB="18288">
-                    <a:solidFill>
-                      <a:srgbClr val="ECF1F6"/>
-                    </a:solidFill>
-                  </a:tcPr>
-                </a:tc>
-                <a:tc>
-                  <a:txBody>
-                    <a:bodyPr wrap="square"/>
-                    <a:lstStyle/>
-                    <a:p>
-                      <a:r>
-                        <a:rPr sz="1100" b="0">
-                          <a:solidFill>
-                            <a:srgbClr val="282828"/>
-                          </a:solidFill>
-                          <a:latin typeface="Arial"/>
-                        </a:rPr>
-                        <a:t>none</a:t>
+                        <a:t>the 1-megapixel camera</a:t>
                       </a:r>
                     </a:p>
                   </a:txBody>
@@ -7502,7 +7701,7 @@
                           </a:solidFill>
                           <a:latin typeface="Arial"/>
                         </a:rPr>
-                        <a:t>null, nothing aligned</a:t>
+                        <a:t>zwfs_run('MODEL',2048, 'NGRID',385, 'param_file','macos_param_2048.txt')</a:t>
                       </a:r>
                     </a:p>
                   </a:txBody>
@@ -7524,103 +7723,13 @@
                           </a:solidFill>
                           <a:latin typeface="Arial"/>
                         </a:rPr>
-                        <a:t>0.134 nm</a:t>
+                        <a:t>the fully sampled setup on a 30 GB machine</a:t>
                       </a:r>
                     </a:p>
                   </a:txBody>
                   <a:tcPr marL="54864" marR="54864" marT="18288" marB="18288">
                     <a:solidFill>
                       <a:srgbClr val="FFFFFF"/>
-                    </a:solidFill>
-                  </a:tcPr>
-                </a:tc>
-                <a:tc>
-                  <a:txBody>
-                    <a:bodyPr wrap="square"/>
-                    <a:lstStyle/>
-                    <a:p>
-                      <a:r>
-                        <a:rPr sz="1100" b="0">
-                          <a:solidFill>
-                            <a:srgbClr val="282828"/>
-                          </a:solidFill>
-                          <a:latin typeface="Arial"/>
-                        </a:rPr>
-                        <a:t>0 by construction (the flat is the reference)</a:t>
-                      </a:r>
-                    </a:p>
-                  </a:txBody>
-                  <a:tcPr marL="54864" marR="54864" marT="18288" marB="18288">
-                    <a:solidFill>
-                      <a:srgbClr val="FFFFFF"/>
-                    </a:solidFill>
-                  </a:tcPr>
-                </a:tc>
-              </a:tr>
-              <a:tr h="468630">
-                <a:tc>
-                  <a:txBody>
-                    <a:bodyPr wrap="square"/>
-                    <a:lstStyle/>
-                    <a:p>
-                      <a:r>
-                        <a:rPr sz="1100" b="0">
-                          <a:solidFill>
-                            <a:srgbClr val="282828"/>
-                          </a:solidFill>
-                          <a:latin typeface="Arial"/>
-                        </a:rPr>
-                        <a:t>response falls off at</a:t>
-                      </a:r>
-                    </a:p>
-                  </a:txBody>
-                  <a:tcPr marL="54864" marR="54864" marT="18288" marB="18288">
-                    <a:solidFill>
-                      <a:srgbClr val="ECF1F6"/>
-                    </a:solidFill>
-                  </a:tcPr>
-                </a:tc>
-                <a:tc>
-                  <a:txBody>
-                    <a:bodyPr wrap="square"/>
-                    <a:lstStyle/>
-                    <a:p>
-                      <a:r>
-                        <a:rPr sz="1100" b="0">
-                          <a:solidFill>
-                            <a:srgbClr val="282828"/>
-                          </a:solidFill>
-                          <a:latin typeface="Arial"/>
-                        </a:rPr>
-                        <a:t>fine patterns: 0.50 at the 96×96 checkerboard</a:t>
-                      </a:r>
-                    </a:p>
-                  </a:txBody>
-                  <a:tcPr marL="54864" marR="54864" marT="18288" marB="18288">
-                    <a:solidFill>
-                      <a:srgbClr val="ECF1F6"/>
-                    </a:solidFill>
-                  </a:tcPr>
-                </a:tc>
-                <a:tc>
-                  <a:txBody>
-                    <a:bodyPr wrap="square"/>
-                    <a:lstStyle/>
-                    <a:p>
-                      <a:r>
-                        <a:rPr sz="1100" b="0">
-                          <a:solidFill>
-                            <a:srgbClr val="282828"/>
-                          </a:solidFill>
-                          <a:latin typeface="Arial"/>
-                        </a:rPr>
-                        <a:t>0.5 to 1 cycle across the pupil (0.5 at 1); piston unseen</a:t>
-                      </a:r>
-                    </a:p>
-                  </a:txBody>
-                  <a:tcPr marL="54864" marR="54864" marT="18288" marB="18288">
-                    <a:solidFill>
-                      <a:srgbClr val="ECF1F6"/>
                     </a:solidFill>
                   </a:tcPr>
                 </a:tc>
@@ -7638,75 +7747,7 @@
                           </a:solidFill>
                           <a:latin typeface="Arial"/>
                         </a:rPr>
-                        <a:t>working surface it can handle</a:t>
-                      </a:r>
-                    </a:p>
-                  </a:txBody>
-                  <a:tcPr marL="54864" marR="54864" marT="18288" marB="18288">
-                    <a:solidFill>
-                      <a:srgbClr val="FFFFFF"/>
-                    </a:solidFill>
-                  </a:tcPr>
-                </a:tc>
-                <a:tc>
-                  <a:txBody>
-                    <a:bodyPr wrap="square"/>
-                    <a:lstStyle/>
-                    <a:p>
-                      <a:r>
-                        <a:rPr sz="1100" b="0">
-                          <a:solidFill>
-                            <a:srgbClr val="282828"/>
-                          </a:solidFill>
-                          <a:latin typeface="Arial"/>
-                        </a:rPr>
-                        <a:t>480 nm rms and beyond</a:t>
-                      </a:r>
-                    </a:p>
-                  </a:txBody>
-                  <a:tcPr marL="54864" marR="54864" marT="18288" marB="18288">
-                    <a:solidFill>
-                      <a:srgbClr val="FFFFFF"/>
-                    </a:solidFill>
-                  </a:tcPr>
-                </a:tc>
-                <a:tc>
-                  <a:txBody>
-                    <a:bodyPr wrap="square"/>
-                    <a:lstStyle/>
-                    <a:p>
-                      <a:r>
-                        <a:rPr sz="1100" b="0">
-                          <a:solidFill>
-                            <a:srgbClr val="282828"/>
-                          </a:solidFill>
-                          <a:latin typeface="Arial"/>
-                        </a:rPr>
-                        <a:t>40 nm rms one-frame (1 mm actuators), 50–60 nm four-frame</a:t>
-                      </a:r>
-                    </a:p>
-                  </a:txBody>
-                  <a:tcPr marL="54864" marR="54864" marT="18288" marB="18288">
-                    <a:solidFill>
-                      <a:srgbClr val="FFFFFF"/>
-                    </a:solidFill>
-                  </a:tcPr>
-                </a:tc>
-              </a:tr>
-              <a:tr h="468630">
-                <a:tc>
-                  <a:txBody>
-                    <a:bodyPr wrap="square"/>
-                    <a:lstStyle/>
-                    <a:p>
-                      <a:r>
-                        <a:rPr sz="1100" b="0">
-                          <a:solidFill>
-                            <a:srgbClr val="282828"/>
-                          </a:solidFill>
-                          <a:latin typeface="Arial"/>
-                        </a:rPr>
-                        <a:t>a 10 nm actuator change on a 30 nm surface</a:t>
+                        <a:t>zwfs_run('stages',{'battery','color','noise','figs'})</a:t>
                       </a:r>
                     </a:p>
                   </a:txBody>
@@ -7728,29 +7769,7 @@
                           </a:solidFill>
                           <a:latin typeface="Arial"/>
                         </a:rPr>
-                        <a:t>gain 0.92, floor 46 pm</a:t>
-                      </a:r>
-                    </a:p>
-                  </a:txBody>
-                  <a:tcPr marL="54864" marR="54864" marT="18288" marB="18288">
-                    <a:solidFill>
-                      <a:srgbClr val="ECF1F6"/>
-                    </a:solidFill>
-                  </a:tcPr>
-                </a:tc>
-                <a:tc>
-                  <a:txBody>
-                    <a:bodyPr wrap="square"/>
-                    <a:lstStyle/>
-                    <a:p>
-                      <a:r>
-                        <a:rPr sz="1100" b="0">
-                          <a:solidFill>
-                            <a:srgbClr val="282828"/>
-                          </a:solidFill>
-                          <a:latin typeface="Arial"/>
-                        </a:rPr>
-                        <a:t>gain 0.99, floor 5 pm (stepped, four frames; matrix on the surface) — gain 1.05, floor 23 pm (linear, one frame)</a:t>
+                        <a:t>everything on this deck's later slides</a:t>
                       </a:r>
                     </a:p>
                   </a:txBody>
@@ -7774,7 +7793,7 @@
                           </a:solidFill>
                           <a:latin typeface="Arial"/>
                         </a:rPr>
-                        <a:t>photons per measurement for 1 pm</a:t>
+                        <a:t>./zwfs_batch.sh TAG "the same arguments"</a:t>
                       </a:r>
                     </a:p>
                   </a:txBody>
@@ -7796,103 +7815,13 @@
                           </a:solidFill>
                           <a:latin typeface="Arial"/>
                         </a:rPr>
-                        <a:t>8×10¹⁴</a:t>
+                        <a:t>unattended, memory-capped, logged</a:t>
                       </a:r>
                     </a:p>
                   </a:txBody>
                   <a:tcPr marL="54864" marR="54864" marT="18288" marB="18288">
                     <a:solidFill>
                       <a:srgbClr val="FFFFFF"/>
-                    </a:solidFill>
-                  </a:tcPr>
-                </a:tc>
-                <a:tc>
-                  <a:txBody>
-                    <a:bodyPr wrap="square"/>
-                    <a:lstStyle/>
-                    <a:p>
-                      <a:r>
-                        <a:rPr sz="1100" b="0">
-                          <a:solidFill>
-                            <a:srgbClr val="282828"/>
-                          </a:solidFill>
-                          <a:latin typeface="Arial"/>
-                        </a:rPr>
-                        <a:t>0.4 to 1×10¹⁴</a:t>
-                      </a:r>
-                    </a:p>
-                  </a:txBody>
-                  <a:tcPr marL="54864" marR="54864" marT="18288" marB="18288">
-                    <a:solidFill>
-                      <a:srgbClr val="FFFFFF"/>
-                    </a:solidFill>
-                  </a:tcPr>
-                </a:tc>
-              </a:tr>
-              <a:tr h="468630">
-                <a:tc>
-                  <a:txBody>
-                    <a:bodyPr wrap="square"/>
-                    <a:lstStyle/>
-                    <a:p>
-                      <a:r>
-                        <a:rPr sz="1100" b="0">
-                          <a:solidFill>
-                            <a:srgbClr val="282828"/>
-                          </a:solidFill>
-                          <a:latin typeface="Arial"/>
-                        </a:rPr>
-                        <a:t>held in closed loop to 3 pm against a 2 pm random walk: photons per cycle</a:t>
-                      </a:r>
-                    </a:p>
-                  </a:txBody>
-                  <a:tcPr marL="54864" marR="54864" marT="18288" marB="18288">
-                    <a:solidFill>
-                      <a:srgbClr val="ECF1F6"/>
-                    </a:solidFill>
-                  </a:tcPr>
-                </a:tc>
-                <a:tc>
-                  <a:txBody>
-                    <a:bodyPr wrap="square"/>
-                    <a:lstStyle/>
-                    <a:p>
-                      <a:r>
-                        <a:rPr sz="1100" b="0">
-                          <a:solidFill>
-                            <a:srgbClr val="282828"/>
-                          </a:solidFill>
-                          <a:latin typeface="Arial"/>
-                        </a:rPr>
-                        <a:t>pending (same loop code, CCMac)</a:t>
-                      </a:r>
-                    </a:p>
-                  </a:txBody>
-                  <a:tcPr marL="54864" marR="54864" marT="18288" marB="18288">
-                    <a:solidFill>
-                      <a:srgbClr val="ECF1F6"/>
-                    </a:solidFill>
-                  </a:tcPr>
-                </a:tc>
-                <a:tc>
-                  <a:txBody>
-                    <a:bodyPr wrap="square"/>
-                    <a:lstStyle/>
-                    <a:p>
-                      <a:r>
-                        <a:rPr sz="1100" b="0">
-                          <a:solidFill>
-                            <a:srgbClr val="282828"/>
-                          </a:solidFill>
-                          <a:latin typeface="Arial"/>
-                        </a:rPr>
-                        <a:t>7.5×10¹² (stepped), 7.3×10¹² (linear)</a:t>
-                      </a:r>
-                    </a:p>
-                  </a:txBody>
-                  <a:tcPr marL="54864" marR="54864" marT="18288" marB="18288">
-                    <a:solidFill>
-                      <a:srgbClr val="ECF1F6"/>
                     </a:solidFill>
                   </a:tcPr>
                 </a:tc>
@@ -7903,13 +7832,13 @@
       </p:graphicFrame>
       <p:sp>
         <p:nvSpPr>
-          <p:cNvPr id="5" name="TextBox 4"/>
+          <p:cNvPr id="6" name="TextBox 5"/>
           <p:cNvSpPr txBox="1"/>
           <p:nvPr/>
         </p:nvSpPr>
         <p:spPr>
           <a:xfrm>
-            <a:off x="411480" y="5468112"/>
+            <a:off x="411480" y="4292346"/>
             <a:ext cx="11368735" cy="274320"/>
           </a:xfrm>
           <a:prstGeom prst="rect">
@@ -7935,20 +7864,20 @@
                 </a:solidFill>
                 <a:latin typeface="Arial"/>
               </a:rPr>
-              <a:t>•  Reading: the interferometer measures any surface and pays at fine patterns; the sensor measures small changes on a small working surface more cheaply — no polarization train, a floor ten times lower once its response matrix is measured on that surface — and pays at the lowest spatial frequencies and in the surface it can handle.</a:t>
-            </a:r>
-          </a:p>
-        </p:txBody>
-      </p:sp>
-      <p:sp>
-        <p:nvSpPr>
-          <p:cNvPr id="6" name="TextBox 5"/>
+              <a:t>•  Checks that run every time: the no-mask round trip through the bracket (must return the field unchanged); the reference-wave model against the engine's own field; the pupil brightness must not change with the DM shape; the sampling checks (pixels across the dimple, camera pixels per actuator); and the search for the camera-to-DM mirror/transpose and sign.</a:t>
+            </a:r>
+          </a:p>
+        </p:txBody>
+      </p:sp>
+      <p:sp>
+        <p:nvSpPr>
+          <p:cNvPr id="7" name="TextBox 6"/>
           <p:cNvSpPr txBox="1"/>
           <p:nvPr/>
         </p:nvSpPr>
         <p:spPr>
           <a:xfrm>
-            <a:off x="411480" y="6387846"/>
+            <a:off x="411480" y="5459730"/>
             <a:ext cx="11368735" cy="274320"/>
           </a:xfrm>
           <a:prstGeom prst="rect">
@@ -7974,7 +7903,7 @@
                 </a:solidFill>
                 <a:latin typeface="Arial"/>
               </a:rPr>
-              <a:t>PSI column: tg_psi_dm96 run 10 and S4/S5; sensor column: 385 rays, matrix calibration on the working surface (slide 10), photons at development sampling.  Both in actuator units through the same code (dm_gauge_lib).</a:t>
+              <a:t>Reproduction check: 64 lines of results against the stage-7 report, 8 differ in the last printed digit (the actuator fit's solver tolerance).  README "Run it yourself" carries the parameter table.</a:t>
             </a:r>
           </a:p>
         </p:txBody>
@@ -8031,7 +7960,7 @@
                 </a:solidFill>
                 <a:latin typeface="Arial"/>
               </a:rPr>
-              <a:t>What the Zernike-sensor literature offers, in priority order</a:t>
+              <a:t>Side by side with the Twyman–Green</a:t>
             </a:r>
           </a:p>
           <a:p>
@@ -8047,7 +7976,7 @@
                 </a:solidFill>
                 <a:latin typeface="Arial"/>
               </a:rPr>
-              <a:t>Twelve papers read; the first import — re-computing the reference wave — is now built and measured (slide 8)</a:t>
+              <a:t>The interferometer loses response at fine patterns and never fails; the sensor, calibrated on its working surface, reads a change to 5 pm up to 50–60 nm</a:t>
             </a:r>
           </a:p>
         </p:txBody>
@@ -8106,7 +8035,7 @@
         </p:nvGraphicFramePr>
         <p:xfrm>
           <a:off x="411480" y="1298448"/>
-          <a:ext cx="11368734" cy="3091815"/>
+          <a:ext cx="11368733" cy="4023360"/>
         </p:xfrm>
         <a:graphic>
           <a:graphicData uri="http://schemas.openxmlformats.org/drawingml/2006/table">
@@ -8115,15 +8044,27 @@
                 <a:tableStyleId>{5C22544A-7EE6-4342-B048-85BDC9FD1C3A}</a:tableStyleId>
               </a:tblPr>
               <a:tblGrid>
-                <a:gridCol w="218948"/>
-                <a:gridCol w="2691327"/>
-                <a:gridCol w="8458459"/>
+                <a:gridCol w="3608337"/>
+                <a:gridCol w="2224317"/>
+                <a:gridCol w="5536079"/>
               </a:tblGrid>
               <a:tr h="280035">
                 <a:tc>
                   <a:txBody>
                     <a:bodyPr wrap="square"/>
                     <a:lstStyle/>
+                    <a:p/>
+                  </a:txBody>
+                  <a:tcPr marL="54864" marR="54864" marT="18288" marB="18288">
+                    <a:solidFill>
+                      <a:srgbClr val="1F4E79"/>
+                    </a:solidFill>
+                  </a:tcPr>
+                </a:tc>
+                <a:tc>
+                  <a:txBody>
+                    <a:bodyPr wrap="square"/>
+                    <a:lstStyle/>
                     <a:p>
                       <a:r>
                         <a:rPr sz="1100" b="1">
@@ -8132,7 +8073,7 @@
                           </a:solidFill>
                           <a:latin typeface="Arial"/>
                         </a:rPr>
-                        <a:t>#</a:t>
+                        <a:t>Twyman–Green PSI (measured)</a:t>
                       </a:r>
                     </a:p>
                   </a:txBody>
@@ -8154,7 +8095,7 @@
                           </a:solidFill>
                           <a:latin typeface="Arial"/>
                         </a:rPr>
-                        <a:t>paper</a:t>
+                        <a:t>Zernike sensor (measured)</a:t>
                       </a:r>
                     </a:p>
                   </a:txBody>
@@ -8164,25 +8105,71 @@
                     </a:solidFill>
                   </a:tcPr>
                 </a:tc>
-                <a:tc>
-                  <a:txBody>
-                    <a:bodyPr wrap="square"/>
-                    <a:lstStyle/>
-                    <a:p>
-                      <a:r>
-                        <a:rPr sz="1100" b="1">
-                          <a:solidFill>
-                            <a:srgbClr val="FFFFFF"/>
-                          </a:solidFill>
-                          <a:latin typeface="Arial"/>
-                        </a:rPr>
-                        <a:t>what it gives this model</a:t>
-                      </a:r>
-                    </a:p>
-                  </a:txBody>
-                  <a:tcPr marL="54864" marR="54864" marT="18288" marB="18288">
-                    <a:solidFill>
-                      <a:srgbClr val="1F4E79"/>
+              </a:tr>
+              <a:tr h="280035">
+                <a:tc>
+                  <a:txBody>
+                    <a:bodyPr wrap="square"/>
+                    <a:lstStyle/>
+                    <a:p>
+                      <a:r>
+                        <a:rPr sz="1100" b="0">
+                          <a:solidFill>
+                            <a:srgbClr val="282828"/>
+                          </a:solidFill>
+                          <a:latin typeface="Arial"/>
+                        </a:rPr>
+                        <a:t>reference beam</a:t>
+                      </a:r>
+                    </a:p>
+                  </a:txBody>
+                  <a:tcPr marL="54864" marR="54864" marT="18288" marB="18288">
+                    <a:solidFill>
+                      <a:srgbClr val="FFFFFF"/>
+                    </a:solidFill>
+                  </a:tcPr>
+                </a:tc>
+                <a:tc>
+                  <a:txBody>
+                    <a:bodyPr wrap="square"/>
+                    <a:lstStyle/>
+                    <a:p>
+                      <a:r>
+                        <a:rPr sz="1100" b="0">
+                          <a:solidFill>
+                            <a:srgbClr val="282828"/>
+                          </a:solidFill>
+                          <a:latin typeface="Arial"/>
+                        </a:rPr>
+                        <a:t>the second arm's flat</a:t>
+                      </a:r>
+                    </a:p>
+                  </a:txBody>
+                  <a:tcPr marL="54864" marR="54864" marT="18288" marB="18288">
+                    <a:solidFill>
+                      <a:srgbClr val="FFFFFF"/>
+                    </a:solidFill>
+                  </a:tcPr>
+                </a:tc>
+                <a:tc>
+                  <a:txBody>
+                    <a:bodyPr wrap="square"/>
+                    <a:lstStyle/>
+                    <a:p>
+                      <a:r>
+                        <a:rPr sz="1100" b="0">
+                          <a:solidFill>
+                            <a:srgbClr val="282828"/>
+                          </a:solidFill>
+                          <a:latin typeface="Arial"/>
+                        </a:rPr>
+                        <a:t>made from the beam's own focal core</a:t>
+                      </a:r>
+                    </a:p>
+                  </a:txBody>
+                  <a:tcPr marL="54864" marR="54864" marT="18288" marB="18288">
+                    <a:solidFill>
+                      <a:srgbClr val="FFFFFF"/>
                     </a:solidFill>
                   </a:tcPr>
                 </a:tc>
@@ -8200,57 +8187,57 @@
                           </a:solidFill>
                           <a:latin typeface="Arial"/>
                         </a:rPr>
-                        <a:t>1</a:t>
-                      </a:r>
-                    </a:p>
-                  </a:txBody>
-                  <a:tcPr marL="54864" marR="54864" marT="18288" marB="18288">
-                    <a:solidFill>
-                      <a:srgbClr val="FFFFFF"/>
-                    </a:solidFill>
-                  </a:tcPr>
-                </a:tc>
-                <a:tc>
-                  <a:txBody>
-                    <a:bodyPr wrap="square"/>
-                    <a:lstStyle/>
-                    <a:p>
-                      <a:r>
-                        <a:rPr sz="1100" b="0">
-                          <a:solidFill>
-                            <a:srgbClr val="282828"/>
-                          </a:solidFill>
-                          <a:latin typeface="Arial"/>
-                        </a:rPr>
-                        <a:t>Ruane, Wallace, Steeves et al. 2020, JATIS 6, 045005</a:t>
-                      </a:r>
-                    </a:p>
-                  </a:txBody>
-                  <a:tcPr marL="54864" marR="54864" marT="18288" marB="18288">
-                    <a:solidFill>
-                      <a:srgbClr val="FFFFFF"/>
-                    </a:solidFill>
-                  </a:tcPr>
-                </a:tc>
-                <a:tc>
-                  <a:txBody>
-                    <a:bodyPr wrap="square"/>
-                    <a:lstStyle/>
-                    <a:p>
-                      <a:r>
-                        <a:rPr sz="1100" b="0">
-                          <a:solidFill>
-                            <a:srgbClr val="282828"/>
-                          </a:solidFill>
-                          <a:latin typeface="Arial"/>
-                        </a:rPr>
-                        <a:t>Exact per-pixel reconstruction from the pupil amplitude, the reference wave b and the masked image; a sensitivity factor per pixel; a four-term systematic budget; 1 pm reached at 4.4×10⁵ frames; no loss to 25 % bandwidth</a:t>
-                      </a:r>
-                    </a:p>
-                  </a:txBody>
-                  <a:tcPr marL="54864" marR="54864" marT="18288" marB="18288">
-                    <a:solidFill>
-                      <a:srgbClr val="FFFFFF"/>
+                        <a:t>one measurement costs</a:t>
+                      </a:r>
+                    </a:p>
+                  </a:txBody>
+                  <a:tcPr marL="54864" marR="54864" marT="18288" marB="18288">
+                    <a:solidFill>
+                      <a:srgbClr val="ECF1F6"/>
+                    </a:solidFill>
+                  </a:tcPr>
+                </a:tc>
+                <a:tc>
+                  <a:txBody>
+                    <a:bodyPr wrap="square"/>
+                    <a:lstStyle/>
+                    <a:p>
+                      <a:r>
+                        <a:rPr sz="1100" b="0">
+                          <a:solidFill>
+                            <a:srgbClr val="282828"/>
+                          </a:solidFill>
+                          <a:latin typeface="Arial"/>
+                        </a:rPr>
+                        <a:t>6 traces (3 per arm), 4 fringe frames</a:t>
+                      </a:r>
+                    </a:p>
+                  </a:txBody>
+                  <a:tcPr marL="54864" marR="54864" marT="18288" marB="18288">
+                    <a:solidFill>
+                      <a:srgbClr val="ECF1F6"/>
+                    </a:solidFill>
+                  </a:tcPr>
+                </a:tc>
+                <a:tc>
+                  <a:txBody>
+                    <a:bodyPr wrap="square"/>
+                    <a:lstStyle/>
+                    <a:p>
+                      <a:r>
+                        <a:rPr sz="1100" b="0">
+                          <a:solidFill>
+                            <a:srgbClr val="282828"/>
+                          </a:solidFill>
+                          <a:latin typeface="Arial"/>
+                        </a:rPr>
+                        <a:t>1 or 4 camera frames; 256 calibration frames once per working surface</a:t>
+                      </a:r>
+                    </a:p>
+                  </a:txBody>
+                  <a:tcPr marL="54864" marR="54864" marT="18288" marB="18288">
+                    <a:solidFill>
+                      <a:srgbClr val="ECF1F6"/>
                     </a:solidFill>
                   </a:tcPr>
                 </a:tc>
@@ -8268,7 +8255,75 @@
                           </a:solidFill>
                           <a:latin typeface="Arial"/>
                         </a:rPr>
-                        <a:t>2</a:t>
+                        <a:t>polarization hardware</a:t>
+                      </a:r>
+                    </a:p>
+                  </a:txBody>
+                  <a:tcPr marL="54864" marR="54864" marT="18288" marB="18288">
+                    <a:solidFill>
+                      <a:srgbClr val="FFFFFF"/>
+                    </a:solidFill>
+                  </a:tcPr>
+                </a:tc>
+                <a:tc>
+                  <a:txBody>
+                    <a:bodyPr wrap="square"/>
+                    <a:lstStyle/>
+                    <a:p>
+                      <a:r>
+                        <a:rPr sz="1100" b="0">
+                          <a:solidFill>
+                            <a:srgbClr val="282828"/>
+                          </a:solidFill>
+                          <a:latin typeface="Arial"/>
+                        </a:rPr>
+                        <a:t>polarizer, 5 waveplates, analyzer</a:t>
+                      </a:r>
+                    </a:p>
+                  </a:txBody>
+                  <a:tcPr marL="54864" marR="54864" marT="18288" marB="18288">
+                    <a:solidFill>
+                      <a:srgbClr val="FFFFFF"/>
+                    </a:solidFill>
+                  </a:tcPr>
+                </a:tc>
+                <a:tc>
+                  <a:txBody>
+                    <a:bodyPr wrap="square"/>
+                    <a:lstStyle/>
+                    <a:p>
+                      <a:r>
+                        <a:rPr sz="1100" b="0">
+                          <a:solidFill>
+                            <a:srgbClr val="282828"/>
+                          </a:solidFill>
+                          <a:latin typeface="Arial"/>
+                        </a:rPr>
+                        <a:t>none</a:t>
+                      </a:r>
+                    </a:p>
+                  </a:txBody>
+                  <a:tcPr marL="54864" marR="54864" marT="18288" marB="18288">
+                    <a:solidFill>
+                      <a:srgbClr val="FFFFFF"/>
+                    </a:solidFill>
+                  </a:tcPr>
+                </a:tc>
+              </a:tr>
+              <a:tr h="280035">
+                <a:tc>
+                  <a:txBody>
+                    <a:bodyPr wrap="square"/>
+                    <a:lstStyle/>
+                    <a:p>
+                      <a:r>
+                        <a:rPr sz="1100" b="0">
+                          <a:solidFill>
+                            <a:srgbClr val="282828"/>
+                          </a:solidFill>
+                          <a:latin typeface="Arial"/>
+                        </a:rPr>
+                        <a:t>moving parts</a:t>
                       </a:r>
                     </a:p>
                   </a:txBody>
@@ -8290,7 +8345,7 @@
                           </a:solidFill>
                           <a:latin typeface="Arial"/>
                         </a:rPr>
-                        <a:t>Doelman, Fagginger Auer, Escuti, Snik 2019, Opt. Lett. 44, 17</a:t>
+                        <a:t>none (polarization-stepped)</a:t>
                       </a:r>
                     </a:p>
                   </a:txBody>
@@ -8312,13 +8367,81 @@
                           </a:solidFill>
                           <a:latin typeface="Arial"/>
                         </a:rPr>
-                        <a:t>Vector Zernike: ±π/2 on opposite circular polarizations gives two pupil images, an exact phase-and-amplitude solution, an iterated b, achromatic to 100 % bandwidth; the leakage terms are written down</a:t>
+                        <a:t>none</a:t>
                       </a:r>
                     </a:p>
                   </a:txBody>
                   <a:tcPr marL="54864" marR="54864" marT="18288" marB="18288">
                     <a:solidFill>
                       <a:srgbClr val="ECF1F6"/>
+                    </a:solidFill>
+                  </a:tcPr>
+                </a:tc>
+              </a:tr>
+              <a:tr h="280035">
+                <a:tc>
+                  <a:txBody>
+                    <a:bodyPr wrap="square"/>
+                    <a:lstStyle/>
+                    <a:p>
+                      <a:r>
+                        <a:rPr sz="1100" b="0">
+                          <a:solidFill>
+                            <a:srgbClr val="282828"/>
+                          </a:solidFill>
+                          <a:latin typeface="Arial"/>
+                        </a:rPr>
+                        <a:t>null, nothing aligned</a:t>
+                      </a:r>
+                    </a:p>
+                  </a:txBody>
+                  <a:tcPr marL="54864" marR="54864" marT="18288" marB="18288">
+                    <a:solidFill>
+                      <a:srgbClr val="FFFFFF"/>
+                    </a:solidFill>
+                  </a:tcPr>
+                </a:tc>
+                <a:tc>
+                  <a:txBody>
+                    <a:bodyPr wrap="square"/>
+                    <a:lstStyle/>
+                    <a:p>
+                      <a:r>
+                        <a:rPr sz="1100" b="0">
+                          <a:solidFill>
+                            <a:srgbClr val="282828"/>
+                          </a:solidFill>
+                          <a:latin typeface="Arial"/>
+                        </a:rPr>
+                        <a:t>0.134 nm</a:t>
+                      </a:r>
+                    </a:p>
+                  </a:txBody>
+                  <a:tcPr marL="54864" marR="54864" marT="18288" marB="18288">
+                    <a:solidFill>
+                      <a:srgbClr val="FFFFFF"/>
+                    </a:solidFill>
+                  </a:tcPr>
+                </a:tc>
+                <a:tc>
+                  <a:txBody>
+                    <a:bodyPr wrap="square"/>
+                    <a:lstStyle/>
+                    <a:p>
+                      <a:r>
+                        <a:rPr sz="1100" b="0">
+                          <a:solidFill>
+                            <a:srgbClr val="282828"/>
+                          </a:solidFill>
+                          <a:latin typeface="Arial"/>
+                        </a:rPr>
+                        <a:t>0 by construction (the flat is the reference)</a:t>
+                      </a:r>
+                    </a:p>
+                  </a:txBody>
+                  <a:tcPr marL="54864" marR="54864" marT="18288" marB="18288">
+                    <a:solidFill>
+                      <a:srgbClr val="FFFFFF"/>
                     </a:solidFill>
                   </a:tcPr>
                 </a:tc>
@@ -8336,7 +8459,75 @@
                           </a:solidFill>
                           <a:latin typeface="Arial"/>
                         </a:rPr>
-                        <a:t>3</a:t>
+                        <a:t>response falls off at</a:t>
+                      </a:r>
+                    </a:p>
+                  </a:txBody>
+                  <a:tcPr marL="54864" marR="54864" marT="18288" marB="18288">
+                    <a:solidFill>
+                      <a:srgbClr val="ECF1F6"/>
+                    </a:solidFill>
+                  </a:tcPr>
+                </a:tc>
+                <a:tc>
+                  <a:txBody>
+                    <a:bodyPr wrap="square"/>
+                    <a:lstStyle/>
+                    <a:p>
+                      <a:r>
+                        <a:rPr sz="1100" b="0">
+                          <a:solidFill>
+                            <a:srgbClr val="282828"/>
+                          </a:solidFill>
+                          <a:latin typeface="Arial"/>
+                        </a:rPr>
+                        <a:t>fine patterns: 0.50 at the 96×96 checkerboard</a:t>
+                      </a:r>
+                    </a:p>
+                  </a:txBody>
+                  <a:tcPr marL="54864" marR="54864" marT="18288" marB="18288">
+                    <a:solidFill>
+                      <a:srgbClr val="ECF1F6"/>
+                    </a:solidFill>
+                  </a:tcPr>
+                </a:tc>
+                <a:tc>
+                  <a:txBody>
+                    <a:bodyPr wrap="square"/>
+                    <a:lstStyle/>
+                    <a:p>
+                      <a:r>
+                        <a:rPr sz="1100" b="0">
+                          <a:solidFill>
+                            <a:srgbClr val="282828"/>
+                          </a:solidFill>
+                          <a:latin typeface="Arial"/>
+                        </a:rPr>
+                        <a:t>0.5 to 1 cycle across the pupil (0.5 at 1); piston unseen</a:t>
+                      </a:r>
+                    </a:p>
+                  </a:txBody>
+                  <a:tcPr marL="54864" marR="54864" marT="18288" marB="18288">
+                    <a:solidFill>
+                      <a:srgbClr val="ECF1F6"/>
+                    </a:solidFill>
+                  </a:tcPr>
+                </a:tc>
+              </a:tr>
+              <a:tr h="280035">
+                <a:tc>
+                  <a:txBody>
+                    <a:bodyPr wrap="square"/>
+                    <a:lstStyle/>
+                    <a:p>
+                      <a:r>
+                        <a:rPr sz="1100" b="0">
+                          <a:solidFill>
+                            <a:srgbClr val="282828"/>
+                          </a:solidFill>
+                          <a:latin typeface="Arial"/>
+                        </a:rPr>
+                        <a:t>working surface it can handle</a:t>
                       </a:r>
                     </a:p>
                   </a:txBody>
@@ -8358,7 +8549,7 @@
                           </a:solidFill>
                           <a:latin typeface="Arial"/>
                         </a:rPr>
-                        <a:t>N'Diaye, Vigan, Dohlen et al. 2016, A&amp;A 592, A79 (ZELDA II)</a:t>
+                        <a:t>480 nm rms and beyond</a:t>
                       </a:r>
                     </a:p>
                   </a:txBody>
@@ -8380,7 +8571,7 @@
                           </a:solidFill>
                           <a:latin typeface="Arial"/>
                         </a:rPr>
-                        <a:t>Second-order reconstruction with b from the mask model; 1.06 λ/D at π/2; range −0.14 to +0.36 λ; the sensitivity factor drifts 10 % day to day on SPHERE</a:t>
+                        <a:t>40 nm rms one-frame (1 mm actuators), 50–60 nm four-frame</a:t>
                       </a:r>
                     </a:p>
                   </a:txBody>
@@ -8404,7 +8595,7 @@
                           </a:solidFill>
                           <a:latin typeface="Arial"/>
                         </a:rPr>
-                        <a:t>4</a:t>
+                        <a:t>a 10 nm actuator change on a 30 nm surface</a:t>
                       </a:r>
                     </a:p>
                   </a:txBody>
@@ -8426,7 +8617,7 @@
                           </a:solidFill>
                           <a:latin typeface="Arial"/>
                         </a:rPr>
-                        <a:t>Chambouleyron, Cissé, Salama, Haffert, Wallace et al. 2024, SPIE 13097</a:t>
+                        <a:t>gain 0.92, floor 46 pm</a:t>
                       </a:r>
                     </a:p>
                   </a:txBody>
@@ -8448,13 +8639,81 @@
                           </a:solidFill>
                           <a:latin typeface="Arial"/>
                         </a:rPr>
-                        <a:t>A phase-shifted pair (±π/2) yields cos φ and sin φ; iterative reconstructors reach about 1 rad rms; the bench limits were polarization crosstalk and defocus between the two pupils</a:t>
+                        <a:t>gain 0.99, floor 5 pm (stepped, four frames; matrix on the surface) — gain 1.05, floor 23 pm (linear, one frame)</a:t>
                       </a:r>
                     </a:p>
                   </a:txBody>
                   <a:tcPr marL="54864" marR="54864" marT="18288" marB="18288">
                     <a:solidFill>
                       <a:srgbClr val="ECF1F6"/>
+                    </a:solidFill>
+                  </a:tcPr>
+                </a:tc>
+              </a:tr>
+              <a:tr h="280035">
+                <a:tc>
+                  <a:txBody>
+                    <a:bodyPr wrap="square"/>
+                    <a:lstStyle/>
+                    <a:p>
+                      <a:r>
+                        <a:rPr sz="1100" b="0">
+                          <a:solidFill>
+                            <a:srgbClr val="282828"/>
+                          </a:solidFill>
+                          <a:latin typeface="Arial"/>
+                        </a:rPr>
+                        <a:t>photons per measurement for 1 pm</a:t>
+                      </a:r>
+                    </a:p>
+                  </a:txBody>
+                  <a:tcPr marL="54864" marR="54864" marT="18288" marB="18288">
+                    <a:solidFill>
+                      <a:srgbClr val="FFFFFF"/>
+                    </a:solidFill>
+                  </a:tcPr>
+                </a:tc>
+                <a:tc>
+                  <a:txBody>
+                    <a:bodyPr wrap="square"/>
+                    <a:lstStyle/>
+                    <a:p>
+                      <a:r>
+                        <a:rPr sz="1100" b="0">
+                          <a:solidFill>
+                            <a:srgbClr val="282828"/>
+                          </a:solidFill>
+                          <a:latin typeface="Arial"/>
+                        </a:rPr>
+                        <a:t>8×10¹⁴</a:t>
+                      </a:r>
+                    </a:p>
+                  </a:txBody>
+                  <a:tcPr marL="54864" marR="54864" marT="18288" marB="18288">
+                    <a:solidFill>
+                      <a:srgbClr val="FFFFFF"/>
+                    </a:solidFill>
+                  </a:tcPr>
+                </a:tc>
+                <a:tc>
+                  <a:txBody>
+                    <a:bodyPr wrap="square"/>
+                    <a:lstStyle/>
+                    <a:p>
+                      <a:r>
+                        <a:rPr sz="1100" b="0">
+                          <a:solidFill>
+                            <a:srgbClr val="282828"/>
+                          </a:solidFill>
+                          <a:latin typeface="Arial"/>
+                        </a:rPr>
+                        <a:t>0.4 to 1×10¹⁴</a:t>
+                      </a:r>
+                    </a:p>
+                  </a:txBody>
+                  <a:tcPr marL="54864" marR="54864" marT="18288" marB="18288">
+                    <a:solidFill>
+                      <a:srgbClr val="FFFFFF"/>
                     </a:solidFill>
                   </a:tcPr>
                 </a:tc>
@@ -8472,75 +8731,7 @@
                           </a:solidFill>
                           <a:latin typeface="Arial"/>
                         </a:rPr>
-                        <a:t>5</a:t>
-                      </a:r>
-                    </a:p>
-                  </a:txBody>
-                  <a:tcPr marL="54864" marR="54864" marT="18288" marB="18288">
-                    <a:solidFill>
-                      <a:srgbClr val="FFFFFF"/>
-                    </a:solidFill>
-                  </a:tcPr>
-                </a:tc>
-                <a:tc>
-                  <a:txBody>
-                    <a:bodyPr wrap="square"/>
-                    <a:lstStyle/>
-                    <a:p>
-                      <a:r>
-                        <a:rPr sz="1100" b="0">
-                          <a:solidFill>
-                            <a:srgbClr val="282828"/>
-                          </a:solidFill>
-                          <a:latin typeface="Arial"/>
-                        </a:rPr>
-                        <a:t>Haffert 2024, A&amp;A 683, A113</a:t>
-                      </a:r>
-                    </a:p>
-                  </a:txBody>
-                  <a:tcPr marL="54864" marR="54864" marT="18288" marB="18288">
-                    <a:solidFill>
-                      <a:srgbClr val="FFFFFF"/>
-                    </a:solidFill>
-                  </a:tcPr>
-                </a:tc>
-                <a:tc>
-                  <a:txBody>
-                    <a:bodyPr wrap="square"/>
-                    <a:lstStyle/>
-                    <a:p>
-                      <a:r>
-                        <a:rPr sz="1100" b="0">
-                          <a:solidFill>
-                            <a:srgbClr val="282828"/>
-                          </a:solidFill>
-                          <a:latin typeface="Arial"/>
-                        </a:rPr>
-                        <a:t>Iterative nonlinear reconstructors reach machine precision below 0.25 rad rms; phase sorting extends to 0.75 rad; adding wavelengths to 1.4 rad rms</a:t>
-                      </a:r>
-                    </a:p>
-                  </a:txBody>
-                  <a:tcPr marL="54864" marR="54864" marT="18288" marB="18288">
-                    <a:solidFill>
-                      <a:srgbClr val="FFFFFF"/>
-                    </a:solidFill>
-                  </a:tcPr>
-                </a:tc>
-              </a:tr>
-              <a:tr h="468630">
-                <a:tc>
-                  <a:txBody>
-                    <a:bodyPr wrap="square"/>
-                    <a:lstStyle/>
-                    <a:p>
-                      <a:r>
-                        <a:rPr sz="1100" b="0">
-                          <a:solidFill>
-                            <a:srgbClr val="282828"/>
-                          </a:solidFill>
-                          <a:latin typeface="Arial"/>
-                        </a:rPr>
-                        <a:t>6</a:t>
+                        <a:t>held in closed loop to 3 pm against a 2 pm random walk: photons per cycle</a:t>
                       </a:r>
                     </a:p>
                   </a:txBody>
@@ -8562,7 +8753,7 @@
                           </a:solidFill>
                           <a:latin typeface="Arial"/>
                         </a:rPr>
-                        <a:t>Darcis, Haffert, Chambouleyron, Doelman et al. 2025, A&amp;A</a:t>
+                        <a:t>pending (same loop code, CCMac)</a:t>
                       </a:r>
                     </a:p>
                   </a:txBody>
@@ -8584,7 +8775,7 @@
                           </a:solidFill>
                           <a:latin typeface="Arial"/>
                         </a:rPr>
-                        <a:t>Multi-wavelength gradient descent through the forward model: dynamic range for the scalar sensor, photon robustness across a wider band, two-wavelength unwrapping of petal errors</a:t>
+                        <a:t>7.5×10¹² (stepped), 7.3×10¹² (linear), 5.3×10¹² (polarized pair)</a:t>
                       </a:r>
                     </a:p>
                   </a:txBody>
@@ -8607,7 +8798,7 @@
         </p:nvSpPr>
         <p:spPr>
           <a:xfrm>
-            <a:off x="411480" y="4536567"/>
+            <a:off x="411480" y="5468112"/>
             <a:ext cx="11368735" cy="274320"/>
           </a:xfrm>
           <a:prstGeom prst="rect">
@@ -8627,13 +8818,52 @@
               </a:spcAft>
             </a:pPr>
             <a:r>
-              <a:rPr sz="1050" b="0">
-                <a:solidFill>
-                  <a:srgbClr val="6E6E6E"/>
+              <a:rPr sz="1500" b="0">
+                <a:solidFill>
+                  <a:srgbClr val="282828"/>
                 </a:solidFill>
                 <a:latin typeface="Arial"/>
               </a:rPr>
-              <a:t>Priority = payoff against this campaign's measured weak results.  Synopses and links: macos/REPORT_zwfs_lit_scan.md.</a:t>
+              <a:t>•  Reading: the interferometer measures any surface and pays at fine patterns; the sensor measures small changes on a small working surface more cheaply — no polarization train, a floor ten times lower once its response matrix is measured on that surface — and pays at the lowest spatial frequencies and in the surface it can handle.</a:t>
+            </a:r>
+          </a:p>
+        </p:txBody>
+      </p:sp>
+      <p:sp>
+        <p:nvSpPr>
+          <p:cNvPr id="6" name="TextBox 5"/>
+          <p:cNvSpPr txBox="1"/>
+          <p:nvPr/>
+        </p:nvSpPr>
+        <p:spPr>
+          <a:xfrm>
+            <a:off x="411480" y="6387846"/>
+            <a:ext cx="11368735" cy="274320"/>
+          </a:xfrm>
+          <a:prstGeom prst="rect">
+            <a:avLst/>
+          </a:prstGeom>
+          <a:noFill/>
+        </p:spPr>
+        <p:txBody>
+          <a:bodyPr wrap="square">
+            <a:spAutoFit/>
+          </a:bodyPr>
+          <a:lstStyle/>
+          <a:p>
+            <a:pPr>
+              <a:spcAft>
+                <a:spcPts val="600"/>
+              </a:spcAft>
+            </a:pPr>
+            <a:r>
+              <a:rPr sz="1050" b="0">
+                <a:solidFill>
+                  <a:srgbClr val="6E6E6E"/>
+                </a:solidFill>
+                <a:latin typeface="Arial"/>
+              </a:rPr>
+              <a:t>PSI column: tg_psi_dm96 run 10 and S4/S5; sensor column: 385 rays, matrix calibration on the working surface (slide 10), photons at development sampling.  Both in actuator units through the same code (dm_gauge_lib).</a:t>
             </a:r>
           </a:p>
         </p:txBody>
@@ -8690,7 +8920,7 @@
                 </a:solidFill>
                 <a:latin typeface="Arial"/>
               </a:rPr>
-              <a:t>Demonstrations, segmented mirrors, and the in-house precedent</a:t>
+              <a:t>What the Zernike-sensor literature offers, in priority order</a:t>
             </a:r>
           </a:p>
           <a:p>
@@ -8706,7 +8936,7 @@
                 </a:solidFill>
                 <a:latin typeface="Arial"/>
               </a:rPr>
-              <a:t>Picometers by alternating DM shapes and averaging; segment piston by model iteration, underestimated below 50 % Strehl</a:t>
+              <a:t>Twelve papers read; the first import — re-computing the reference wave — is now built and measured (slide 8)</a:t>
             </a:r>
           </a:p>
         </p:txBody>
@@ -8774,9 +9004,9 @@
                 <a:tableStyleId>{5C22544A-7EE6-4342-B048-85BDC9FD1C3A}</a:tableStyleId>
               </a:tblPr>
               <a:tblGrid>
-                <a:gridCol w="291592"/>
-                <a:gridCol w="3730058"/>
-                <a:gridCol w="7347084"/>
+                <a:gridCol w="218948"/>
+                <a:gridCol w="2691327"/>
+                <a:gridCol w="8458459"/>
               </a:tblGrid>
               <a:tr h="280035">
                 <a:tc>
@@ -8859,7 +9089,7 @@
                           </a:solidFill>
                           <a:latin typeface="Arial"/>
                         </a:rPr>
-                        <a:t>7</a:t>
+                        <a:t>1</a:t>
                       </a:r>
                     </a:p>
                   </a:txBody>
@@ -8881,7 +9111,7 @@
                           </a:solidFill>
                           <a:latin typeface="Arial"/>
                         </a:rPr>
-                        <a:t>Steeves, Wallace, Kettenbeil, Jewell 2020, Optica 7, 1267</a:t>
+                        <a:t>Ruane, Wallace, Steeves et al. 2020, JATIS 6, 045005</a:t>
                       </a:r>
                     </a:p>
                   </a:txBody>
@@ -8903,7 +9133,7 @@
                           </a:solidFill>
                           <a:latin typeface="Arial"/>
                         </a:rPr>
-                        <a:t>1.6 pm repeatability in 4.3 s by alternating flat and waffle DM shapes and averaging the differences; a reconstruction robust at the highest spatial frequencies</a:t>
+                        <a:t>Exact per-pixel reconstruction from the pupil amplitude, the reference wave b and the masked image; a sensitivity factor per pixel; a four-term systematic budget; 1 pm reached at 4.4×10⁵ frames; no loss to 25 % bandwidth</a:t>
                       </a:r>
                     </a:p>
                   </a:txBody>
@@ -8927,7 +9157,7 @@
                           </a:solidFill>
                           <a:latin typeface="Arial"/>
                         </a:rPr>
-                        <a:t>8</a:t>
+                        <a:t>2</a:t>
                       </a:r>
                     </a:p>
                   </a:txBody>
@@ -8949,7 +9179,7 @@
                           </a:solidFill>
                           <a:latin typeface="Arial"/>
                         </a:rPr>
-                        <a:t>Wallace, Rao, Jensen-Clem, Serabyn 2011, SPIE 8126</a:t>
+                        <a:t>Doelman, Fagginger Auer, Escuti, Snik 2019, Opt. Lett. 44, 17</a:t>
                       </a:r>
                     </a:p>
                   </a:txBody>
@@ -8971,7 +9201,7 @@
                           </a:solidFill>
                           <a:latin typeface="Arial"/>
                         </a:rPr>
-                        <a:t>All-reflective phase-shifting Zernike interferometer: a dynamic, arbitrary core phase shift read in four steps gives phase and amplitude; low sensitivity to vibration, polarization and wavelength</a:t>
+                        <a:t>Vector Zernike: ±π/2 on opposite circular polarizations gives two pupil images, an exact phase-and-amplitude solution, an iterated b, achromatic to 100 % bandwidth; the leakage terms are written down</a:t>
                       </a:r>
                     </a:p>
                   </a:txBody>
@@ -8995,7 +9225,7 @@
                           </a:solidFill>
                           <a:latin typeface="Arial"/>
                         </a:rPr>
-                        <a:t>9</a:t>
+                        <a:t>3</a:t>
                       </a:r>
                     </a:p>
                   </a:txBody>
@@ -9017,7 +9247,7 @@
                           </a:solidFill>
                           <a:latin typeface="Arial"/>
                         </a:rPr>
-                        <a:t>Moore and Redding 2018, SPIE 10698</a:t>
+                        <a:t>N'Diaye, Vigan, Dohlen et al. 2016, A&amp;A 592, A79 (ZELDA II)</a:t>
                       </a:r>
                     </a:p>
                   </a:txBody>
@@ -9039,7 +9269,7 @@
                           </a:solidFill>
                           <a:latin typeface="Arial"/>
                         </a:rPr>
-                        <a:t>Nonlinear polychromatic physical-optics reconstruction for picometer differential metrology on LUVOIR; the in-house precedent for the reconstructor above</a:t>
+                        <a:t>Second-order reconstruction with b from the mask model; 1.06 λ/D at π/2; range −0.14 to +0.36 λ; the sensitivity factor drifts 10 % day to day on SPHERE</a:t>
                       </a:r>
                     </a:p>
                   </a:txBody>
@@ -9063,7 +9293,7 @@
                           </a:solidFill>
                           <a:latin typeface="Arial"/>
                         </a:rPr>
-                        <a:t>10</a:t>
+                        <a:t>4</a:t>
                       </a:r>
                     </a:p>
                   </a:txBody>
@@ -9085,7 +9315,7 @@
                           </a:solidFill>
                           <a:latin typeface="Arial"/>
                         </a:rPr>
-                        <a:t>Keck vector-Zernike segment control 2024 (arXiv 2404.08728); Wallace et al. 2022 (arXiv 2205.02241)</a:t>
+                        <a:t>Chambouleyron, Cissé, Salama, Haffert, Wallace et al. 2024, SPIE 13097</a:t>
                       </a:r>
                     </a:p>
                   </a:txBody>
@@ -9107,7 +9337,7 @@
                           </a:solidFill>
                           <a:latin typeface="Arial"/>
                         </a:rPr>
-                        <a:t>Segment piston by model-based iteration; 11 nm rms piston uncertainty; underestimation 2 to 4× below 50 % Strehl; fabricated shifts 0.30π and 0.68π instead of ±0.5π</a:t>
+                        <a:t>A phase-shifted pair (±π/2) yields cos φ and sin φ; iterative reconstructors reach about 1 rad rms; the bench limits were polarization crosstalk and defocus between the two pupils</a:t>
                       </a:r>
                     </a:p>
                   </a:txBody>
@@ -9131,7 +9361,7 @@
                           </a:solidFill>
                           <a:latin typeface="Arial"/>
                         </a:rPr>
-                        <a:t>11</a:t>
+                        <a:t>5</a:t>
                       </a:r>
                     </a:p>
                   </a:txBody>
@@ -9153,7 +9383,7 @@
                           </a:solidFill>
                           <a:latin typeface="Arial"/>
                         </a:rPr>
-                        <a:t>HiCAT mid-order Zernike sensor 2024 (arXiv 2409.03411)</a:t>
+                        <a:t>Haffert 2024, A&amp;A 683, A113</a:t>
                       </a:r>
                     </a:p>
                   </a:txBody>
@@ -9175,7 +9405,7 @@
                           </a:solidFill>
                           <a:latin typeface="Arial"/>
                         </a:rPr>
-                        <a:t>Per-segment piston, tip and tilt by interaction matrix; a minimal step of 125 ± 31 pm at SNR 4; 14-bit DM quantization reads as steps in the response</a:t>
+                        <a:t>Iterative nonlinear reconstructors reach machine precision below 0.25 rad rms; phase sorting extends to 0.75 rad; adding wavelengths to 1.4 rad rms</a:t>
                       </a:r>
                     </a:p>
                   </a:txBody>
@@ -9199,7 +9429,7 @@
                           </a:solidFill>
                           <a:latin typeface="Arial"/>
                         </a:rPr>
-                        <a:t>12</a:t>
+                        <a:t>6</a:t>
                       </a:r>
                     </a:p>
                   </a:txBody>
@@ -9221,7 +9451,7 @@
                           </a:solidFill>
                           <a:latin typeface="Arial"/>
                         </a:rPr>
-                        <a:t>Shi et al. 2015, SPIE 9605 (Roman low-order sensor)</a:t>
+                        <a:t>Darcis, Haffert, Chambouleyron, Doelman et al. 2025, A&amp;A</a:t>
                       </a:r>
                     </a:p>
                   </a:txBody>
@@ -9243,7 +9473,7 @@
                           </a:solidFill>
                           <a:latin typeface="Arial"/>
                         </a:rPr>
-                        <a:t>A reflective dimple on the focal-plane mask senses Z2 to Z11 from the rejected starlight: the spatially filtered form of the same sensor</a:t>
+                        <a:t>Multi-wavelength gradient descent through the forward model: dynamic range for the scalar sensor, photon robustness across a wider band, two-wavelength unwrapping of petal errors</a:t>
                       </a:r>
                     </a:p>
                   </a:txBody>
@@ -9292,7 +9522,7 @@
                 </a:solidFill>
                 <a:latin typeface="Arial"/>
               </a:rPr>
-              <a:t>Also read: PIAA-ZWFS (2026, arXiv 2606.28136), lossless pupil apodization that closes the gap to the fundamental sensitivity limit by 10× — a design lever, not a model change.</a:t>
+              <a:t>Priority = payoff against this campaign's measured weak results.  Synopses and links: macos/REPORT_zwfs_lit_scan.md.</a:t>
             </a:r>
           </a:p>
         </p:txBody>
@@ -9349,7 +9579,7 @@
                 </a:solidFill>
                 <a:latin typeface="Arial"/>
               </a:rPr>
-              <a:t>Conclusions: what the corrected model and the exact reading settled</a:t>
+              <a:t>Demonstrations, segmented mirrors, and the in-house precedent</a:t>
             </a:r>
           </a:p>
           <a:p>
@@ -9365,7 +9595,7 @@
                 </a:solidFill>
                 <a:latin typeface="Arial"/>
               </a:rPr>
-              <a:t>Fixing the model was the bigger gain; a response matrix measured on the working surface takes the stepped reading to 5 pm; color and photons are not the limit</a:t>
+              <a:t>Picometers by alternating DM shapes and averaging; segment piston by model iteration, underestimated below 50 % Strehl</a:t>
             </a:r>
           </a:p>
         </p:txBody>
@@ -9414,15 +9644,518 @@
           </a:p>
         </p:txBody>
       </p:sp>
-      <p:sp>
-        <p:nvSpPr>
-          <p:cNvPr id="4" name="TextBox 3"/>
+      <p:graphicFrame>
+        <p:nvGraphicFramePr>
+          <p:cNvPr id="4" name="Table 3"/>
+          <p:cNvGraphicFramePr>
+            <a:graphicFrameLocks noGrp="1"/>
+          </p:cNvGraphicFramePr>
+          <p:nvPr/>
+        </p:nvGraphicFramePr>
+        <p:xfrm>
+          <a:off x="411480" y="1298448"/>
+          <a:ext cx="11368734" cy="3091815"/>
+        </p:xfrm>
+        <a:graphic>
+          <a:graphicData uri="http://schemas.openxmlformats.org/drawingml/2006/table">
+            <a:tbl>
+              <a:tblPr firstRow="1" bandRow="1">
+                <a:tableStyleId>{5C22544A-7EE6-4342-B048-85BDC9FD1C3A}</a:tableStyleId>
+              </a:tblPr>
+              <a:tblGrid>
+                <a:gridCol w="291592"/>
+                <a:gridCol w="3730058"/>
+                <a:gridCol w="7347084"/>
+              </a:tblGrid>
+              <a:tr h="280035">
+                <a:tc>
+                  <a:txBody>
+                    <a:bodyPr wrap="square"/>
+                    <a:lstStyle/>
+                    <a:p>
+                      <a:r>
+                        <a:rPr sz="1100" b="1">
+                          <a:solidFill>
+                            <a:srgbClr val="FFFFFF"/>
+                          </a:solidFill>
+                          <a:latin typeface="Arial"/>
+                        </a:rPr>
+                        <a:t>#</a:t>
+                      </a:r>
+                    </a:p>
+                  </a:txBody>
+                  <a:tcPr marL="54864" marR="54864" marT="18288" marB="18288">
+                    <a:solidFill>
+                      <a:srgbClr val="1F4E79"/>
+                    </a:solidFill>
+                  </a:tcPr>
+                </a:tc>
+                <a:tc>
+                  <a:txBody>
+                    <a:bodyPr wrap="square"/>
+                    <a:lstStyle/>
+                    <a:p>
+                      <a:r>
+                        <a:rPr sz="1100" b="1">
+                          <a:solidFill>
+                            <a:srgbClr val="FFFFFF"/>
+                          </a:solidFill>
+                          <a:latin typeface="Arial"/>
+                        </a:rPr>
+                        <a:t>paper</a:t>
+                      </a:r>
+                    </a:p>
+                  </a:txBody>
+                  <a:tcPr marL="54864" marR="54864" marT="18288" marB="18288">
+                    <a:solidFill>
+                      <a:srgbClr val="1F4E79"/>
+                    </a:solidFill>
+                  </a:tcPr>
+                </a:tc>
+                <a:tc>
+                  <a:txBody>
+                    <a:bodyPr wrap="square"/>
+                    <a:lstStyle/>
+                    <a:p>
+                      <a:r>
+                        <a:rPr sz="1100" b="1">
+                          <a:solidFill>
+                            <a:srgbClr val="FFFFFF"/>
+                          </a:solidFill>
+                          <a:latin typeface="Arial"/>
+                        </a:rPr>
+                        <a:t>what it gives this model</a:t>
+                      </a:r>
+                    </a:p>
+                  </a:txBody>
+                  <a:tcPr marL="54864" marR="54864" marT="18288" marB="18288">
+                    <a:solidFill>
+                      <a:srgbClr val="1F4E79"/>
+                    </a:solidFill>
+                  </a:tcPr>
+                </a:tc>
+              </a:tr>
+              <a:tr h="468630">
+                <a:tc>
+                  <a:txBody>
+                    <a:bodyPr wrap="square"/>
+                    <a:lstStyle/>
+                    <a:p>
+                      <a:r>
+                        <a:rPr sz="1100" b="0">
+                          <a:solidFill>
+                            <a:srgbClr val="282828"/>
+                          </a:solidFill>
+                          <a:latin typeface="Arial"/>
+                        </a:rPr>
+                        <a:t>7</a:t>
+                      </a:r>
+                    </a:p>
+                  </a:txBody>
+                  <a:tcPr marL="54864" marR="54864" marT="18288" marB="18288">
+                    <a:solidFill>
+                      <a:srgbClr val="FFFFFF"/>
+                    </a:solidFill>
+                  </a:tcPr>
+                </a:tc>
+                <a:tc>
+                  <a:txBody>
+                    <a:bodyPr wrap="square"/>
+                    <a:lstStyle/>
+                    <a:p>
+                      <a:r>
+                        <a:rPr sz="1100" b="0">
+                          <a:solidFill>
+                            <a:srgbClr val="282828"/>
+                          </a:solidFill>
+                          <a:latin typeface="Arial"/>
+                        </a:rPr>
+                        <a:t>Steeves, Wallace, Kettenbeil, Jewell 2020, Optica 7, 1267</a:t>
+                      </a:r>
+                    </a:p>
+                  </a:txBody>
+                  <a:tcPr marL="54864" marR="54864" marT="18288" marB="18288">
+                    <a:solidFill>
+                      <a:srgbClr val="FFFFFF"/>
+                    </a:solidFill>
+                  </a:tcPr>
+                </a:tc>
+                <a:tc>
+                  <a:txBody>
+                    <a:bodyPr wrap="square"/>
+                    <a:lstStyle/>
+                    <a:p>
+                      <a:r>
+                        <a:rPr sz="1100" b="0">
+                          <a:solidFill>
+                            <a:srgbClr val="282828"/>
+                          </a:solidFill>
+                          <a:latin typeface="Arial"/>
+                        </a:rPr>
+                        <a:t>1.6 pm repeatability in 4.3 s by alternating flat and waffle DM shapes and averaging the differences; a reconstruction robust at the highest spatial frequencies</a:t>
+                      </a:r>
+                    </a:p>
+                  </a:txBody>
+                  <a:tcPr marL="54864" marR="54864" marT="18288" marB="18288">
+                    <a:solidFill>
+                      <a:srgbClr val="FFFFFF"/>
+                    </a:solidFill>
+                  </a:tcPr>
+                </a:tc>
+              </a:tr>
+              <a:tr h="468630">
+                <a:tc>
+                  <a:txBody>
+                    <a:bodyPr wrap="square"/>
+                    <a:lstStyle/>
+                    <a:p>
+                      <a:r>
+                        <a:rPr sz="1100" b="0">
+                          <a:solidFill>
+                            <a:srgbClr val="282828"/>
+                          </a:solidFill>
+                          <a:latin typeface="Arial"/>
+                        </a:rPr>
+                        <a:t>8</a:t>
+                      </a:r>
+                    </a:p>
+                  </a:txBody>
+                  <a:tcPr marL="54864" marR="54864" marT="18288" marB="18288">
+                    <a:solidFill>
+                      <a:srgbClr val="ECF1F6"/>
+                    </a:solidFill>
+                  </a:tcPr>
+                </a:tc>
+                <a:tc>
+                  <a:txBody>
+                    <a:bodyPr wrap="square"/>
+                    <a:lstStyle/>
+                    <a:p>
+                      <a:r>
+                        <a:rPr sz="1100" b="0">
+                          <a:solidFill>
+                            <a:srgbClr val="282828"/>
+                          </a:solidFill>
+                          <a:latin typeface="Arial"/>
+                        </a:rPr>
+                        <a:t>Wallace, Rao, Jensen-Clem, Serabyn 2011, SPIE 8126</a:t>
+                      </a:r>
+                    </a:p>
+                  </a:txBody>
+                  <a:tcPr marL="54864" marR="54864" marT="18288" marB="18288">
+                    <a:solidFill>
+                      <a:srgbClr val="ECF1F6"/>
+                    </a:solidFill>
+                  </a:tcPr>
+                </a:tc>
+                <a:tc>
+                  <a:txBody>
+                    <a:bodyPr wrap="square"/>
+                    <a:lstStyle/>
+                    <a:p>
+                      <a:r>
+                        <a:rPr sz="1100" b="0">
+                          <a:solidFill>
+                            <a:srgbClr val="282828"/>
+                          </a:solidFill>
+                          <a:latin typeface="Arial"/>
+                        </a:rPr>
+                        <a:t>All-reflective phase-shifting Zernike interferometer: a dynamic, arbitrary core phase shift read in four steps gives phase and amplitude; low sensitivity to vibration, polarization and wavelength</a:t>
+                      </a:r>
+                    </a:p>
+                  </a:txBody>
+                  <a:tcPr marL="54864" marR="54864" marT="18288" marB="18288">
+                    <a:solidFill>
+                      <a:srgbClr val="ECF1F6"/>
+                    </a:solidFill>
+                  </a:tcPr>
+                </a:tc>
+              </a:tr>
+              <a:tr h="468630">
+                <a:tc>
+                  <a:txBody>
+                    <a:bodyPr wrap="square"/>
+                    <a:lstStyle/>
+                    <a:p>
+                      <a:r>
+                        <a:rPr sz="1100" b="0">
+                          <a:solidFill>
+                            <a:srgbClr val="282828"/>
+                          </a:solidFill>
+                          <a:latin typeface="Arial"/>
+                        </a:rPr>
+                        <a:t>9</a:t>
+                      </a:r>
+                    </a:p>
+                  </a:txBody>
+                  <a:tcPr marL="54864" marR="54864" marT="18288" marB="18288">
+                    <a:solidFill>
+                      <a:srgbClr val="FFFFFF"/>
+                    </a:solidFill>
+                  </a:tcPr>
+                </a:tc>
+                <a:tc>
+                  <a:txBody>
+                    <a:bodyPr wrap="square"/>
+                    <a:lstStyle/>
+                    <a:p>
+                      <a:r>
+                        <a:rPr sz="1100" b="0">
+                          <a:solidFill>
+                            <a:srgbClr val="282828"/>
+                          </a:solidFill>
+                          <a:latin typeface="Arial"/>
+                        </a:rPr>
+                        <a:t>Moore and Redding 2018, SPIE 10698</a:t>
+                      </a:r>
+                    </a:p>
+                  </a:txBody>
+                  <a:tcPr marL="54864" marR="54864" marT="18288" marB="18288">
+                    <a:solidFill>
+                      <a:srgbClr val="FFFFFF"/>
+                    </a:solidFill>
+                  </a:tcPr>
+                </a:tc>
+                <a:tc>
+                  <a:txBody>
+                    <a:bodyPr wrap="square"/>
+                    <a:lstStyle/>
+                    <a:p>
+                      <a:r>
+                        <a:rPr sz="1100" b="0">
+                          <a:solidFill>
+                            <a:srgbClr val="282828"/>
+                          </a:solidFill>
+                          <a:latin typeface="Arial"/>
+                        </a:rPr>
+                        <a:t>Nonlinear polychromatic physical-optics reconstruction for picometer differential metrology on LUVOIR; the in-house precedent for the reconstructor above</a:t>
+                      </a:r>
+                    </a:p>
+                  </a:txBody>
+                  <a:tcPr marL="54864" marR="54864" marT="18288" marB="18288">
+                    <a:solidFill>
+                      <a:srgbClr val="FFFFFF"/>
+                    </a:solidFill>
+                  </a:tcPr>
+                </a:tc>
+              </a:tr>
+              <a:tr h="468630">
+                <a:tc>
+                  <a:txBody>
+                    <a:bodyPr wrap="square"/>
+                    <a:lstStyle/>
+                    <a:p>
+                      <a:r>
+                        <a:rPr sz="1100" b="0">
+                          <a:solidFill>
+                            <a:srgbClr val="282828"/>
+                          </a:solidFill>
+                          <a:latin typeface="Arial"/>
+                        </a:rPr>
+                        <a:t>10</a:t>
+                      </a:r>
+                    </a:p>
+                  </a:txBody>
+                  <a:tcPr marL="54864" marR="54864" marT="18288" marB="18288">
+                    <a:solidFill>
+                      <a:srgbClr val="ECF1F6"/>
+                    </a:solidFill>
+                  </a:tcPr>
+                </a:tc>
+                <a:tc>
+                  <a:txBody>
+                    <a:bodyPr wrap="square"/>
+                    <a:lstStyle/>
+                    <a:p>
+                      <a:r>
+                        <a:rPr sz="1100" b="0">
+                          <a:solidFill>
+                            <a:srgbClr val="282828"/>
+                          </a:solidFill>
+                          <a:latin typeface="Arial"/>
+                        </a:rPr>
+                        <a:t>Keck vector-Zernike segment control 2024 (arXiv 2404.08728); Wallace et al. 2022 (arXiv 2205.02241)</a:t>
+                      </a:r>
+                    </a:p>
+                  </a:txBody>
+                  <a:tcPr marL="54864" marR="54864" marT="18288" marB="18288">
+                    <a:solidFill>
+                      <a:srgbClr val="ECF1F6"/>
+                    </a:solidFill>
+                  </a:tcPr>
+                </a:tc>
+                <a:tc>
+                  <a:txBody>
+                    <a:bodyPr wrap="square"/>
+                    <a:lstStyle/>
+                    <a:p>
+                      <a:r>
+                        <a:rPr sz="1100" b="0">
+                          <a:solidFill>
+                            <a:srgbClr val="282828"/>
+                          </a:solidFill>
+                          <a:latin typeface="Arial"/>
+                        </a:rPr>
+                        <a:t>Segment piston by model-based iteration; 11 nm rms piston uncertainty; underestimation 2 to 4× below 50 % Strehl; fabricated shifts 0.30π and 0.68π instead of ±0.5π</a:t>
+                      </a:r>
+                    </a:p>
+                  </a:txBody>
+                  <a:tcPr marL="54864" marR="54864" marT="18288" marB="18288">
+                    <a:solidFill>
+                      <a:srgbClr val="ECF1F6"/>
+                    </a:solidFill>
+                  </a:tcPr>
+                </a:tc>
+              </a:tr>
+              <a:tr h="468630">
+                <a:tc>
+                  <a:txBody>
+                    <a:bodyPr wrap="square"/>
+                    <a:lstStyle/>
+                    <a:p>
+                      <a:r>
+                        <a:rPr sz="1100" b="0">
+                          <a:solidFill>
+                            <a:srgbClr val="282828"/>
+                          </a:solidFill>
+                          <a:latin typeface="Arial"/>
+                        </a:rPr>
+                        <a:t>11</a:t>
+                      </a:r>
+                    </a:p>
+                  </a:txBody>
+                  <a:tcPr marL="54864" marR="54864" marT="18288" marB="18288">
+                    <a:solidFill>
+                      <a:srgbClr val="FFFFFF"/>
+                    </a:solidFill>
+                  </a:tcPr>
+                </a:tc>
+                <a:tc>
+                  <a:txBody>
+                    <a:bodyPr wrap="square"/>
+                    <a:lstStyle/>
+                    <a:p>
+                      <a:r>
+                        <a:rPr sz="1100" b="0">
+                          <a:solidFill>
+                            <a:srgbClr val="282828"/>
+                          </a:solidFill>
+                          <a:latin typeface="Arial"/>
+                        </a:rPr>
+                        <a:t>HiCAT mid-order Zernike sensor 2024 (arXiv 2409.03411)</a:t>
+                      </a:r>
+                    </a:p>
+                  </a:txBody>
+                  <a:tcPr marL="54864" marR="54864" marT="18288" marB="18288">
+                    <a:solidFill>
+                      <a:srgbClr val="FFFFFF"/>
+                    </a:solidFill>
+                  </a:tcPr>
+                </a:tc>
+                <a:tc>
+                  <a:txBody>
+                    <a:bodyPr wrap="square"/>
+                    <a:lstStyle/>
+                    <a:p>
+                      <a:r>
+                        <a:rPr sz="1100" b="0">
+                          <a:solidFill>
+                            <a:srgbClr val="282828"/>
+                          </a:solidFill>
+                          <a:latin typeface="Arial"/>
+                        </a:rPr>
+                        <a:t>Per-segment piston, tip and tilt by interaction matrix; a minimal step of 125 ± 31 pm at SNR 4; 14-bit DM quantization reads as steps in the response</a:t>
+                      </a:r>
+                    </a:p>
+                  </a:txBody>
+                  <a:tcPr marL="54864" marR="54864" marT="18288" marB="18288">
+                    <a:solidFill>
+                      <a:srgbClr val="FFFFFF"/>
+                    </a:solidFill>
+                  </a:tcPr>
+                </a:tc>
+              </a:tr>
+              <a:tr h="468630">
+                <a:tc>
+                  <a:txBody>
+                    <a:bodyPr wrap="square"/>
+                    <a:lstStyle/>
+                    <a:p>
+                      <a:r>
+                        <a:rPr sz="1100" b="0">
+                          <a:solidFill>
+                            <a:srgbClr val="282828"/>
+                          </a:solidFill>
+                          <a:latin typeface="Arial"/>
+                        </a:rPr>
+                        <a:t>12</a:t>
+                      </a:r>
+                    </a:p>
+                  </a:txBody>
+                  <a:tcPr marL="54864" marR="54864" marT="18288" marB="18288">
+                    <a:solidFill>
+                      <a:srgbClr val="ECF1F6"/>
+                    </a:solidFill>
+                  </a:tcPr>
+                </a:tc>
+                <a:tc>
+                  <a:txBody>
+                    <a:bodyPr wrap="square"/>
+                    <a:lstStyle/>
+                    <a:p>
+                      <a:r>
+                        <a:rPr sz="1100" b="0">
+                          <a:solidFill>
+                            <a:srgbClr val="282828"/>
+                          </a:solidFill>
+                          <a:latin typeface="Arial"/>
+                        </a:rPr>
+                        <a:t>Shi et al. 2015, SPIE 9605 (Roman low-order sensor)</a:t>
+                      </a:r>
+                    </a:p>
+                  </a:txBody>
+                  <a:tcPr marL="54864" marR="54864" marT="18288" marB="18288">
+                    <a:solidFill>
+                      <a:srgbClr val="ECF1F6"/>
+                    </a:solidFill>
+                  </a:tcPr>
+                </a:tc>
+                <a:tc>
+                  <a:txBody>
+                    <a:bodyPr wrap="square"/>
+                    <a:lstStyle/>
+                    <a:p>
+                      <a:r>
+                        <a:rPr sz="1100" b="0">
+                          <a:solidFill>
+                            <a:srgbClr val="282828"/>
+                          </a:solidFill>
+                          <a:latin typeface="Arial"/>
+                        </a:rPr>
+                        <a:t>A reflective dimple on the focal-plane mask senses Z2 to Z11 from the rejected starlight: the spatially filtered form of the same sensor</a:t>
+                      </a:r>
+                    </a:p>
+                  </a:txBody>
+                  <a:tcPr marL="54864" marR="54864" marT="18288" marB="18288">
+                    <a:solidFill>
+                      <a:srgbClr val="ECF1F6"/>
+                    </a:solidFill>
+                  </a:tcPr>
+                </a:tc>
+              </a:tr>
+            </a:tbl>
+          </a:graphicData>
+        </a:graphic>
+      </p:graphicFrame>
+      <p:sp>
+        <p:nvSpPr>
+          <p:cNvPr id="5" name="TextBox 4"/>
           <p:cNvSpPr txBox="1"/>
           <p:nvPr/>
         </p:nvSpPr>
         <p:spPr>
           <a:xfrm>
-            <a:off x="411480" y="1298448"/>
+            <a:off x="411480" y="4536567"/>
             <a:ext cx="11368735" cy="274320"/>
           </a:xfrm>
           <a:prstGeom prst="rect">
@@ -9442,132 +10175,13 @@
               </a:spcAft>
             </a:pPr>
             <a:r>
-              <a:rPr sz="1500" b="0">
-                <a:solidFill>
-                  <a:srgbClr val="282828"/>
+              <a:rPr sz="1050" b="0">
+                <a:solidFill>
+                  <a:srgbClr val="6E6E6E"/>
                 </a:solidFill>
                 <a:latin typeface="Arial"/>
               </a:rPr>
-              <a:t>•  The model must keep the pupil image in focus: the two spheres around the mask share one radius, and the script checks the no-mask round trip on every run.  The correction alone took the single-actuator floor from 744 to 67 pm and made the undetected grid case detectable.</a:t>
-            </a:r>
-          </a:p>
-          <a:p>
-            <a:pPr>
-              <a:spcAft>
-                <a:spcPts val="600"/>
-              </a:spcAft>
-            </a:pPr>
-            <a:r>
-              <a:rPr sz="1500" b="0">
-                <a:solidFill>
-                  <a:srgbClr val="282828"/>
-                </a:solidFill>
-                <a:latin typeface="Arial"/>
-              </a:rPr>
-              <a:t>•  The exact reading with a re-computed reference is the import that paid (paper 1): 26 pm from one frame on a 30 nm working surface, SNR 355 — with the sign fold settled once from four stepped frames and refined.  The plain stepped sign map misses 3% of pixels and can flip a single actuator's sign.</a:t>
-            </a:r>
-          </a:p>
-          <a:p>
-            <a:pPr>
-              <a:spcAft>
-                <a:spcPts val="600"/>
-              </a:spcAft>
-            </a:pPr>
-            <a:r>
-              <a:rPr sz="1500" b="0">
-                <a:solidFill>
-                  <a:srgbClr val="282828"/>
-                </a:solidFill>
-                <a:latin typeface="Arial"/>
-              </a:rPr>
-              <a:t>•  Calibrate with a measured response matrix, on the working surface: the sparse-grid measurement of every actuator's response (with the sensor's piston null carried) reads a single actuator on the flat at 0.994 with a 4 pm floor; measured on the working surface it gives the stepped reading 0.99 and 5 pm there and makes the linear one-frame reading usable (1.05, 23 pm).  The floors fall ten times; what remains is gain stability as the surface drifts (7% over 20 nm rms) and the one-frame exact readings' sign fold.</a:t>
-            </a:r>
-          </a:p>
-          <a:p>
-            <a:pPr>
-              <a:spcAft>
-                <a:spcPts val="600"/>
-              </a:spcAft>
-            </a:pPr>
-            <a:r>
-              <a:rPr sz="1500" b="0">
-                <a:solidFill>
-                  <a:srgbClr val="282828"/>
-                </a:solidFill>
-                <a:latin typeface="Arial"/>
-              </a:rPr>
-              <a:t>•  Sampling is settled, and a bias in the fit is fixed: camera pixels per actuator (the ray count) set the gain on a test actuator; sampling the single-site response pattern at the actuator center took that gain to 0.996 at 5 pixels per actuator.</a:t>
-            </a:r>
-          </a:p>
-          <a:p>
-            <a:pPr>
-              <a:spcAft>
-                <a:spcPts val="600"/>
-              </a:spcAft>
-            </a:pPr>
-            <a:r>
-              <a:rPr sz="1500" b="0">
-                <a:solidFill>
-                  <a:srgbClr val="282828"/>
-                </a:solidFill>
-                <a:latin typeface="Arial"/>
-              </a:rPr>
-              <a:t>•  Color and photons are not levers: the chromatic null was the defocus; 10¹⁴ photons per measurement reach 1 pm.  The budget is systematic error: the 25 to 60 pm floors and the gain's stability.</a:t>
-            </a:r>
-          </a:p>
-          <a:p>
-            <a:pPr>
-              <a:spcAft>
-                <a:spcPts val="600"/>
-              </a:spcAft>
-            </a:pPr>
-            <a:r>
-              <a:rPr sz="1500" b="0">
-                <a:solidFill>
-                  <a:srgbClr val="282828"/>
-                </a:solidFill>
-                <a:latin typeface="Arial"/>
-              </a:rPr>
-              <a:t>•  In closed loop the stepped reading has no fixed error: it holds a 2 pm-per-cycle walk to 3 pm from 7.5×10¹² photons per cycle and returns to zero after a step; the linear reading costs the same light but leaves a fine-scale error under a slow ramp; the one-frame exact reading runs away.</a:t>
-            </a:r>
-          </a:p>
-        </p:txBody>
-      </p:sp>
-      <p:sp>
-        <p:nvSpPr>
-          <p:cNvPr id="5" name="TextBox 4"/>
-          <p:cNvSpPr txBox="1"/>
-          <p:nvPr/>
-        </p:nvSpPr>
-        <p:spPr>
-          <a:xfrm>
-            <a:off x="411480" y="6881622"/>
-            <a:ext cx="11368735" cy="274320"/>
-          </a:xfrm>
-          <a:prstGeom prst="rect">
-            <a:avLst/>
-          </a:prstGeom>
-          <a:noFill/>
-        </p:spPr>
-        <p:txBody>
-          <a:bodyPr wrap="square">
-            <a:spAutoFit/>
-          </a:bodyPr>
-          <a:lstStyle/>
-          <a:p>
-            <a:pPr>
-              <a:spcAft>
-                <a:spcPts val="600"/>
-              </a:spcAft>
-            </a:pPr>
-            <a:r>
-              <a:rPr sz="1050" b="0">
-                <a:solidFill>
-                  <a:srgbClr val="6E6E6E"/>
-                </a:solidFill>
-                <a:latin typeface="Arial"/>
-              </a:rPr>
-              <a:t>Script and records: templates/40_benches/zwfs_dm96 (README S7/S8; runs/rec193, ng385, ng385s3, m2048, rec193full).</a:t>
+              <a:t>Also read: PIAA-ZWFS (2026, arXiv 2606.28136), lossless pupil apodization that closes the gap to the fundamental sensitivity limit by 10× — a design lever, not a model change.</a:t>
             </a:r>
           </a:p>
         </p:txBody>
@@ -9914,7 +10528,7 @@
                 </a:solidFill>
                 <a:latin typeface="Arial"/>
               </a:rPr>
-              <a:t>Conclusions: what to import next, in order</a:t>
+              <a:t>Conclusions: what the corrected model and the exact reading settled</a:t>
             </a:r>
           </a:p>
           <a:p>
@@ -9930,7 +10544,7 @@
                 </a:solidFill>
                 <a:latin typeface="Arial"/>
               </a:rPr>
-              <a:t>The JPL budget form, DM calibration through the sensor's own images, the vector sensor priced before it is built, and the interferometer's lever</a:t>
+              <a:t>Fixing the model was the bigger gain; a response matrix measured on the working surface takes the stepped reading to 5 pm; color and photons are not the limit</a:t>
             </a:r>
           </a:p>
         </p:txBody>
@@ -10013,7 +10627,7 @@
                 </a:solidFill>
                 <a:latin typeface="Arial"/>
               </a:rPr>
-              <a:t>•  The JPL budget form: a sensitivity factor per pixel from the measured fields — the quantity the working-surface effect on slide 10 is made of — predicts the photon-noise stage analytically, and four systematic terms (pupil calibration at ½, reference wave at 1, dimple depth, initial phase) become the rows of the error budget.</a:t>
+              <a:t>•  The model must keep the pupil image in focus: the two spheres around the mask share one radius, and the script checks the no-mask round trip on every run.  The correction alone took the single-actuator floor from 744 to 67 pm and made the undetected grid case detectable.</a:t>
             </a:r>
           </a:p>
           <a:p>
@@ -10029,7 +10643,7 @@
                 </a:solidFill>
                 <a:latin typeface="Arial"/>
               </a:rPr>
-              <a:t>•  The response matrix for the interferometer too: its calibration still uses a single-site response pattern, with the stencil bias fixed here (slide 9); the sparse-grid measured matrix is the calibration its reflective build should carry.  Model-matched DM calibration (actuator positions and gains through the sensor's own images) remains the lever for a real DM's geometry.</a:t>
+              <a:t>•  The exact reading with a re-computed reference is the import that paid (paper 1): 26 pm from one frame on a 30 nm working surface, SNR 355 — with the sign fold settled once from four stepped frames and refined.  The plain stepped sign map misses 3% of pixels and can flip a single actuator's sign.</a:t>
             </a:r>
           </a:p>
           <a:p>
@@ -10045,7 +10659,7 @@
                 </a:solidFill>
                 <a:latin typeface="Arial"/>
               </a:rPr>
-              <a:t>•  Color as a joint fit, not a combination: an equal-weight combination inherits a bad channel; a joint fit through the exact reading would use 700 to 780 nm for range and 632.8 nm for the calibration of record.</a:t>
+              <a:t>•  Calibrate with a measured response matrix, on the working surface: the sparse-grid measurement of every actuator's response (with the sensor's piston null carried) reads a single actuator on the flat at 0.994 with a 4 pm floor; measured on the working surface it gives the stepped reading 0.99 and 5 pm there and makes the linear one-frame reading usable (1.05, 23 pm).  The floors fall ten times; what remains is gain stability as the surface drifts (7% over 20 nm rms) and the one-frame exact readings' sign fold.</a:t>
             </a:r>
           </a:p>
           <a:p>
@@ -10061,7 +10675,7 @@
                 </a:solidFill>
                 <a:latin typeface="Arial"/>
               </a:rPr>
-              <a:t>•  Model the vector sensor before the metasurface is built: the exact two-image solution and its leakage terms (retardance offsets, splitter rotation) run on the engine's polarization machinery; the bench limits at Keck and SEAL were defocus and crosstalk between the two pupil images, both priceable here.</a:t>
+              <a:t>•  Sampling is settled, and a bias in the fit is fixed: camera pixels per actuator (the ray count) set the gain on a test actuator; sampling the single-site response pattern at the actuator center took that gain to 0.996 at 5 pixels per actuator.</a:t>
             </a:r>
           </a:p>
           <a:p>
@@ -10077,7 +10691,39 @@
                 </a:solidFill>
                 <a:latin typeface="Arial"/>
               </a:rPr>
-              <a:t>•  The interferometer, for balance: a PZT phase shift buys no model gain — its floors are geometric and color-independent — but on hardware an absolute phase scale and freedom from polarization systematics; the recommended form is a hybrid: polarization snapshot for the change measurements, a PZT on the reference flat as calibrator.  Its all-mirror (OAP) version is in build.</a:t>
+              <a:t>•  Color and photons are not levers: the chromatic null was the defocus; 10¹⁴ photons per measurement reach 1 pm.  The budget is systematic error: the 25 to 60 pm floors and the gain's stability.</a:t>
+            </a:r>
+          </a:p>
+          <a:p>
+            <a:pPr>
+              <a:spcAft>
+                <a:spcPts val="600"/>
+              </a:spcAft>
+            </a:pPr>
+            <a:r>
+              <a:rPr sz="1500" b="0">
+                <a:solidFill>
+                  <a:srgbClr val="282828"/>
+                </a:solidFill>
+                <a:latin typeface="Arial"/>
+              </a:rPr>
+              <a:t>•  In closed loop the stepped reading has no fixed error: it holds a 2 pm-per-cycle walk to 3 pm from 7.5×10¹² photons per cycle and returns to zero after a step; the linear reading costs the same light but leaves a fine-scale error under a slow ramp; the one-frame exact reading runs away.</a:t>
+            </a:r>
+          </a:p>
+          <a:p>
+            <a:pPr>
+              <a:spcAft>
+                <a:spcPts val="600"/>
+              </a:spcAft>
+            </a:pPr>
+            <a:r>
+              <a:rPr sz="1500" b="0">
+                <a:solidFill>
+                  <a:srgbClr val="282828"/>
+                </a:solidFill>
+                <a:latin typeface="Arial"/>
+              </a:rPr>
+              <a:t>•  The polarized dimple is the best reading on every line: two simultaneous frames, no fold, 3 pm held from 5.3×10¹² photons per cycle, and a calibration that stays within 2% out to 60 nm rms.</a:t>
             </a:r>
           </a:p>
         </p:txBody>
@@ -10090,7 +10736,7 @@
         </p:nvSpPr>
         <p:spPr>
           <a:xfrm>
-            <a:off x="411480" y="5998464"/>
+            <a:off x="411480" y="7517130"/>
             <a:ext cx="11368735" cy="274320"/>
           </a:xfrm>
           <a:prstGeom prst="rect">
@@ -10116,7 +10762,7 @@
                 </a:solidFill>
                 <a:latin typeface="Arial"/>
               </a:rPr>
-              <a:t>Segmented-mirror lessons carried forward: the sensor reads segment piston but not global piston, DM quantization appears as steps in the response, and piston is underestimated below 50 % Strehl (Keck) — all three enter the e5-class segmented gauges.</a:t>
+              <a:t>Script and records: templates/40_benches/zwfs_dm96 (README S7/S8; runs/rec193, ng385, ng385s3, m2048, rec193full).</a:t>
             </a:r>
           </a:p>
         </p:txBody>
@@ -10147,63 +10793,6 @@
         </p:nvSpPr>
         <p:spPr>
           <a:xfrm>
-            <a:off x="822960" y="2743200"/>
-            <a:ext cx="10545775" cy="1280160"/>
-          </a:xfrm>
-          <a:prstGeom prst="rect">
-            <a:avLst/>
-          </a:prstGeom>
-          <a:noFill/>
-        </p:spPr>
-        <p:txBody>
-          <a:bodyPr wrap="square">
-            <a:spAutoFit/>
-          </a:bodyPr>
-          <a:lstStyle/>
-          <a:p>
-            <a:pPr algn="ctr">
-              <a:spcAft>
-                <a:spcPts val="400"/>
-              </a:spcAft>
-            </a:pPr>
-            <a:r>
-              <a:rPr sz="4000" b="1">
-                <a:solidFill>
-                  <a:srgbClr val="1F4E79"/>
-                </a:solidFill>
-                <a:latin typeface="Arial"/>
-              </a:rPr>
-              <a:t>Backup</a:t>
-            </a:r>
-          </a:p>
-        </p:txBody>
-      </p:sp>
-    </p:spTree>
-  </p:cSld>
-  <p:clrMapOvr>
-    <a:masterClrMapping/>
-  </p:clrMapOvr>
-</p:sld>
-</file>
-
-<file path=ppt/slides/slide22.xml><?xml version="1.0" encoding="utf-8"?>
-<p:sld xmlns:a="http://schemas.openxmlformats.org/drawingml/2006/main" xmlns:p="http://schemas.openxmlformats.org/presentationml/2006/main" xmlns:r="http://schemas.openxmlformats.org/officeDocument/2006/relationships">
-  <p:cSld>
-    <p:spTree>
-      <p:nvGrpSpPr>
-        <p:cNvPr id="1" name=""/>
-        <p:cNvGrpSpPr/>
-        <p:nvPr/>
-      </p:nvGrpSpPr>
-      <p:grpSpPr/>
-      <p:sp>
-        <p:nvSpPr>
-          <p:cNvPr id="2" name="TextBox 1"/>
-          <p:cNvSpPr txBox="1"/>
-          <p:nvPr/>
-        </p:nvSpPr>
-        <p:spPr>
-          <a:xfrm>
             <a:off x="411480" y="201168"/>
             <a:ext cx="11368735" cy="914400"/>
           </a:xfrm>
@@ -10230,7 +10819,7 @@
                 </a:solidFill>
                 <a:latin typeface="Arial"/>
               </a:rPr>
-              <a:t>Before the correction: the first poke and color results</a:t>
+              <a:t>Conclusions: what to import next, in order</a:t>
             </a:r>
           </a:p>
           <a:p>
@@ -10246,7 +10835,7 @@
                 </a:solidFill>
                 <a:latin typeface="Arial"/>
               </a:rPr>
-              <a:t>Kept for the record; every number on this slide is from the out-of-focus model</a:t>
+              <a:t>The JPL budget form, DM calibration through the sensor's own images, the vector sensor priced before it is built, and the interferometer's lever</a:t>
             </a:r>
           </a:p>
         </p:txBody>
@@ -10295,6 +10884,322 @@
           </a:p>
         </p:txBody>
       </p:sp>
+      <p:sp>
+        <p:nvSpPr>
+          <p:cNvPr id="4" name="TextBox 3"/>
+          <p:cNvSpPr txBox="1"/>
+          <p:nvPr/>
+        </p:nvSpPr>
+        <p:spPr>
+          <a:xfrm>
+            <a:off x="411480" y="1298448"/>
+            <a:ext cx="11368735" cy="274320"/>
+          </a:xfrm>
+          <a:prstGeom prst="rect">
+            <a:avLst/>
+          </a:prstGeom>
+          <a:noFill/>
+        </p:spPr>
+        <p:txBody>
+          <a:bodyPr wrap="square">
+            <a:spAutoFit/>
+          </a:bodyPr>
+          <a:lstStyle/>
+          <a:p>
+            <a:pPr>
+              <a:spcAft>
+                <a:spcPts val="600"/>
+              </a:spcAft>
+            </a:pPr>
+            <a:r>
+              <a:rPr sz="1500" b="0">
+                <a:solidFill>
+                  <a:srgbClr val="282828"/>
+                </a:solidFill>
+                <a:latin typeface="Arial"/>
+              </a:rPr>
+              <a:t>•  The JPL budget form: a sensitivity factor per pixel from the measured fields — the quantity the working-surface effect on slide 10 is made of — predicts the photon-noise stage analytically, and four systematic terms (pupil calibration at ½, reference wave at 1, dimple depth, initial phase) become the rows of the error budget.</a:t>
+            </a:r>
+          </a:p>
+          <a:p>
+            <a:pPr>
+              <a:spcAft>
+                <a:spcPts val="600"/>
+              </a:spcAft>
+            </a:pPr>
+            <a:r>
+              <a:rPr sz="1500" b="0">
+                <a:solidFill>
+                  <a:srgbClr val="282828"/>
+                </a:solidFill>
+                <a:latin typeface="Arial"/>
+              </a:rPr>
+              <a:t>•  The response matrix for the interferometer too: its calibration still uses a single-site response pattern, with the stencil bias fixed here (slide 9); the sparse-grid measured matrix is the calibration its reflective build should carry.  Model-matched DM calibration (actuator positions and gains through the sensor's own images) remains the lever for a real DM's geometry.</a:t>
+            </a:r>
+          </a:p>
+          <a:p>
+            <a:pPr>
+              <a:spcAft>
+                <a:spcPts val="600"/>
+              </a:spcAft>
+            </a:pPr>
+            <a:r>
+              <a:rPr sz="1500" b="0">
+                <a:solidFill>
+                  <a:srgbClr val="282828"/>
+                </a:solidFill>
+                <a:latin typeface="Arial"/>
+              </a:rPr>
+              <a:t>•  Color as a joint fit, not a combination: an equal-weight combination inherits a bad channel; a joint fit through the exact reading would use 700 to 780 nm for range and 632.8 nm for the calibration of record.</a:t>
+            </a:r>
+          </a:p>
+          <a:p>
+            <a:pPr>
+              <a:spcAft>
+                <a:spcPts val="600"/>
+              </a:spcAft>
+            </a:pPr>
+            <a:r>
+              <a:rPr sz="1500" b="0">
+                <a:solidFill>
+                  <a:srgbClr val="282828"/>
+                </a:solidFill>
+                <a:latin typeface="Arial"/>
+              </a:rPr>
+              <a:t>•  Model the vector sensor before the metasurface is built: the exact two-image solution and its leakage terms (retardance offsets, splitter rotation) run on the engine's polarization machinery; the bench limits at Keck and SEAL were defocus and crosstalk between the two pupil images, both priceable here.</a:t>
+            </a:r>
+          </a:p>
+          <a:p>
+            <a:pPr>
+              <a:spcAft>
+                <a:spcPts val="600"/>
+              </a:spcAft>
+            </a:pPr>
+            <a:r>
+              <a:rPr sz="1500" b="0">
+                <a:solidFill>
+                  <a:srgbClr val="282828"/>
+                </a:solidFill>
+                <a:latin typeface="Arial"/>
+              </a:rPr>
+              <a:t>•  The interferometer, for balance: a PZT phase shift buys no model gain — its floors are geometric and color-independent — but on hardware an absolute phase scale and freedom from polarization systematics; the recommended form is a hybrid: polarization snapshot for the change measurements, a PZT on the reference flat as calibrator.  Its all-mirror (OAP) version is in build.</a:t>
+            </a:r>
+          </a:p>
+        </p:txBody>
+      </p:sp>
+      <p:sp>
+        <p:nvSpPr>
+          <p:cNvPr id="5" name="TextBox 4"/>
+          <p:cNvSpPr txBox="1"/>
+          <p:nvPr/>
+        </p:nvSpPr>
+        <p:spPr>
+          <a:xfrm>
+            <a:off x="411480" y="5998464"/>
+            <a:ext cx="11368735" cy="274320"/>
+          </a:xfrm>
+          <a:prstGeom prst="rect">
+            <a:avLst/>
+          </a:prstGeom>
+          <a:noFill/>
+        </p:spPr>
+        <p:txBody>
+          <a:bodyPr wrap="square">
+            <a:spAutoFit/>
+          </a:bodyPr>
+          <a:lstStyle/>
+          <a:p>
+            <a:pPr>
+              <a:spcAft>
+                <a:spcPts val="600"/>
+              </a:spcAft>
+            </a:pPr>
+            <a:r>
+              <a:rPr sz="1050" b="0">
+                <a:solidFill>
+                  <a:srgbClr val="6E6E6E"/>
+                </a:solidFill>
+                <a:latin typeface="Arial"/>
+              </a:rPr>
+              <a:t>Segmented-mirror lessons carried forward: the sensor reads segment piston but not global piston, DM quantization appears as steps in the response, and piston is underestimated below 50 % Strehl (Keck) — all three enter the e5-class segmented gauges.</a:t>
+            </a:r>
+          </a:p>
+        </p:txBody>
+      </p:sp>
+    </p:spTree>
+  </p:cSld>
+  <p:clrMapOvr>
+    <a:masterClrMapping/>
+  </p:clrMapOvr>
+</p:sld>
+</file>
+
+<file path=ppt/slides/slide22.xml><?xml version="1.0" encoding="utf-8"?>
+<p:sld xmlns:a="http://schemas.openxmlformats.org/drawingml/2006/main" xmlns:p="http://schemas.openxmlformats.org/presentationml/2006/main" xmlns:r="http://schemas.openxmlformats.org/officeDocument/2006/relationships">
+  <p:cSld>
+    <p:spTree>
+      <p:nvGrpSpPr>
+        <p:cNvPr id="1" name=""/>
+        <p:cNvGrpSpPr/>
+        <p:nvPr/>
+      </p:nvGrpSpPr>
+      <p:grpSpPr/>
+      <p:sp>
+        <p:nvSpPr>
+          <p:cNvPr id="2" name="TextBox 1"/>
+          <p:cNvSpPr txBox="1"/>
+          <p:nvPr/>
+        </p:nvSpPr>
+        <p:spPr>
+          <a:xfrm>
+            <a:off x="822960" y="2743200"/>
+            <a:ext cx="10545775" cy="1280160"/>
+          </a:xfrm>
+          <a:prstGeom prst="rect">
+            <a:avLst/>
+          </a:prstGeom>
+          <a:noFill/>
+        </p:spPr>
+        <p:txBody>
+          <a:bodyPr wrap="square">
+            <a:spAutoFit/>
+          </a:bodyPr>
+          <a:lstStyle/>
+          <a:p>
+            <a:pPr algn="ctr">
+              <a:spcAft>
+                <a:spcPts val="400"/>
+              </a:spcAft>
+            </a:pPr>
+            <a:r>
+              <a:rPr sz="4000" b="1">
+                <a:solidFill>
+                  <a:srgbClr val="1F4E79"/>
+                </a:solidFill>
+                <a:latin typeface="Arial"/>
+              </a:rPr>
+              <a:t>Backup</a:t>
+            </a:r>
+          </a:p>
+        </p:txBody>
+      </p:sp>
+    </p:spTree>
+  </p:cSld>
+  <p:clrMapOvr>
+    <a:masterClrMapping/>
+  </p:clrMapOvr>
+</p:sld>
+</file>
+
+<file path=ppt/slides/slide23.xml><?xml version="1.0" encoding="utf-8"?>
+<p:sld xmlns:a="http://schemas.openxmlformats.org/drawingml/2006/main" xmlns:p="http://schemas.openxmlformats.org/presentationml/2006/main" xmlns:r="http://schemas.openxmlformats.org/officeDocument/2006/relationships">
+  <p:cSld>
+    <p:spTree>
+      <p:nvGrpSpPr>
+        <p:cNvPr id="1" name=""/>
+        <p:cNvGrpSpPr/>
+        <p:nvPr/>
+      </p:nvGrpSpPr>
+      <p:grpSpPr/>
+      <p:sp>
+        <p:nvSpPr>
+          <p:cNvPr id="2" name="TextBox 1"/>
+          <p:cNvSpPr txBox="1"/>
+          <p:nvPr/>
+        </p:nvSpPr>
+        <p:spPr>
+          <a:xfrm>
+            <a:off x="411480" y="201168"/>
+            <a:ext cx="11368735" cy="914400"/>
+          </a:xfrm>
+          <a:prstGeom prst="rect">
+            <a:avLst/>
+          </a:prstGeom>
+          <a:noFill/>
+        </p:spPr>
+        <p:txBody>
+          <a:bodyPr wrap="square">
+            <a:spAutoFit/>
+          </a:bodyPr>
+          <a:lstStyle/>
+          <a:p>
+            <a:pPr>
+              <a:spcAft>
+                <a:spcPts val="400"/>
+              </a:spcAft>
+            </a:pPr>
+            <a:r>
+              <a:rPr sz="2400" b="1">
+                <a:solidFill>
+                  <a:srgbClr val="1F4E79"/>
+                </a:solidFill>
+                <a:latin typeface="Arial"/>
+              </a:rPr>
+              <a:t>Before the correction: the first poke and color results</a:t>
+            </a:r>
+          </a:p>
+          <a:p>
+            <a:pPr>
+              <a:spcAft>
+                <a:spcPts val="0"/>
+              </a:spcAft>
+            </a:pPr>
+            <a:r>
+              <a:rPr sz="1250" b="0">
+                <a:solidFill>
+                  <a:srgbClr val="6E6E6E"/>
+                </a:solidFill>
+                <a:latin typeface="Arial"/>
+              </a:rPr>
+              <a:t>Kept for the record; every number on this slide is from the out-of-focus model</a:t>
+            </a:r>
+          </a:p>
+        </p:txBody>
+      </p:sp>
+      <p:sp>
+        <p:nvSpPr>
+          <p:cNvPr id="3" name="Rectangle 2"/>
+          <p:cNvSpPr/>
+          <p:nvPr/>
+        </p:nvSpPr>
+        <p:spPr>
+          <a:xfrm>
+            <a:off x="411480" y="1133856"/>
+            <a:ext cx="11368735" cy="20320"/>
+          </a:xfrm>
+          <a:prstGeom prst="rect">
+            <a:avLst/>
+          </a:prstGeom>
+          <a:solidFill>
+            <a:srgbClr val="B8C6D4"/>
+          </a:solidFill>
+          <a:ln>
+            <a:noFill/>
+          </a:ln>
+          <a:effectLst/>
+        </p:spPr>
+        <p:style>
+          <a:lnRef idx="1">
+            <a:schemeClr val="accent1"/>
+          </a:lnRef>
+          <a:fillRef idx="3">
+            <a:schemeClr val="accent1"/>
+          </a:fillRef>
+          <a:effectRef idx="2">
+            <a:schemeClr val="accent1"/>
+          </a:effectRef>
+          <a:fontRef idx="minor">
+            <a:schemeClr val="lt1"/>
+          </a:fontRef>
+        </p:style>
+        <p:txBody>
+          <a:bodyPr rtlCol="0" anchor="ctr"/>
+          <a:lstStyle/>
+          <a:p>
+            <a:pPr algn="ctr"/>
+          </a:p>
+        </p:txBody>
+      </p:sp>
       <p:pic>
         <p:nvPicPr>
           <p:cNvPr id="4" name="Picture 3" descr="zwfs_poke_triptych.png"/>
@@ -10523,7 +11428,7 @@
 </p:sld>
 </file>
 
-<file path=ppt/slides/slide23.xml><?xml version="1.0" encoding="utf-8"?>
+<file path=ppt/slides/slide24.xml><?xml version="1.0" encoding="utf-8"?>
 <p:sld xmlns:a="http://schemas.openxmlformats.org/drawingml/2006/main" xmlns:p="http://schemas.openxmlformats.org/presentationml/2006/main" xmlns:r="http://schemas.openxmlformats.org/officeDocument/2006/relationships">
   <p:cSld>
     <p:spTree>

</xml_diff>